<commit_message>
I added EDA analysis, hypothesis testing and started the presentation slides
</commit_message>
<xml_diff>
--- a/RNCP_presentation_sept26.pptx
+++ b/RNCP_presentation_sept26.pptx
@@ -6,8 +6,22 @@
   </p:sldMasterIdLst>
   <p:sldIdLst>
     <p:sldId id="256" r:id="rId2"/>
-    <p:sldId id="257" r:id="rId3"/>
-    <p:sldId id="258" r:id="rId4"/>
+    <p:sldId id="259" r:id="rId3"/>
+    <p:sldId id="260" r:id="rId4"/>
+    <p:sldId id="261" r:id="rId5"/>
+    <p:sldId id="257" r:id="rId6"/>
+    <p:sldId id="258" r:id="rId7"/>
+    <p:sldId id="262" r:id="rId8"/>
+    <p:sldId id="263" r:id="rId9"/>
+    <p:sldId id="264" r:id="rId10"/>
+    <p:sldId id="267" r:id="rId11"/>
+    <p:sldId id="265" r:id="rId12"/>
+    <p:sldId id="272" r:id="rId13"/>
+    <p:sldId id="266" r:id="rId14"/>
+    <p:sldId id="268" r:id="rId15"/>
+    <p:sldId id="270" r:id="rId16"/>
+    <p:sldId id="269" r:id="rId17"/>
+    <p:sldId id="271" r:id="rId18"/>
   </p:sldIdLst>
   <p:sldSz cx="12192000" cy="6858000"/>
   <p:notesSz cx="6858000" cy="9144000"/>
@@ -6011,8 +6025,8 @@
         </p:nvSpPr>
         <p:spPr>
           <a:xfrm>
-            <a:off x="647701" y="4763803"/>
-            <a:ext cx="6837650" cy="1464378"/>
+            <a:off x="647700" y="4763803"/>
+            <a:ext cx="7051963" cy="1464378"/>
           </a:xfrm>
         </p:spPr>
         <p:txBody>
@@ -6021,7 +6035,10 @@
           </a:bodyPr>
           <a:lstStyle/>
           <a:p>
-            <a:endParaRPr lang="en-US"/>
+            <a:r>
+              <a:rPr lang="en-US" dirty="0"/>
+              <a:t>Are there significant territorial inequalities in mobile network performance in France, and what can explain these disparities?</a:t>
+            </a:r>
           </a:p>
         </p:txBody>
       </p:sp>
@@ -6221,6 +6238,1693 @@
 </p:sld>
 </file>
 
+<file path=ppt/slides/slide10.xml><?xml version="1.0" encoding="utf-8"?>
+<p:sld xmlns:a="http://schemas.openxmlformats.org/drawingml/2006/main" xmlns:r="http://schemas.openxmlformats.org/officeDocument/2006/relationships" xmlns:p="http://schemas.openxmlformats.org/presentationml/2006/main">
+  <p:cSld>
+    <p:spTree>
+      <p:nvGrpSpPr>
+        <p:cNvPr id="1" name=""/>
+        <p:cNvGrpSpPr/>
+        <p:nvPr/>
+      </p:nvGrpSpPr>
+      <p:grpSpPr>
+        <a:xfrm>
+          <a:off x="0" y="0"/>
+          <a:ext cx="0" cy="0"/>
+          <a:chOff x="0" y="0"/>
+          <a:chExt cx="0" cy="0"/>
+        </a:xfrm>
+      </p:grpSpPr>
+      <p:sp>
+        <p:nvSpPr>
+          <p:cNvPr id="2" name="Title 1">
+            <a:extLst>
+              <a:ext uri="{FF2B5EF4-FFF2-40B4-BE49-F238E27FC236}">
+                <a16:creationId xmlns:a16="http://schemas.microsoft.com/office/drawing/2014/main" id="{F74FA3CA-ACB3-E65A-A0F1-43FB4A63D80E}"/>
+              </a:ext>
+            </a:extLst>
+          </p:cNvPr>
+          <p:cNvSpPr>
+            <a:spLocks noGrp="1"/>
+          </p:cNvSpPr>
+          <p:nvPr>
+            <p:ph type="title"/>
+          </p:nvPr>
+        </p:nvSpPr>
+        <p:spPr/>
+        <p:txBody>
+          <a:bodyPr/>
+          <a:lstStyle/>
+          <a:p>
+            <a:r>
+              <a:rPr lang="en-US" sz="2400" dirty="0"/>
+              <a:t>Does the level of genuine 5G infrastructure explain the differences in measured 5G download performance between regions and operators?</a:t>
+            </a:r>
+          </a:p>
+        </p:txBody>
+      </p:sp>
+      <p:pic>
+        <p:nvPicPr>
+          <p:cNvPr id="5" name="Content Placeholder 4">
+            <a:extLst>
+              <a:ext uri="{FF2B5EF4-FFF2-40B4-BE49-F238E27FC236}">
+                <a16:creationId xmlns:a16="http://schemas.microsoft.com/office/drawing/2014/main" id="{C41F5F4D-125D-83EE-B2F5-3525D9AAB358}"/>
+              </a:ext>
+            </a:extLst>
+          </p:cNvPr>
+          <p:cNvPicPr>
+            <a:picLocks noGrp="1" noChangeAspect="1"/>
+          </p:cNvPicPr>
+          <p:nvPr>
+            <p:ph idx="1"/>
+          </p:nvPr>
+        </p:nvPicPr>
+        <p:blipFill>
+          <a:blip r:embed="rId2"/>
+          <a:stretch>
+            <a:fillRect/>
+          </a:stretch>
+        </p:blipFill>
+        <p:spPr>
+          <a:xfrm>
+            <a:off x="6096000" y="1282261"/>
+            <a:ext cx="5307724" cy="5223641"/>
+          </a:xfrm>
+          <a:prstGeom prst="rect">
+            <a:avLst/>
+          </a:prstGeom>
+        </p:spPr>
+      </p:pic>
+    </p:spTree>
+    <p:extLst>
+      <p:ext uri="{BB962C8B-B14F-4D97-AF65-F5344CB8AC3E}">
+        <p14:creationId xmlns:p14="http://schemas.microsoft.com/office/powerpoint/2010/main" val="585021824"/>
+      </p:ext>
+    </p:extLst>
+  </p:cSld>
+  <p:clrMapOvr>
+    <a:masterClrMapping/>
+  </p:clrMapOvr>
+</p:sld>
+</file>
+
+<file path=ppt/slides/slide11.xml><?xml version="1.0" encoding="utf-8"?>
+<p:sld xmlns:a="http://schemas.openxmlformats.org/drawingml/2006/main" xmlns:r="http://schemas.openxmlformats.org/officeDocument/2006/relationships" xmlns:p="http://schemas.openxmlformats.org/presentationml/2006/main">
+  <p:cSld>
+    <p:spTree>
+      <p:nvGrpSpPr>
+        <p:cNvPr id="1" name=""/>
+        <p:cNvGrpSpPr/>
+        <p:nvPr/>
+      </p:nvGrpSpPr>
+      <p:grpSpPr>
+        <a:xfrm>
+          <a:off x="0" y="0"/>
+          <a:ext cx="0" cy="0"/>
+          <a:chOff x="0" y="0"/>
+          <a:chExt cx="0" cy="0"/>
+        </a:xfrm>
+      </p:grpSpPr>
+      <p:sp>
+        <p:nvSpPr>
+          <p:cNvPr id="2" name="Title 1">
+            <a:extLst>
+              <a:ext uri="{FF2B5EF4-FFF2-40B4-BE49-F238E27FC236}">
+                <a16:creationId xmlns:a16="http://schemas.microsoft.com/office/drawing/2014/main" id="{E4EC204C-AF1E-154F-D137-B20C235339AC}"/>
+              </a:ext>
+            </a:extLst>
+          </p:cNvPr>
+          <p:cNvSpPr>
+            <a:spLocks noGrp="1"/>
+          </p:cNvSpPr>
+          <p:nvPr>
+            <p:ph type="title"/>
+          </p:nvPr>
+        </p:nvSpPr>
+        <p:spPr>
+          <a:xfrm>
+            <a:off x="469465" y="164997"/>
+            <a:ext cx="9404723" cy="1400530"/>
+          </a:xfrm>
+        </p:spPr>
+        <p:txBody>
+          <a:bodyPr/>
+          <a:lstStyle/>
+          <a:p>
+            <a:r>
+              <a:rPr lang="en-US" sz="2400" b="1" dirty="0"/>
+              <a:t>Question:</a:t>
+            </a:r>
+            <a:br>
+              <a:rPr lang="en-US" sz="2400" b="1" dirty="0"/>
+            </a:br>
+            <a:r>
+              <a:rPr lang="en-US" sz="2400" b="1" dirty="0"/>
+              <a:t>Do regions with larger populations tend to have different 5G performance?</a:t>
+            </a:r>
+          </a:p>
+        </p:txBody>
+      </p:sp>
+      <p:sp>
+        <p:nvSpPr>
+          <p:cNvPr id="3" name="Content Placeholder 2">
+            <a:extLst>
+              <a:ext uri="{FF2B5EF4-FFF2-40B4-BE49-F238E27FC236}">
+                <a16:creationId xmlns:a16="http://schemas.microsoft.com/office/drawing/2014/main" id="{93FC8BCB-1FA8-DFA4-4C98-1E16048BFDB2}"/>
+              </a:ext>
+            </a:extLst>
+          </p:cNvPr>
+          <p:cNvSpPr>
+            <a:spLocks noGrp="1"/>
+          </p:cNvSpPr>
+          <p:nvPr>
+            <p:ph idx="1"/>
+          </p:nvPr>
+        </p:nvSpPr>
+        <p:spPr>
+          <a:xfrm>
+            <a:off x="199423" y="1797257"/>
+            <a:ext cx="6201377" cy="4195481"/>
+          </a:xfrm>
+        </p:spPr>
+        <p:txBody>
+          <a:bodyPr/>
+          <a:lstStyle/>
+          <a:p>
+            <a:pPr lvl="0"/>
+            <a:r>
+              <a:rPr lang="en-US" b="1" dirty="0"/>
+              <a:t>Overall:</a:t>
+            </a:r>
+            <a:r>
+              <a:rPr lang="en-US" dirty="0"/>
+              <a:t> a </a:t>
+            </a:r>
+            <a:r>
+              <a:rPr lang="en-US" b="1" dirty="0"/>
+              <a:t>positive trend</a:t>
+            </a:r>
+            <a:r>
+              <a:rPr lang="en-US" dirty="0"/>
+              <a:t> between regional population and average 5G download speed. </a:t>
+            </a:r>
+          </a:p>
+          <a:p>
+            <a:pPr lvl="0"/>
+            <a:r>
+              <a:rPr lang="en-US" b="1" dirty="0"/>
+              <a:t>For each operator:</a:t>
+            </a:r>
+            <a:r>
+              <a:rPr lang="en-US" dirty="0"/>
+              <a:t> the trend is also </a:t>
+            </a:r>
+            <a:r>
+              <a:rPr lang="en-US" b="1" dirty="0"/>
+              <a:t>positive</a:t>
+            </a:r>
+            <a:r>
+              <a:rPr lang="en-US" dirty="0"/>
+              <a:t>.</a:t>
+            </a:r>
+          </a:p>
+          <a:p>
+            <a:endParaRPr lang="en-US" dirty="0"/>
+          </a:p>
+          <a:p>
+            <a:pPr>
+              <a:buFont typeface="Wingdings" panose="05000000000000000000" pitchFamily="2" charset="2"/>
+              <a:buChar char="q"/>
+            </a:pPr>
+            <a:r>
+              <a:rPr lang="en-US" dirty="0"/>
+              <a:t>Regional population is positively associated with 5G download performance. This positive relationship is observed both across all operators and within each individual operator. More populated regions tend to exhibit higher average 5G download speeds.</a:t>
+            </a:r>
+          </a:p>
+        </p:txBody>
+      </p:sp>
+      <p:pic>
+        <p:nvPicPr>
+          <p:cNvPr id="7" name="Picture 6">
+            <a:extLst>
+              <a:ext uri="{FF2B5EF4-FFF2-40B4-BE49-F238E27FC236}">
+                <a16:creationId xmlns:a16="http://schemas.microsoft.com/office/drawing/2014/main" id="{CB6EFA63-663C-FE0E-85A1-5F0E4F4F6E99}"/>
+              </a:ext>
+            </a:extLst>
+          </p:cNvPr>
+          <p:cNvPicPr>
+            <a:picLocks noChangeAspect="1"/>
+          </p:cNvPicPr>
+          <p:nvPr/>
+        </p:nvPicPr>
+        <p:blipFill>
+          <a:blip r:embed="rId2"/>
+          <a:stretch>
+            <a:fillRect/>
+          </a:stretch>
+        </p:blipFill>
+        <p:spPr>
+          <a:xfrm>
+            <a:off x="7890805" y="1152983"/>
+            <a:ext cx="3197883" cy="2742015"/>
+          </a:xfrm>
+          <a:prstGeom prst="rect">
+            <a:avLst/>
+          </a:prstGeom>
+        </p:spPr>
+      </p:pic>
+      <p:pic>
+        <p:nvPicPr>
+          <p:cNvPr id="9" name="Picture 8">
+            <a:extLst>
+              <a:ext uri="{FF2B5EF4-FFF2-40B4-BE49-F238E27FC236}">
+                <a16:creationId xmlns:a16="http://schemas.microsoft.com/office/drawing/2014/main" id="{4B2E735E-CCAD-8FB9-1B05-D63E1423E222}"/>
+              </a:ext>
+            </a:extLst>
+          </p:cNvPr>
+          <p:cNvPicPr>
+            <a:picLocks noChangeAspect="1"/>
+          </p:cNvPicPr>
+          <p:nvPr/>
+        </p:nvPicPr>
+        <p:blipFill>
+          <a:blip r:embed="rId3"/>
+          <a:stretch>
+            <a:fillRect/>
+          </a:stretch>
+        </p:blipFill>
+        <p:spPr>
+          <a:xfrm>
+            <a:off x="7914618" y="3993461"/>
+            <a:ext cx="3150255" cy="2769231"/>
+          </a:xfrm>
+          <a:prstGeom prst="rect">
+            <a:avLst/>
+          </a:prstGeom>
+        </p:spPr>
+      </p:pic>
+    </p:spTree>
+    <p:extLst>
+      <p:ext uri="{BB962C8B-B14F-4D97-AF65-F5344CB8AC3E}">
+        <p14:creationId xmlns:p14="http://schemas.microsoft.com/office/powerpoint/2010/main" val="2302817719"/>
+      </p:ext>
+    </p:extLst>
+  </p:cSld>
+  <p:clrMapOvr>
+    <a:masterClrMapping/>
+  </p:clrMapOvr>
+</p:sld>
+</file>
+
+<file path=ppt/slides/slide12.xml><?xml version="1.0" encoding="utf-8"?>
+<p:sld xmlns:a="http://schemas.openxmlformats.org/drawingml/2006/main" xmlns:r="http://schemas.openxmlformats.org/officeDocument/2006/relationships" xmlns:p="http://schemas.openxmlformats.org/presentationml/2006/main">
+  <p:cSld>
+    <p:spTree>
+      <p:nvGrpSpPr>
+        <p:cNvPr id="1" name=""/>
+        <p:cNvGrpSpPr/>
+        <p:nvPr/>
+      </p:nvGrpSpPr>
+      <p:grpSpPr>
+        <a:xfrm>
+          <a:off x="0" y="0"/>
+          <a:ext cx="0" cy="0"/>
+          <a:chOff x="0" y="0"/>
+          <a:chExt cx="0" cy="0"/>
+        </a:xfrm>
+      </p:grpSpPr>
+      <p:sp>
+        <p:nvSpPr>
+          <p:cNvPr id="2" name="Title 1">
+            <a:extLst>
+              <a:ext uri="{FF2B5EF4-FFF2-40B4-BE49-F238E27FC236}">
+                <a16:creationId xmlns:a16="http://schemas.microsoft.com/office/drawing/2014/main" id="{6A733531-CD8E-CD93-73AA-63962A222E7B}"/>
+              </a:ext>
+            </a:extLst>
+          </p:cNvPr>
+          <p:cNvSpPr>
+            <a:spLocks noGrp="1"/>
+          </p:cNvSpPr>
+          <p:nvPr>
+            <p:ph type="title"/>
+          </p:nvPr>
+        </p:nvSpPr>
+        <p:spPr/>
+        <p:txBody>
+          <a:bodyPr/>
+          <a:lstStyle/>
+          <a:p>
+            <a:r>
+              <a:rPr lang="en-US" dirty="0"/>
+              <a:t>Hypothesis 2 — Population vs. 5G download speed</a:t>
+            </a:r>
+          </a:p>
+        </p:txBody>
+      </p:sp>
+      <p:sp>
+        <p:nvSpPr>
+          <p:cNvPr id="3" name="Content Placeholder 2">
+            <a:extLst>
+              <a:ext uri="{FF2B5EF4-FFF2-40B4-BE49-F238E27FC236}">
+                <a16:creationId xmlns:a16="http://schemas.microsoft.com/office/drawing/2014/main" id="{7489E646-05CA-F0E0-1A71-DADEC9559DA7}"/>
+              </a:ext>
+            </a:extLst>
+          </p:cNvPr>
+          <p:cNvSpPr>
+            <a:spLocks noGrp="1"/>
+          </p:cNvSpPr>
+          <p:nvPr>
+            <p:ph idx="1"/>
+          </p:nvPr>
+        </p:nvSpPr>
+        <p:spPr/>
+        <p:txBody>
+          <a:bodyPr>
+            <a:normAutofit lnSpcReduction="10000"/>
+          </a:bodyPr>
+          <a:lstStyle/>
+          <a:p>
+            <a:r>
+              <a:rPr lang="fr-FR" dirty="0" err="1"/>
+              <a:t>Calculate</a:t>
+            </a:r>
+            <a:r>
+              <a:rPr lang="fr-FR" dirty="0"/>
+              <a:t> the </a:t>
+            </a:r>
+            <a:r>
+              <a:rPr lang="fr-FR" dirty="0" err="1"/>
+              <a:t>spearman</a:t>
+            </a:r>
+            <a:r>
+              <a:rPr lang="fr-FR" dirty="0"/>
+              <a:t> association: </a:t>
+            </a:r>
+            <a:r>
+              <a:rPr lang="en-US" dirty="0"/>
+              <a:t>We'll use a </a:t>
+            </a:r>
+            <a:r>
+              <a:rPr lang="en-US" b="1" dirty="0"/>
+              <a:t>Spearman correlation</a:t>
+            </a:r>
+            <a:r>
+              <a:rPr lang="en-US" dirty="0"/>
+              <a:t>, because we're testing whether population and download speed are associated, without assuming a perfectly linear relationship</a:t>
+            </a:r>
+          </a:p>
+          <a:p>
+            <a:pPr lvl="1"/>
+            <a:r>
+              <a:rPr lang="en-US" b="1" dirty="0"/>
+              <a:t>H₀:</a:t>
+            </a:r>
+            <a:r>
+              <a:rPr lang="en-US" dirty="0"/>
+              <a:t> There is no significant association between regional population and average 5G download speed.</a:t>
+            </a:r>
+            <a:br>
+              <a:rPr lang="en-US" dirty="0"/>
+            </a:br>
+            <a:r>
+              <a:rPr lang="en-US" b="1" dirty="0"/>
+              <a:t>H₁:</a:t>
+            </a:r>
+            <a:r>
+              <a:rPr lang="en-US" dirty="0"/>
+              <a:t> There is a significant association between regional population and average 5G download speed.</a:t>
+            </a:r>
+          </a:p>
+          <a:p>
+            <a:pPr lvl="1"/>
+            <a:endParaRPr lang="en-US" dirty="0"/>
+          </a:p>
+          <a:p>
+            <a:pPr lvl="1"/>
+            <a:r>
+              <a:rPr lang="en-US" dirty="0"/>
+              <a:t>The Spearman correlation indicates a statistically significant positive association between regional population and average 5G download speed (ρ = 0.369, p = 0.007). More populated regions tend to have higher average 5G download speeds. </a:t>
+            </a:r>
+            <a:r>
+              <a:rPr lang="en-US"/>
+              <a:t>However, this result indicates an association and does not establish a causal relationship.</a:t>
+            </a:r>
+            <a:endParaRPr lang="en-US" dirty="0"/>
+          </a:p>
+        </p:txBody>
+      </p:sp>
+    </p:spTree>
+    <p:extLst>
+      <p:ext uri="{BB962C8B-B14F-4D97-AF65-F5344CB8AC3E}">
+        <p14:creationId xmlns:p14="http://schemas.microsoft.com/office/powerpoint/2010/main" val="3455783513"/>
+      </p:ext>
+    </p:extLst>
+  </p:cSld>
+  <p:clrMapOvr>
+    <a:masterClrMapping/>
+  </p:clrMapOvr>
+</p:sld>
+</file>
+
+<file path=ppt/slides/slide13.xml><?xml version="1.0" encoding="utf-8"?>
+<p:sld xmlns:a="http://schemas.openxmlformats.org/drawingml/2006/main" xmlns:r="http://schemas.openxmlformats.org/officeDocument/2006/relationships" xmlns:p="http://schemas.openxmlformats.org/presentationml/2006/main">
+  <p:cSld>
+    <p:spTree>
+      <p:nvGrpSpPr>
+        <p:cNvPr id="1" name=""/>
+        <p:cNvGrpSpPr/>
+        <p:nvPr/>
+      </p:nvGrpSpPr>
+      <p:grpSpPr>
+        <a:xfrm>
+          <a:off x="0" y="0"/>
+          <a:ext cx="0" cy="0"/>
+          <a:chOff x="0" y="0"/>
+          <a:chExt cx="0" cy="0"/>
+        </a:xfrm>
+      </p:grpSpPr>
+      <p:sp>
+        <p:nvSpPr>
+          <p:cNvPr id="2" name="Title 1">
+            <a:extLst>
+              <a:ext uri="{FF2B5EF4-FFF2-40B4-BE49-F238E27FC236}">
+                <a16:creationId xmlns:a16="http://schemas.microsoft.com/office/drawing/2014/main" id="{482F6E32-27ED-04BE-397F-01F005ECCF3B}"/>
+              </a:ext>
+            </a:extLst>
+          </p:cNvPr>
+          <p:cNvSpPr>
+            <a:spLocks noGrp="1"/>
+          </p:cNvSpPr>
+          <p:nvPr>
+            <p:ph type="title"/>
+          </p:nvPr>
+        </p:nvSpPr>
+        <p:spPr/>
+        <p:txBody>
+          <a:bodyPr/>
+          <a:lstStyle/>
+          <a:p>
+            <a:r>
+              <a:rPr lang="en-US" sz="2800" b="1" dirty="0"/>
+              <a:t>Can differences in 5G radio conditions help explain differences in download performance?</a:t>
+            </a:r>
+          </a:p>
+        </p:txBody>
+      </p:sp>
+      <p:pic>
+        <p:nvPicPr>
+          <p:cNvPr id="5" name="Content Placeholder 4">
+            <a:extLst>
+              <a:ext uri="{FF2B5EF4-FFF2-40B4-BE49-F238E27FC236}">
+                <a16:creationId xmlns:a16="http://schemas.microsoft.com/office/drawing/2014/main" id="{74C66988-C810-063A-1047-B3BDB1FE3750}"/>
+              </a:ext>
+            </a:extLst>
+          </p:cNvPr>
+          <p:cNvPicPr>
+            <a:picLocks noGrp="1" noChangeAspect="1"/>
+          </p:cNvPicPr>
+          <p:nvPr>
+            <p:ph idx="1"/>
+          </p:nvPr>
+        </p:nvPicPr>
+        <p:blipFill>
+          <a:blip r:embed="rId2"/>
+          <a:stretch>
+            <a:fillRect/>
+          </a:stretch>
+        </p:blipFill>
+        <p:spPr>
+          <a:xfrm>
+            <a:off x="4008933" y="2044383"/>
+            <a:ext cx="3245511" cy="2769231"/>
+          </a:xfrm>
+          <a:prstGeom prst="rect">
+            <a:avLst/>
+          </a:prstGeom>
+        </p:spPr>
+      </p:pic>
+      <p:pic>
+        <p:nvPicPr>
+          <p:cNvPr id="7" name="Picture 6">
+            <a:extLst>
+              <a:ext uri="{FF2B5EF4-FFF2-40B4-BE49-F238E27FC236}">
+                <a16:creationId xmlns:a16="http://schemas.microsoft.com/office/drawing/2014/main" id="{75789A53-7C37-15C1-E9BA-EB685679341D}"/>
+              </a:ext>
+            </a:extLst>
+          </p:cNvPr>
+          <p:cNvPicPr>
+            <a:picLocks noChangeAspect="1"/>
+          </p:cNvPicPr>
+          <p:nvPr/>
+        </p:nvPicPr>
+        <p:blipFill>
+          <a:blip r:embed="rId3"/>
+          <a:stretch>
+            <a:fillRect/>
+          </a:stretch>
+        </p:blipFill>
+        <p:spPr>
+          <a:xfrm>
+            <a:off x="9856004" y="1584889"/>
+            <a:ext cx="2031196" cy="1844112"/>
+          </a:xfrm>
+          <a:prstGeom prst="rect">
+            <a:avLst/>
+          </a:prstGeom>
+        </p:spPr>
+      </p:pic>
+      <p:pic>
+        <p:nvPicPr>
+          <p:cNvPr id="9" name="Picture 8">
+            <a:extLst>
+              <a:ext uri="{FF2B5EF4-FFF2-40B4-BE49-F238E27FC236}">
+                <a16:creationId xmlns:a16="http://schemas.microsoft.com/office/drawing/2014/main" id="{D4A74783-9C9B-A87C-9AD5-ECFE296E662D}"/>
+              </a:ext>
+            </a:extLst>
+          </p:cNvPr>
+          <p:cNvPicPr>
+            <a:picLocks noChangeAspect="1"/>
+          </p:cNvPicPr>
+          <p:nvPr/>
+        </p:nvPicPr>
+        <p:blipFill>
+          <a:blip r:embed="rId4"/>
+          <a:stretch>
+            <a:fillRect/>
+          </a:stretch>
+        </p:blipFill>
+        <p:spPr>
+          <a:xfrm>
+            <a:off x="7603940" y="1636347"/>
+            <a:ext cx="2111645" cy="1792652"/>
+          </a:xfrm>
+          <a:prstGeom prst="rect">
+            <a:avLst/>
+          </a:prstGeom>
+        </p:spPr>
+      </p:pic>
+      <p:pic>
+        <p:nvPicPr>
+          <p:cNvPr id="11" name="Picture 10">
+            <a:extLst>
+              <a:ext uri="{FF2B5EF4-FFF2-40B4-BE49-F238E27FC236}">
+                <a16:creationId xmlns:a16="http://schemas.microsoft.com/office/drawing/2014/main" id="{2E8480AA-3875-F131-2EB2-323FA957056D}"/>
+              </a:ext>
+            </a:extLst>
+          </p:cNvPr>
+          <p:cNvPicPr>
+            <a:picLocks noChangeAspect="1"/>
+          </p:cNvPicPr>
+          <p:nvPr/>
+        </p:nvPicPr>
+        <p:blipFill>
+          <a:blip r:embed="rId5"/>
+          <a:stretch>
+            <a:fillRect/>
+          </a:stretch>
+        </p:blipFill>
+        <p:spPr>
+          <a:xfrm>
+            <a:off x="9833327" y="3506269"/>
+            <a:ext cx="2134322" cy="1792653"/>
+          </a:xfrm>
+          <a:prstGeom prst="rect">
+            <a:avLst/>
+          </a:prstGeom>
+        </p:spPr>
+      </p:pic>
+      <p:pic>
+        <p:nvPicPr>
+          <p:cNvPr id="13" name="Picture 12">
+            <a:extLst>
+              <a:ext uri="{FF2B5EF4-FFF2-40B4-BE49-F238E27FC236}">
+                <a16:creationId xmlns:a16="http://schemas.microsoft.com/office/drawing/2014/main" id="{7E7DEC88-6CCC-7224-05DE-DB140C66E867}"/>
+              </a:ext>
+            </a:extLst>
+          </p:cNvPr>
+          <p:cNvPicPr>
+            <a:picLocks noChangeAspect="1"/>
+          </p:cNvPicPr>
+          <p:nvPr/>
+        </p:nvPicPr>
+        <p:blipFill>
+          <a:blip r:embed="rId6"/>
+          <a:stretch>
+            <a:fillRect/>
+          </a:stretch>
+        </p:blipFill>
+        <p:spPr>
+          <a:xfrm>
+            <a:off x="7603940" y="3506270"/>
+            <a:ext cx="2111645" cy="1856241"/>
+          </a:xfrm>
+          <a:prstGeom prst="rect">
+            <a:avLst/>
+          </a:prstGeom>
+        </p:spPr>
+      </p:pic>
+      <p:sp>
+        <p:nvSpPr>
+          <p:cNvPr id="16" name="Content Placeholder 2">
+            <a:extLst>
+              <a:ext uri="{FF2B5EF4-FFF2-40B4-BE49-F238E27FC236}">
+                <a16:creationId xmlns:a16="http://schemas.microsoft.com/office/drawing/2014/main" id="{25F398BF-3ACF-B63D-E5D1-7EDDF95836F0}"/>
+              </a:ext>
+            </a:extLst>
+          </p:cNvPr>
+          <p:cNvSpPr txBox="1">
+            <a:spLocks/>
+          </p:cNvSpPr>
+          <p:nvPr/>
+        </p:nvSpPr>
+        <p:spPr>
+          <a:xfrm>
+            <a:off x="199424" y="1797257"/>
+            <a:ext cx="3460014" cy="4195481"/>
+          </a:xfrm>
+          <a:prstGeom prst="rect">
+            <a:avLst/>
+          </a:prstGeom>
+        </p:spPr>
+        <p:txBody>
+          <a:bodyPr vert="horz" lIns="91440" tIns="45720" rIns="91440" bIns="45720" rtlCol="0">
+            <a:normAutofit fontScale="62500" lnSpcReduction="20000"/>
+          </a:bodyPr>
+          <a:lstStyle>
+            <a:lvl1pPr marL="342900" indent="-342900" algn="l" defTabSz="457200" rtl="0" eaLnBrk="1" latinLnBrk="0" hangingPunct="1">
+              <a:spcBef>
+                <a:spcPts val="1000"/>
+              </a:spcBef>
+              <a:spcAft>
+                <a:spcPts val="0"/>
+              </a:spcAft>
+              <a:buClr>
+                <a:schemeClr val="accent1"/>
+              </a:buClr>
+              <a:buSzPct val="80000"/>
+              <a:buFont typeface="Wingdings 3" charset="2"/>
+              <a:buChar char=""/>
+              <a:defRPr sz="2000" b="0" i="0" kern="1200">
+                <a:solidFill>
+                  <a:schemeClr val="tx1"/>
+                </a:solidFill>
+                <a:latin typeface="+mj-lt"/>
+                <a:ea typeface="+mj-ea"/>
+                <a:cs typeface="+mj-cs"/>
+              </a:defRPr>
+            </a:lvl1pPr>
+            <a:lvl2pPr marL="742950" indent="-285750" algn="l" defTabSz="457200" rtl="0" eaLnBrk="1" latinLnBrk="0" hangingPunct="1">
+              <a:spcBef>
+                <a:spcPts val="1000"/>
+              </a:spcBef>
+              <a:spcAft>
+                <a:spcPts val="0"/>
+              </a:spcAft>
+              <a:buClr>
+                <a:schemeClr val="accent1"/>
+              </a:buClr>
+              <a:buSzPct val="80000"/>
+              <a:buFont typeface="Wingdings 3" charset="2"/>
+              <a:buChar char=""/>
+              <a:defRPr sz="1800" b="0" i="0" kern="1200">
+                <a:solidFill>
+                  <a:schemeClr val="tx1"/>
+                </a:solidFill>
+                <a:latin typeface="+mj-lt"/>
+                <a:ea typeface="+mj-ea"/>
+                <a:cs typeface="+mj-cs"/>
+              </a:defRPr>
+            </a:lvl2pPr>
+            <a:lvl3pPr marL="1143000" indent="-228600" algn="l" defTabSz="457200" rtl="0" eaLnBrk="1" latinLnBrk="0" hangingPunct="1">
+              <a:spcBef>
+                <a:spcPts val="1000"/>
+              </a:spcBef>
+              <a:spcAft>
+                <a:spcPts val="0"/>
+              </a:spcAft>
+              <a:buClr>
+                <a:schemeClr val="accent1"/>
+              </a:buClr>
+              <a:buSzPct val="80000"/>
+              <a:buFont typeface="Wingdings 3" charset="2"/>
+              <a:buChar char=""/>
+              <a:defRPr sz="1600" b="0" i="0" kern="1200">
+                <a:solidFill>
+                  <a:schemeClr val="tx1"/>
+                </a:solidFill>
+                <a:latin typeface="+mj-lt"/>
+                <a:ea typeface="+mj-ea"/>
+                <a:cs typeface="+mj-cs"/>
+              </a:defRPr>
+            </a:lvl3pPr>
+            <a:lvl4pPr marL="1600200" indent="-228600" algn="l" defTabSz="457200" rtl="0" eaLnBrk="1" latinLnBrk="0" hangingPunct="1">
+              <a:spcBef>
+                <a:spcPts val="1000"/>
+              </a:spcBef>
+              <a:spcAft>
+                <a:spcPts val="0"/>
+              </a:spcAft>
+              <a:buClr>
+                <a:schemeClr val="accent1"/>
+              </a:buClr>
+              <a:buSzPct val="80000"/>
+              <a:buFont typeface="Wingdings 3" charset="2"/>
+              <a:buChar char=""/>
+              <a:defRPr sz="1400" b="0" i="0" kern="1200">
+                <a:solidFill>
+                  <a:schemeClr val="tx1"/>
+                </a:solidFill>
+                <a:latin typeface="+mj-lt"/>
+                <a:ea typeface="+mj-ea"/>
+                <a:cs typeface="+mj-cs"/>
+              </a:defRPr>
+            </a:lvl4pPr>
+            <a:lvl5pPr marL="2057400" indent="-228600" algn="l" defTabSz="457200" rtl="0" eaLnBrk="1" latinLnBrk="0" hangingPunct="1">
+              <a:spcBef>
+                <a:spcPts val="1000"/>
+              </a:spcBef>
+              <a:spcAft>
+                <a:spcPts val="0"/>
+              </a:spcAft>
+              <a:buClr>
+                <a:schemeClr val="accent1"/>
+              </a:buClr>
+              <a:buSzPct val="80000"/>
+              <a:buFont typeface="Wingdings 3" charset="2"/>
+              <a:buChar char=""/>
+              <a:defRPr sz="1400" b="0" i="0" kern="1200">
+                <a:solidFill>
+                  <a:schemeClr val="tx1"/>
+                </a:solidFill>
+                <a:latin typeface="+mj-lt"/>
+                <a:ea typeface="+mj-ea"/>
+                <a:cs typeface="+mj-cs"/>
+              </a:defRPr>
+            </a:lvl5pPr>
+            <a:lvl6pPr marL="2514600" indent="-228600" algn="l" defTabSz="457200" rtl="0" eaLnBrk="1" latinLnBrk="0" hangingPunct="1">
+              <a:spcBef>
+                <a:spcPts val="1000"/>
+              </a:spcBef>
+              <a:spcAft>
+                <a:spcPts val="0"/>
+              </a:spcAft>
+              <a:buClr>
+                <a:schemeClr val="accent1"/>
+              </a:buClr>
+              <a:buSzPct val="80000"/>
+              <a:buFont typeface="Wingdings 3" charset="2"/>
+              <a:buChar char=""/>
+              <a:defRPr sz="1400" b="0" i="0" kern="1200">
+                <a:solidFill>
+                  <a:schemeClr val="tx1"/>
+                </a:solidFill>
+                <a:latin typeface="+mj-lt"/>
+                <a:ea typeface="+mj-ea"/>
+                <a:cs typeface="+mj-cs"/>
+              </a:defRPr>
+            </a:lvl6pPr>
+            <a:lvl7pPr marL="2971800" indent="-228600" algn="l" defTabSz="457200" rtl="0" eaLnBrk="1" latinLnBrk="0" hangingPunct="1">
+              <a:spcBef>
+                <a:spcPts val="1000"/>
+              </a:spcBef>
+              <a:spcAft>
+                <a:spcPts val="0"/>
+              </a:spcAft>
+              <a:buClr>
+                <a:schemeClr val="accent1"/>
+              </a:buClr>
+              <a:buSzPct val="80000"/>
+              <a:buFont typeface="Wingdings 3" charset="2"/>
+              <a:buChar char=""/>
+              <a:defRPr sz="1400" b="0" i="0" kern="1200">
+                <a:solidFill>
+                  <a:schemeClr val="tx1"/>
+                </a:solidFill>
+                <a:latin typeface="+mj-lt"/>
+                <a:ea typeface="+mj-ea"/>
+                <a:cs typeface="+mj-cs"/>
+              </a:defRPr>
+            </a:lvl7pPr>
+            <a:lvl8pPr marL="3429000" indent="-228600" algn="l" defTabSz="457200" rtl="0" eaLnBrk="1" latinLnBrk="0" hangingPunct="1">
+              <a:spcBef>
+                <a:spcPts val="1000"/>
+              </a:spcBef>
+              <a:spcAft>
+                <a:spcPts val="0"/>
+              </a:spcAft>
+              <a:buClr>
+                <a:schemeClr val="accent1"/>
+              </a:buClr>
+              <a:buSzPct val="80000"/>
+              <a:buFont typeface="Wingdings 3" charset="2"/>
+              <a:buChar char=""/>
+              <a:defRPr sz="1400" b="0" i="0" kern="1200">
+                <a:solidFill>
+                  <a:schemeClr val="tx1"/>
+                </a:solidFill>
+                <a:latin typeface="+mj-lt"/>
+                <a:ea typeface="+mj-ea"/>
+                <a:cs typeface="+mj-cs"/>
+              </a:defRPr>
+            </a:lvl8pPr>
+            <a:lvl9pPr marL="3886200" indent="-228600" algn="l" defTabSz="457200" rtl="0" eaLnBrk="1" latinLnBrk="0" hangingPunct="1">
+              <a:spcBef>
+                <a:spcPts val="1000"/>
+              </a:spcBef>
+              <a:spcAft>
+                <a:spcPts val="0"/>
+              </a:spcAft>
+              <a:buClr>
+                <a:schemeClr val="accent1"/>
+              </a:buClr>
+              <a:buSzPct val="80000"/>
+              <a:buFont typeface="Wingdings 3" charset="2"/>
+              <a:buChar char=""/>
+              <a:defRPr sz="1400" b="0" i="0" kern="1200">
+                <a:solidFill>
+                  <a:schemeClr val="tx1"/>
+                </a:solidFill>
+                <a:latin typeface="+mj-lt"/>
+                <a:ea typeface="+mj-ea"/>
+                <a:cs typeface="+mj-cs"/>
+              </a:defRPr>
+            </a:lvl9pPr>
+          </a:lstStyle>
+          <a:p>
+            <a:r>
+              <a:rPr lang="en-US" dirty="0"/>
+              <a:t>Higher RSRP levels are associated with higher 5G download speeds. This positive relationship is consistent across all operators, suggesting that signal strength is an important factor in 5G performance.</a:t>
+            </a:r>
+          </a:p>
+          <a:p>
+            <a:r>
+              <a:rPr lang="en-US" b="1" dirty="0"/>
+              <a:t>RSRQ → download speed</a:t>
+            </a:r>
+          </a:p>
+          <a:p>
+            <a:pPr lvl="1">
+              <a:buFont typeface="Wingdings" panose="05000000000000000000" pitchFamily="2" charset="2"/>
+              <a:buChar char="§"/>
+            </a:pPr>
+            <a:r>
+              <a:rPr lang="en-US" b="1" dirty="0"/>
+              <a:t>Overall:</a:t>
+            </a:r>
+            <a:r>
+              <a:rPr lang="en-US" dirty="0"/>
+              <a:t> positive trend </a:t>
+            </a:r>
+          </a:p>
+          <a:p>
+            <a:pPr lvl="1">
+              <a:buFont typeface="Wingdings" panose="05000000000000000000" pitchFamily="2" charset="2"/>
+              <a:buChar char="§"/>
+            </a:pPr>
+            <a:r>
+              <a:rPr lang="en-US" b="1" dirty="0"/>
+              <a:t>Orange:</a:t>
+            </a:r>
+            <a:r>
+              <a:rPr lang="en-US" dirty="0"/>
+              <a:t> positive trend </a:t>
+            </a:r>
+          </a:p>
+          <a:p>
+            <a:pPr lvl="1">
+              <a:buFont typeface="Wingdings" panose="05000000000000000000" pitchFamily="2" charset="2"/>
+              <a:buChar char="§"/>
+            </a:pPr>
+            <a:r>
+              <a:rPr lang="en-US" b="1" dirty="0"/>
+              <a:t>Bouygues, Free and SFR:</a:t>
+            </a:r>
+            <a:r>
+              <a:rPr lang="en-US" dirty="0"/>
+              <a:t> negative trend</a:t>
+            </a:r>
+          </a:p>
+          <a:p>
+            <a:r>
+              <a:rPr lang="en-US" dirty="0"/>
+              <a:t>The relationship between RSRQ and 5G download performance is less consistent. While the overall trend is positive, three operators show a negative relationship, whereas Orange shows a positive relationship. This suggests that the relationship between radio quality and download performance may depend on the operator and its network conditions.</a:t>
+            </a:r>
+          </a:p>
+        </p:txBody>
+      </p:sp>
+    </p:spTree>
+    <p:extLst>
+      <p:ext uri="{BB962C8B-B14F-4D97-AF65-F5344CB8AC3E}">
+        <p14:creationId xmlns:p14="http://schemas.microsoft.com/office/powerpoint/2010/main" val="384311853"/>
+      </p:ext>
+    </p:extLst>
+  </p:cSld>
+  <p:clrMapOvr>
+    <a:masterClrMapping/>
+  </p:clrMapOvr>
+</p:sld>
+</file>
+
+<file path=ppt/slides/slide14.xml><?xml version="1.0" encoding="utf-8"?>
+<p:sld xmlns:a="http://schemas.openxmlformats.org/drawingml/2006/main" xmlns:r="http://schemas.openxmlformats.org/officeDocument/2006/relationships" xmlns:p="http://schemas.openxmlformats.org/presentationml/2006/main">
+  <p:cSld>
+    <p:spTree>
+      <p:nvGrpSpPr>
+        <p:cNvPr id="1" name=""/>
+        <p:cNvGrpSpPr/>
+        <p:nvPr/>
+      </p:nvGrpSpPr>
+      <p:grpSpPr>
+        <a:xfrm>
+          <a:off x="0" y="0"/>
+          <a:ext cx="0" cy="0"/>
+          <a:chOff x="0" y="0"/>
+          <a:chExt cx="0" cy="0"/>
+        </a:xfrm>
+      </p:grpSpPr>
+      <p:sp>
+        <p:nvSpPr>
+          <p:cNvPr id="2" name="Title 1">
+            <a:extLst>
+              <a:ext uri="{FF2B5EF4-FFF2-40B4-BE49-F238E27FC236}">
+                <a16:creationId xmlns:a16="http://schemas.microsoft.com/office/drawing/2014/main" id="{372AB476-7B24-C21A-889F-4C51A852E807}"/>
+              </a:ext>
+            </a:extLst>
+          </p:cNvPr>
+          <p:cNvSpPr>
+            <a:spLocks noGrp="1"/>
+          </p:cNvSpPr>
+          <p:nvPr>
+            <p:ph type="title"/>
+          </p:nvPr>
+        </p:nvSpPr>
+        <p:spPr>
+          <a:xfrm>
+            <a:off x="1103312" y="390373"/>
+            <a:ext cx="9404723" cy="1400530"/>
+          </a:xfrm>
+        </p:spPr>
+        <p:txBody>
+          <a:bodyPr/>
+          <a:lstStyle/>
+          <a:p>
+            <a:r>
+              <a:rPr lang="en-US" dirty="0"/>
+              <a:t>Operator differences:</a:t>
+            </a:r>
+            <a:br>
+              <a:rPr lang="en-US" dirty="0"/>
+            </a:br>
+            <a:r>
+              <a:rPr lang="en-US" sz="2400" b="1" dirty="0"/>
+              <a:t>Do the four operators have different levels of 5G performance?</a:t>
+            </a:r>
+            <a:endParaRPr lang="en-US" dirty="0"/>
+          </a:p>
+        </p:txBody>
+      </p:sp>
+      <p:pic>
+        <p:nvPicPr>
+          <p:cNvPr id="5" name="Content Placeholder 4">
+            <a:extLst>
+              <a:ext uri="{FF2B5EF4-FFF2-40B4-BE49-F238E27FC236}">
+                <a16:creationId xmlns:a16="http://schemas.microsoft.com/office/drawing/2014/main" id="{FDC13AFB-4ACE-A8BA-1A69-0F3B9C5A7D49}"/>
+              </a:ext>
+            </a:extLst>
+          </p:cNvPr>
+          <p:cNvPicPr>
+            <a:picLocks noGrp="1" noChangeAspect="1"/>
+          </p:cNvPicPr>
+          <p:nvPr>
+            <p:ph idx="1"/>
+          </p:nvPr>
+        </p:nvPicPr>
+        <p:blipFill>
+          <a:blip r:embed="rId2"/>
+          <a:stretch>
+            <a:fillRect/>
+          </a:stretch>
+        </p:blipFill>
+        <p:spPr>
+          <a:xfrm>
+            <a:off x="4553130" y="2538613"/>
+            <a:ext cx="7397884" cy="3216874"/>
+          </a:xfrm>
+          <a:prstGeom prst="rect">
+            <a:avLst/>
+          </a:prstGeom>
+        </p:spPr>
+      </p:pic>
+      <p:sp>
+        <p:nvSpPr>
+          <p:cNvPr id="7" name="Content Placeholder 2">
+            <a:extLst>
+              <a:ext uri="{FF2B5EF4-FFF2-40B4-BE49-F238E27FC236}">
+                <a16:creationId xmlns:a16="http://schemas.microsoft.com/office/drawing/2014/main" id="{6C54C9D9-CF30-1F59-1E90-DC13EA73A84B}"/>
+              </a:ext>
+            </a:extLst>
+          </p:cNvPr>
+          <p:cNvSpPr txBox="1">
+            <a:spLocks/>
+          </p:cNvSpPr>
+          <p:nvPr/>
+        </p:nvSpPr>
+        <p:spPr>
+          <a:xfrm>
+            <a:off x="85123" y="2171330"/>
+            <a:ext cx="4133585" cy="4195481"/>
+          </a:xfrm>
+          <a:prstGeom prst="rect">
+            <a:avLst/>
+          </a:prstGeom>
+        </p:spPr>
+        <p:txBody>
+          <a:bodyPr vert="horz" lIns="91440" tIns="45720" rIns="91440" bIns="45720" rtlCol="0">
+            <a:normAutofit fontScale="85000" lnSpcReduction="20000"/>
+          </a:bodyPr>
+          <a:lstStyle>
+            <a:lvl1pPr marL="342900" indent="-342900" algn="l" defTabSz="457200" rtl="0" eaLnBrk="1" latinLnBrk="0" hangingPunct="1">
+              <a:spcBef>
+                <a:spcPts val="1000"/>
+              </a:spcBef>
+              <a:spcAft>
+                <a:spcPts val="0"/>
+              </a:spcAft>
+              <a:buClr>
+                <a:schemeClr val="accent1"/>
+              </a:buClr>
+              <a:buSzPct val="80000"/>
+              <a:buFont typeface="Wingdings 3" charset="2"/>
+              <a:buChar char=""/>
+              <a:defRPr sz="2000" b="0" i="0" kern="1200">
+                <a:solidFill>
+                  <a:schemeClr val="tx1"/>
+                </a:solidFill>
+                <a:latin typeface="+mj-lt"/>
+                <a:ea typeface="+mj-ea"/>
+                <a:cs typeface="+mj-cs"/>
+              </a:defRPr>
+            </a:lvl1pPr>
+            <a:lvl2pPr marL="742950" indent="-285750" algn="l" defTabSz="457200" rtl="0" eaLnBrk="1" latinLnBrk="0" hangingPunct="1">
+              <a:spcBef>
+                <a:spcPts val="1000"/>
+              </a:spcBef>
+              <a:spcAft>
+                <a:spcPts val="0"/>
+              </a:spcAft>
+              <a:buClr>
+                <a:schemeClr val="accent1"/>
+              </a:buClr>
+              <a:buSzPct val="80000"/>
+              <a:buFont typeface="Wingdings 3" charset="2"/>
+              <a:buChar char=""/>
+              <a:defRPr sz="1800" b="0" i="0" kern="1200">
+                <a:solidFill>
+                  <a:schemeClr val="tx1"/>
+                </a:solidFill>
+                <a:latin typeface="+mj-lt"/>
+                <a:ea typeface="+mj-ea"/>
+                <a:cs typeface="+mj-cs"/>
+              </a:defRPr>
+            </a:lvl2pPr>
+            <a:lvl3pPr marL="1143000" indent="-228600" algn="l" defTabSz="457200" rtl="0" eaLnBrk="1" latinLnBrk="0" hangingPunct="1">
+              <a:spcBef>
+                <a:spcPts val="1000"/>
+              </a:spcBef>
+              <a:spcAft>
+                <a:spcPts val="0"/>
+              </a:spcAft>
+              <a:buClr>
+                <a:schemeClr val="accent1"/>
+              </a:buClr>
+              <a:buSzPct val="80000"/>
+              <a:buFont typeface="Wingdings 3" charset="2"/>
+              <a:buChar char=""/>
+              <a:defRPr sz="1600" b="0" i="0" kern="1200">
+                <a:solidFill>
+                  <a:schemeClr val="tx1"/>
+                </a:solidFill>
+                <a:latin typeface="+mj-lt"/>
+                <a:ea typeface="+mj-ea"/>
+                <a:cs typeface="+mj-cs"/>
+              </a:defRPr>
+            </a:lvl3pPr>
+            <a:lvl4pPr marL="1600200" indent="-228600" algn="l" defTabSz="457200" rtl="0" eaLnBrk="1" latinLnBrk="0" hangingPunct="1">
+              <a:spcBef>
+                <a:spcPts val="1000"/>
+              </a:spcBef>
+              <a:spcAft>
+                <a:spcPts val="0"/>
+              </a:spcAft>
+              <a:buClr>
+                <a:schemeClr val="accent1"/>
+              </a:buClr>
+              <a:buSzPct val="80000"/>
+              <a:buFont typeface="Wingdings 3" charset="2"/>
+              <a:buChar char=""/>
+              <a:defRPr sz="1400" b="0" i="0" kern="1200">
+                <a:solidFill>
+                  <a:schemeClr val="tx1"/>
+                </a:solidFill>
+                <a:latin typeface="+mj-lt"/>
+                <a:ea typeface="+mj-ea"/>
+                <a:cs typeface="+mj-cs"/>
+              </a:defRPr>
+            </a:lvl4pPr>
+            <a:lvl5pPr marL="2057400" indent="-228600" algn="l" defTabSz="457200" rtl="0" eaLnBrk="1" latinLnBrk="0" hangingPunct="1">
+              <a:spcBef>
+                <a:spcPts val="1000"/>
+              </a:spcBef>
+              <a:spcAft>
+                <a:spcPts val="0"/>
+              </a:spcAft>
+              <a:buClr>
+                <a:schemeClr val="accent1"/>
+              </a:buClr>
+              <a:buSzPct val="80000"/>
+              <a:buFont typeface="Wingdings 3" charset="2"/>
+              <a:buChar char=""/>
+              <a:defRPr sz="1400" b="0" i="0" kern="1200">
+                <a:solidFill>
+                  <a:schemeClr val="tx1"/>
+                </a:solidFill>
+                <a:latin typeface="+mj-lt"/>
+                <a:ea typeface="+mj-ea"/>
+                <a:cs typeface="+mj-cs"/>
+              </a:defRPr>
+            </a:lvl5pPr>
+            <a:lvl6pPr marL="2514600" indent="-228600" algn="l" defTabSz="457200" rtl="0" eaLnBrk="1" latinLnBrk="0" hangingPunct="1">
+              <a:spcBef>
+                <a:spcPts val="1000"/>
+              </a:spcBef>
+              <a:spcAft>
+                <a:spcPts val="0"/>
+              </a:spcAft>
+              <a:buClr>
+                <a:schemeClr val="accent1"/>
+              </a:buClr>
+              <a:buSzPct val="80000"/>
+              <a:buFont typeface="Wingdings 3" charset="2"/>
+              <a:buChar char=""/>
+              <a:defRPr sz="1400" b="0" i="0" kern="1200">
+                <a:solidFill>
+                  <a:schemeClr val="tx1"/>
+                </a:solidFill>
+                <a:latin typeface="+mj-lt"/>
+                <a:ea typeface="+mj-ea"/>
+                <a:cs typeface="+mj-cs"/>
+              </a:defRPr>
+            </a:lvl6pPr>
+            <a:lvl7pPr marL="2971800" indent="-228600" algn="l" defTabSz="457200" rtl="0" eaLnBrk="1" latinLnBrk="0" hangingPunct="1">
+              <a:spcBef>
+                <a:spcPts val="1000"/>
+              </a:spcBef>
+              <a:spcAft>
+                <a:spcPts val="0"/>
+              </a:spcAft>
+              <a:buClr>
+                <a:schemeClr val="accent1"/>
+              </a:buClr>
+              <a:buSzPct val="80000"/>
+              <a:buFont typeface="Wingdings 3" charset="2"/>
+              <a:buChar char=""/>
+              <a:defRPr sz="1400" b="0" i="0" kern="1200">
+                <a:solidFill>
+                  <a:schemeClr val="tx1"/>
+                </a:solidFill>
+                <a:latin typeface="+mj-lt"/>
+                <a:ea typeface="+mj-ea"/>
+                <a:cs typeface="+mj-cs"/>
+              </a:defRPr>
+            </a:lvl7pPr>
+            <a:lvl8pPr marL="3429000" indent="-228600" algn="l" defTabSz="457200" rtl="0" eaLnBrk="1" latinLnBrk="0" hangingPunct="1">
+              <a:spcBef>
+                <a:spcPts val="1000"/>
+              </a:spcBef>
+              <a:spcAft>
+                <a:spcPts val="0"/>
+              </a:spcAft>
+              <a:buClr>
+                <a:schemeClr val="accent1"/>
+              </a:buClr>
+              <a:buSzPct val="80000"/>
+              <a:buFont typeface="Wingdings 3" charset="2"/>
+              <a:buChar char=""/>
+              <a:defRPr sz="1400" b="0" i="0" kern="1200">
+                <a:solidFill>
+                  <a:schemeClr val="tx1"/>
+                </a:solidFill>
+                <a:latin typeface="+mj-lt"/>
+                <a:ea typeface="+mj-ea"/>
+                <a:cs typeface="+mj-cs"/>
+              </a:defRPr>
+            </a:lvl8pPr>
+            <a:lvl9pPr marL="3886200" indent="-228600" algn="l" defTabSz="457200" rtl="0" eaLnBrk="1" latinLnBrk="0" hangingPunct="1">
+              <a:spcBef>
+                <a:spcPts val="1000"/>
+              </a:spcBef>
+              <a:spcAft>
+                <a:spcPts val="0"/>
+              </a:spcAft>
+              <a:buClr>
+                <a:schemeClr val="accent1"/>
+              </a:buClr>
+              <a:buSzPct val="80000"/>
+              <a:buFont typeface="Wingdings 3" charset="2"/>
+              <a:buChar char=""/>
+              <a:defRPr sz="1400" b="0" i="0" kern="1200">
+                <a:solidFill>
+                  <a:schemeClr val="tx1"/>
+                </a:solidFill>
+                <a:latin typeface="+mj-lt"/>
+                <a:ea typeface="+mj-ea"/>
+                <a:cs typeface="+mj-cs"/>
+              </a:defRPr>
+            </a:lvl9pPr>
+          </a:lstStyle>
+          <a:p>
+            <a:r>
+              <a:rPr lang="en-US" dirty="0"/>
+              <a:t>Significant differences in 5G performance are observed between operators. Orange has the highest average download speed, followed by Bouygues Telecom, SFR and Free. However, the ranking of 5G deployment rates is almost the opposite, with Free having the highest deployment rate and Orange the lowest. This indicates that a higher level of 5G deployment does not necessarily translate into higher download performance. Operator-specific network strategies and radio conditions may therefore contribute to the observed performance disparities.</a:t>
+            </a:r>
+          </a:p>
+        </p:txBody>
+      </p:sp>
+    </p:spTree>
+    <p:extLst>
+      <p:ext uri="{BB962C8B-B14F-4D97-AF65-F5344CB8AC3E}">
+        <p14:creationId xmlns:p14="http://schemas.microsoft.com/office/powerpoint/2010/main" val="3640212211"/>
+      </p:ext>
+    </p:extLst>
+  </p:cSld>
+  <p:clrMapOvr>
+    <a:masterClrMapping/>
+  </p:clrMapOvr>
+</p:sld>
+</file>
+
+<file path=ppt/slides/slide15.xml><?xml version="1.0" encoding="utf-8"?>
+<p:sld xmlns:a="http://schemas.openxmlformats.org/drawingml/2006/main" xmlns:r="http://schemas.openxmlformats.org/officeDocument/2006/relationships" xmlns:p="http://schemas.openxmlformats.org/presentationml/2006/main">
+  <p:cSld>
+    <p:spTree>
+      <p:nvGrpSpPr>
+        <p:cNvPr id="1" name=""/>
+        <p:cNvGrpSpPr/>
+        <p:nvPr/>
+      </p:nvGrpSpPr>
+      <p:grpSpPr>
+        <a:xfrm>
+          <a:off x="0" y="0"/>
+          <a:ext cx="0" cy="0"/>
+          <a:chOff x="0" y="0"/>
+          <a:chExt cx="0" cy="0"/>
+        </a:xfrm>
+      </p:grpSpPr>
+      <p:sp>
+        <p:nvSpPr>
+          <p:cNvPr id="2" name="Title 1">
+            <a:extLst>
+              <a:ext uri="{FF2B5EF4-FFF2-40B4-BE49-F238E27FC236}">
+                <a16:creationId xmlns:a16="http://schemas.microsoft.com/office/drawing/2014/main" id="{86D00839-9EA0-6EDD-0599-E7D9F9F1C64C}"/>
+              </a:ext>
+            </a:extLst>
+          </p:cNvPr>
+          <p:cNvSpPr>
+            <a:spLocks noGrp="1"/>
+          </p:cNvSpPr>
+          <p:nvPr>
+            <p:ph type="title"/>
+          </p:nvPr>
+        </p:nvSpPr>
+        <p:spPr>
+          <a:xfrm>
+            <a:off x="645130" y="140991"/>
+            <a:ext cx="9404723" cy="1400530"/>
+          </a:xfrm>
+        </p:spPr>
+        <p:txBody>
+          <a:bodyPr/>
+          <a:lstStyle/>
+          <a:p>
+            <a:r>
+              <a:rPr lang="en-US" dirty="0"/>
+              <a:t>Let’s reinforce the previous visual observation by a statistical test</a:t>
+            </a:r>
+            <a:br>
+              <a:rPr lang="en-US" dirty="0"/>
+            </a:br>
+            <a:r>
+              <a:rPr lang="en-US" sz="3600" b="1" dirty="0"/>
+              <a:t>Hypothesis testing1</a:t>
+            </a:r>
+            <a:br>
+              <a:rPr lang="en-US" dirty="0"/>
+            </a:br>
+            <a:br>
+              <a:rPr lang="en-US" sz="2400" b="1" dirty="0"/>
+            </a:br>
+            <a:endParaRPr lang="en-US" b="1" dirty="0"/>
+          </a:p>
+        </p:txBody>
+      </p:sp>
+      <p:sp>
+        <p:nvSpPr>
+          <p:cNvPr id="3" name="Content Placeholder 2">
+            <a:extLst>
+              <a:ext uri="{FF2B5EF4-FFF2-40B4-BE49-F238E27FC236}">
+                <a16:creationId xmlns:a16="http://schemas.microsoft.com/office/drawing/2014/main" id="{089E2A11-159C-8804-67F8-0331A731A6F6}"/>
+              </a:ext>
+            </a:extLst>
+          </p:cNvPr>
+          <p:cNvSpPr>
+            <a:spLocks noGrp="1"/>
+          </p:cNvSpPr>
+          <p:nvPr>
+            <p:ph idx="1"/>
+          </p:nvPr>
+        </p:nvSpPr>
+        <p:spPr/>
+        <p:txBody>
+          <a:bodyPr>
+            <a:normAutofit/>
+          </a:bodyPr>
+          <a:lstStyle/>
+          <a:p>
+            <a:r>
+              <a:rPr lang="en-US" dirty="0"/>
+              <a:t>Do operators have different average 5G download speed across French regions? </a:t>
+            </a:r>
+          </a:p>
+          <a:p>
+            <a:pPr lvl="1">
+              <a:buFont typeface="Wingdings" panose="05000000000000000000" pitchFamily="2" charset="2"/>
+              <a:buChar char="v"/>
+            </a:pPr>
+            <a:r>
+              <a:rPr lang="en-US" b="1" dirty="0"/>
+              <a:t>H₀:</a:t>
+            </a:r>
+            <a:r>
+              <a:rPr lang="en-US" dirty="0"/>
+              <a:t> the average of 5G download speed is the same for all operators. </a:t>
+            </a:r>
+          </a:p>
+          <a:p>
+            <a:pPr lvl="1">
+              <a:buFont typeface="Wingdings" panose="05000000000000000000" pitchFamily="2" charset="2"/>
+              <a:buChar char="v"/>
+            </a:pPr>
+            <a:r>
+              <a:rPr lang="en-US" b="1" dirty="0"/>
+              <a:t>H₁:</a:t>
+            </a:r>
+            <a:r>
+              <a:rPr lang="en-US" dirty="0"/>
+              <a:t> at least one operator differs.</a:t>
+            </a:r>
+          </a:p>
+          <a:p>
+            <a:pPr lvl="1">
+              <a:buFont typeface="Wingdings" panose="05000000000000000000" pitchFamily="2" charset="2"/>
+              <a:buChar char="è"/>
+            </a:pPr>
+            <a:r>
+              <a:rPr lang="en-US" dirty="0"/>
+              <a:t>1-way </a:t>
+            </a:r>
+            <a:r>
+              <a:rPr lang="en-US" dirty="0" err="1"/>
+              <a:t>Anovatest</a:t>
+            </a:r>
+            <a:r>
+              <a:rPr lang="en-US" dirty="0"/>
+              <a:t>: Why Kruskal–Wallis for operators?</a:t>
+            </a:r>
+          </a:p>
+          <a:p>
+            <a:pPr lvl="2">
+              <a:buFont typeface="Wingdings" panose="05000000000000000000" pitchFamily="2" charset="2"/>
+              <a:buChar char="è"/>
+            </a:pPr>
+            <a:r>
+              <a:rPr lang="en-US" dirty="0"/>
+              <a:t>We have </a:t>
+            </a:r>
+            <a:r>
+              <a:rPr lang="en-US" b="1" dirty="0"/>
+              <a:t>4 independent operator groups </a:t>
+            </a:r>
+            <a:r>
+              <a:rPr lang="en-US" b="1" dirty="0">
+                <a:sym typeface="Wingdings" panose="05000000000000000000" pitchFamily="2" charset="2"/>
+              </a:rPr>
+              <a:t>One way Anova</a:t>
+            </a:r>
+            <a:endParaRPr lang="en-US" dirty="0"/>
+          </a:p>
+          <a:p>
+            <a:endParaRPr lang="en-US" dirty="0"/>
+          </a:p>
+          <a:p>
+            <a:r>
+              <a:rPr lang="en-US" dirty="0"/>
+              <a:t>The one-way ANOVA indicates a statistically significant difference in average download speed between the four mobile operators (F = 32.44, p &lt; 0.001). Therefore, the null hypothesis of equal mean download speeds is rejected.</a:t>
+            </a:r>
+          </a:p>
+        </p:txBody>
+      </p:sp>
+    </p:spTree>
+    <p:extLst>
+      <p:ext uri="{BB962C8B-B14F-4D97-AF65-F5344CB8AC3E}">
+        <p14:creationId xmlns:p14="http://schemas.microsoft.com/office/powerpoint/2010/main" val="1064116770"/>
+      </p:ext>
+    </p:extLst>
+  </p:cSld>
+  <p:clrMapOvr>
+    <a:masterClrMapping/>
+  </p:clrMapOvr>
+</p:sld>
+</file>
+
+<file path=ppt/slides/slide16.xml><?xml version="1.0" encoding="utf-8"?>
+<p:sld xmlns:a="http://schemas.openxmlformats.org/drawingml/2006/main" xmlns:r="http://schemas.openxmlformats.org/officeDocument/2006/relationships" xmlns:p="http://schemas.openxmlformats.org/presentationml/2006/main">
+  <p:cSld>
+    <p:spTree>
+      <p:nvGrpSpPr>
+        <p:cNvPr id="1" name=""/>
+        <p:cNvGrpSpPr/>
+        <p:nvPr/>
+      </p:nvGrpSpPr>
+      <p:grpSpPr>
+        <a:xfrm>
+          <a:off x="0" y="0"/>
+          <a:ext cx="0" cy="0"/>
+          <a:chOff x="0" y="0"/>
+          <a:chExt cx="0" cy="0"/>
+        </a:xfrm>
+      </p:grpSpPr>
+      <p:sp>
+        <p:nvSpPr>
+          <p:cNvPr id="2" name="Title 1">
+            <a:extLst>
+              <a:ext uri="{FF2B5EF4-FFF2-40B4-BE49-F238E27FC236}">
+                <a16:creationId xmlns:a16="http://schemas.microsoft.com/office/drawing/2014/main" id="{F03A4959-28EB-08DD-292C-C563F967444C}"/>
+              </a:ext>
+            </a:extLst>
+          </p:cNvPr>
+          <p:cNvSpPr>
+            <a:spLocks noGrp="1"/>
+          </p:cNvSpPr>
+          <p:nvPr>
+            <p:ph type="title"/>
+          </p:nvPr>
+        </p:nvSpPr>
+        <p:spPr/>
+        <p:txBody>
+          <a:bodyPr/>
+          <a:lstStyle/>
+          <a:p>
+            <a:r>
+              <a:rPr lang="fr-FR" dirty="0" err="1"/>
+              <a:t>Conslusion</a:t>
+            </a:r>
+            <a:r>
+              <a:rPr lang="fr-FR" dirty="0"/>
+              <a:t> </a:t>
+            </a:r>
+            <a:r>
+              <a:rPr lang="fr-FR" dirty="0" err="1"/>
+              <a:t>Analysis</a:t>
+            </a:r>
+            <a:endParaRPr lang="en-US" dirty="0"/>
+          </a:p>
+        </p:txBody>
+      </p:sp>
+      <p:sp>
+        <p:nvSpPr>
+          <p:cNvPr id="3" name="Content Placeholder 2">
+            <a:extLst>
+              <a:ext uri="{FF2B5EF4-FFF2-40B4-BE49-F238E27FC236}">
+                <a16:creationId xmlns:a16="http://schemas.microsoft.com/office/drawing/2014/main" id="{778EE035-7E71-84FB-EF79-8D382C670D80}"/>
+              </a:ext>
+            </a:extLst>
+          </p:cNvPr>
+          <p:cNvSpPr>
+            <a:spLocks noGrp="1"/>
+          </p:cNvSpPr>
+          <p:nvPr>
+            <p:ph idx="1"/>
+          </p:nvPr>
+        </p:nvSpPr>
+        <p:spPr/>
+        <p:txBody>
+          <a:bodyPr/>
+          <a:lstStyle/>
+          <a:p>
+            <a:pPr lvl="0"/>
+            <a:r>
+              <a:rPr lang="en-US" b="1" dirty="0"/>
+              <a:t>Infrastructure:</a:t>
+            </a:r>
+            <a:r>
+              <a:rPr lang="en-US" dirty="0"/>
+              <a:t> deployment alone does not explain performance. </a:t>
+            </a:r>
+          </a:p>
+          <a:p>
+            <a:pPr lvl="0"/>
+            <a:r>
+              <a:rPr lang="en-US" b="1" dirty="0"/>
+              <a:t>Population:</a:t>
+            </a:r>
+            <a:r>
+              <a:rPr lang="en-US" dirty="0"/>
+              <a:t> more populated regions tend to have higher download speeds. </a:t>
+            </a:r>
+          </a:p>
+          <a:p>
+            <a:pPr lvl="0"/>
+            <a:r>
+              <a:rPr lang="en-US" b="1" dirty="0"/>
+              <a:t>Radio conditions:</a:t>
+            </a:r>
+            <a:r>
+              <a:rPr lang="en-US" dirty="0"/>
+              <a:t> RSRP has a consistent positive relationship; RSRQ is operator-dependent. </a:t>
+            </a:r>
+          </a:p>
+          <a:p>
+            <a:pPr lvl="0"/>
+            <a:r>
+              <a:rPr lang="en-US" b="1" dirty="0"/>
+              <a:t>Operators:</a:t>
+            </a:r>
+            <a:r>
+              <a:rPr lang="en-US" dirty="0"/>
+              <a:t> strong differences in performance and deployment strategy.</a:t>
+            </a:r>
+          </a:p>
+          <a:p>
+            <a:endParaRPr lang="en-US" dirty="0"/>
+          </a:p>
+        </p:txBody>
+      </p:sp>
+    </p:spTree>
+    <p:extLst>
+      <p:ext uri="{BB962C8B-B14F-4D97-AF65-F5344CB8AC3E}">
+        <p14:creationId xmlns:p14="http://schemas.microsoft.com/office/powerpoint/2010/main" val="3500296086"/>
+      </p:ext>
+    </p:extLst>
+  </p:cSld>
+  <p:clrMapOvr>
+    <a:masterClrMapping/>
+  </p:clrMapOvr>
+</p:sld>
+</file>
+
+<file path=ppt/slides/slide17.xml><?xml version="1.0" encoding="utf-8"?>
+<p:sld xmlns:a="http://schemas.openxmlformats.org/drawingml/2006/main" xmlns:r="http://schemas.openxmlformats.org/officeDocument/2006/relationships" xmlns:p="http://schemas.openxmlformats.org/presentationml/2006/main">
+  <p:cSld>
+    <p:spTree>
+      <p:nvGrpSpPr>
+        <p:cNvPr id="1" name=""/>
+        <p:cNvGrpSpPr/>
+        <p:nvPr/>
+      </p:nvGrpSpPr>
+      <p:grpSpPr>
+        <a:xfrm>
+          <a:off x="0" y="0"/>
+          <a:ext cx="0" cy="0"/>
+          <a:chOff x="0" y="0"/>
+          <a:chExt cx="0" cy="0"/>
+        </a:xfrm>
+      </p:grpSpPr>
+      <p:sp>
+        <p:nvSpPr>
+          <p:cNvPr id="2" name="Title 1">
+            <a:extLst>
+              <a:ext uri="{FF2B5EF4-FFF2-40B4-BE49-F238E27FC236}">
+                <a16:creationId xmlns:a16="http://schemas.microsoft.com/office/drawing/2014/main" id="{8CEBEADA-5AD3-6471-E08E-EB513AC09E20}"/>
+              </a:ext>
+            </a:extLst>
+          </p:cNvPr>
+          <p:cNvSpPr>
+            <a:spLocks noGrp="1"/>
+          </p:cNvSpPr>
+          <p:nvPr>
+            <p:ph type="title"/>
+          </p:nvPr>
+        </p:nvSpPr>
+        <p:spPr/>
+        <p:txBody>
+          <a:bodyPr/>
+          <a:lstStyle/>
+          <a:p>
+            <a:r>
+              <a:rPr lang="en-US" dirty="0"/>
+              <a:t>Hypothesis testing2</a:t>
+            </a:r>
+          </a:p>
+        </p:txBody>
+      </p:sp>
+      <p:sp>
+        <p:nvSpPr>
+          <p:cNvPr id="3" name="Content Placeholder 2">
+            <a:extLst>
+              <a:ext uri="{FF2B5EF4-FFF2-40B4-BE49-F238E27FC236}">
+                <a16:creationId xmlns:a16="http://schemas.microsoft.com/office/drawing/2014/main" id="{A723C284-61E4-A3C8-F72F-535F54132786}"/>
+              </a:ext>
+            </a:extLst>
+          </p:cNvPr>
+          <p:cNvSpPr>
+            <a:spLocks noGrp="1"/>
+          </p:cNvSpPr>
+          <p:nvPr>
+            <p:ph idx="1"/>
+          </p:nvPr>
+        </p:nvSpPr>
+        <p:spPr/>
+        <p:txBody>
+          <a:bodyPr/>
+          <a:lstStyle/>
+          <a:p>
+            <a:endParaRPr lang="en-US" dirty="0"/>
+          </a:p>
+        </p:txBody>
+      </p:sp>
+    </p:spTree>
+    <p:extLst>
+      <p:ext uri="{BB962C8B-B14F-4D97-AF65-F5344CB8AC3E}">
+        <p14:creationId xmlns:p14="http://schemas.microsoft.com/office/powerpoint/2010/main" val="2089249441"/>
+      </p:ext>
+    </p:extLst>
+  </p:cSld>
+  <p:clrMapOvr>
+    <a:masterClrMapping/>
+  </p:clrMapOvr>
+</p:sld>
+</file>
+
 <file path=ppt/slides/slide2.xml><?xml version="1.0" encoding="utf-8"?>
 <p:sld xmlns:a="http://schemas.openxmlformats.org/drawingml/2006/main" xmlns:r="http://schemas.openxmlformats.org/officeDocument/2006/relationships" xmlns:p="http://schemas.openxmlformats.org/presentationml/2006/main">
   <p:cSld>
@@ -6243,7 +7947,7 @@
           <p:cNvPr id="2" name="Title 1">
             <a:extLst>
               <a:ext uri="{FF2B5EF4-FFF2-40B4-BE49-F238E27FC236}">
-                <a16:creationId xmlns:a16="http://schemas.microsoft.com/office/drawing/2014/main" id="{09897808-0148-A72C-9BE3-74E4E592A827}"/>
+                <a16:creationId xmlns:a16="http://schemas.microsoft.com/office/drawing/2014/main" id="{D3B037B9-6064-E947-BFE6-555E1D42FD8E}"/>
               </a:ext>
             </a:extLst>
           </p:cNvPr>
@@ -6254,12 +7958,20 @@
             <p:ph type="title"/>
           </p:nvPr>
         </p:nvSpPr>
-        <p:spPr/>
+        <p:spPr>
+          <a:xfrm>
+            <a:off x="646111" y="452718"/>
+            <a:ext cx="9609716" cy="1400530"/>
+          </a:xfrm>
+        </p:spPr>
         <p:txBody>
           <a:bodyPr/>
           <a:lstStyle/>
           <a:p>
-            <a:endParaRPr lang="en-US"/>
+            <a:r>
+              <a:rPr lang="en-US" dirty="0"/>
+              <a:t>Data acquisition 1 Data modelling</a:t>
+            </a:r>
           </a:p>
         </p:txBody>
       </p:sp>
@@ -6268,7 +7980,7 @@
           <p:cNvPr id="3" name="Content Placeholder 2">
             <a:extLst>
               <a:ext uri="{FF2B5EF4-FFF2-40B4-BE49-F238E27FC236}">
-                <a16:creationId xmlns:a16="http://schemas.microsoft.com/office/drawing/2014/main" id="{A1E64786-B4DA-8552-8316-646BF33CB08E}"/>
+                <a16:creationId xmlns:a16="http://schemas.microsoft.com/office/drawing/2014/main" id="{BF879EB4-5DF2-86E7-7DA8-8E2B4930034C}"/>
               </a:ext>
             </a:extLst>
           </p:cNvPr>
@@ -6279,19 +7991,343 @@
             <p:ph idx="1"/>
           </p:nvPr>
         </p:nvSpPr>
-        <p:spPr/>
+        <p:spPr>
+          <a:xfrm>
+            <a:off x="1103312" y="2052919"/>
+            <a:ext cx="5422179" cy="2248918"/>
+          </a:xfrm>
+        </p:spPr>
         <p:txBody>
           <a:bodyPr/>
           <a:lstStyle/>
           <a:p>
-            <a:endParaRPr lang="en-US"/>
+            <a:pPr lvl="0"/>
+            <a:r>
+              <a:rPr lang="en-US" dirty="0"/>
+              <a:t>Web scraping → ARCEP QoS </a:t>
+            </a:r>
+          </a:p>
+          <a:p>
+            <a:pPr lvl="0"/>
+            <a:r>
+              <a:rPr lang="en-US" dirty="0"/>
+              <a:t>Flat files → ARCEP Sites / INSEE </a:t>
+            </a:r>
+          </a:p>
+          <a:p>
+            <a:pPr lvl="0"/>
+            <a:r>
+              <a:rPr lang="en-US" dirty="0"/>
+              <a:t>Data preserved in raw form </a:t>
+            </a:r>
+          </a:p>
+          <a:p>
+            <a:pPr lvl="0"/>
+            <a:r>
+              <a:rPr lang="en-US" dirty="0"/>
+              <a:t>Cleaning performed independently</a:t>
+            </a:r>
+          </a:p>
+          <a:p>
+            <a:endParaRPr lang="en-US" dirty="0"/>
+          </a:p>
+        </p:txBody>
+      </p:sp>
+      <p:sp>
+        <p:nvSpPr>
+          <p:cNvPr id="4" name="Content Placeholder 2">
+            <a:extLst>
+              <a:ext uri="{FF2B5EF4-FFF2-40B4-BE49-F238E27FC236}">
+                <a16:creationId xmlns:a16="http://schemas.microsoft.com/office/drawing/2014/main" id="{E3B5068D-A489-72C9-CEC7-0BBFC93AD3F3}"/>
+              </a:ext>
+            </a:extLst>
+          </p:cNvPr>
+          <p:cNvSpPr txBox="1">
+            <a:spLocks/>
+          </p:cNvSpPr>
+          <p:nvPr/>
+        </p:nvSpPr>
+        <p:spPr>
+          <a:xfrm>
+            <a:off x="6368039" y="2052918"/>
+            <a:ext cx="5422179" cy="2706117"/>
+          </a:xfrm>
+          <a:prstGeom prst="rect">
+            <a:avLst/>
+          </a:prstGeom>
+        </p:spPr>
+        <p:txBody>
+          <a:bodyPr vert="horz" lIns="91440" tIns="45720" rIns="91440" bIns="45720" rtlCol="0">
+            <a:normAutofit/>
+          </a:bodyPr>
+          <a:lstStyle>
+            <a:lvl1pPr marL="342900" indent="-342900" algn="l" defTabSz="457200" rtl="0" eaLnBrk="1" latinLnBrk="0" hangingPunct="1">
+              <a:spcBef>
+                <a:spcPts val="1000"/>
+              </a:spcBef>
+              <a:spcAft>
+                <a:spcPts val="0"/>
+              </a:spcAft>
+              <a:buClr>
+                <a:schemeClr val="accent1"/>
+              </a:buClr>
+              <a:buSzPct val="80000"/>
+              <a:buFont typeface="Wingdings 3" charset="2"/>
+              <a:buChar char=""/>
+              <a:defRPr sz="2000" b="0" i="0" kern="1200">
+                <a:solidFill>
+                  <a:schemeClr val="tx1"/>
+                </a:solidFill>
+                <a:latin typeface="+mj-lt"/>
+                <a:ea typeface="+mj-ea"/>
+                <a:cs typeface="+mj-cs"/>
+              </a:defRPr>
+            </a:lvl1pPr>
+            <a:lvl2pPr marL="742950" indent="-285750" algn="l" defTabSz="457200" rtl="0" eaLnBrk="1" latinLnBrk="0" hangingPunct="1">
+              <a:spcBef>
+                <a:spcPts val="1000"/>
+              </a:spcBef>
+              <a:spcAft>
+                <a:spcPts val="0"/>
+              </a:spcAft>
+              <a:buClr>
+                <a:schemeClr val="accent1"/>
+              </a:buClr>
+              <a:buSzPct val="80000"/>
+              <a:buFont typeface="Wingdings 3" charset="2"/>
+              <a:buChar char=""/>
+              <a:defRPr sz="1800" b="0" i="0" kern="1200">
+                <a:solidFill>
+                  <a:schemeClr val="tx1"/>
+                </a:solidFill>
+                <a:latin typeface="+mj-lt"/>
+                <a:ea typeface="+mj-ea"/>
+                <a:cs typeface="+mj-cs"/>
+              </a:defRPr>
+            </a:lvl2pPr>
+            <a:lvl3pPr marL="1143000" indent="-228600" algn="l" defTabSz="457200" rtl="0" eaLnBrk="1" latinLnBrk="0" hangingPunct="1">
+              <a:spcBef>
+                <a:spcPts val="1000"/>
+              </a:spcBef>
+              <a:spcAft>
+                <a:spcPts val="0"/>
+              </a:spcAft>
+              <a:buClr>
+                <a:schemeClr val="accent1"/>
+              </a:buClr>
+              <a:buSzPct val="80000"/>
+              <a:buFont typeface="Wingdings 3" charset="2"/>
+              <a:buChar char=""/>
+              <a:defRPr sz="1600" b="0" i="0" kern="1200">
+                <a:solidFill>
+                  <a:schemeClr val="tx1"/>
+                </a:solidFill>
+                <a:latin typeface="+mj-lt"/>
+                <a:ea typeface="+mj-ea"/>
+                <a:cs typeface="+mj-cs"/>
+              </a:defRPr>
+            </a:lvl3pPr>
+            <a:lvl4pPr marL="1600200" indent="-228600" algn="l" defTabSz="457200" rtl="0" eaLnBrk="1" latinLnBrk="0" hangingPunct="1">
+              <a:spcBef>
+                <a:spcPts val="1000"/>
+              </a:spcBef>
+              <a:spcAft>
+                <a:spcPts val="0"/>
+              </a:spcAft>
+              <a:buClr>
+                <a:schemeClr val="accent1"/>
+              </a:buClr>
+              <a:buSzPct val="80000"/>
+              <a:buFont typeface="Wingdings 3" charset="2"/>
+              <a:buChar char=""/>
+              <a:defRPr sz="1400" b="0" i="0" kern="1200">
+                <a:solidFill>
+                  <a:schemeClr val="tx1"/>
+                </a:solidFill>
+                <a:latin typeface="+mj-lt"/>
+                <a:ea typeface="+mj-ea"/>
+                <a:cs typeface="+mj-cs"/>
+              </a:defRPr>
+            </a:lvl4pPr>
+            <a:lvl5pPr marL="2057400" indent="-228600" algn="l" defTabSz="457200" rtl="0" eaLnBrk="1" latinLnBrk="0" hangingPunct="1">
+              <a:spcBef>
+                <a:spcPts val="1000"/>
+              </a:spcBef>
+              <a:spcAft>
+                <a:spcPts val="0"/>
+              </a:spcAft>
+              <a:buClr>
+                <a:schemeClr val="accent1"/>
+              </a:buClr>
+              <a:buSzPct val="80000"/>
+              <a:buFont typeface="Wingdings 3" charset="2"/>
+              <a:buChar char=""/>
+              <a:defRPr sz="1400" b="0" i="0" kern="1200">
+                <a:solidFill>
+                  <a:schemeClr val="tx1"/>
+                </a:solidFill>
+                <a:latin typeface="+mj-lt"/>
+                <a:ea typeface="+mj-ea"/>
+                <a:cs typeface="+mj-cs"/>
+              </a:defRPr>
+            </a:lvl5pPr>
+            <a:lvl6pPr marL="2514600" indent="-228600" algn="l" defTabSz="457200" rtl="0" eaLnBrk="1" latinLnBrk="0" hangingPunct="1">
+              <a:spcBef>
+                <a:spcPts val="1000"/>
+              </a:spcBef>
+              <a:spcAft>
+                <a:spcPts val="0"/>
+              </a:spcAft>
+              <a:buClr>
+                <a:schemeClr val="accent1"/>
+              </a:buClr>
+              <a:buSzPct val="80000"/>
+              <a:buFont typeface="Wingdings 3" charset="2"/>
+              <a:buChar char=""/>
+              <a:defRPr sz="1400" b="0" i="0" kern="1200">
+                <a:solidFill>
+                  <a:schemeClr val="tx1"/>
+                </a:solidFill>
+                <a:latin typeface="+mj-lt"/>
+                <a:ea typeface="+mj-ea"/>
+                <a:cs typeface="+mj-cs"/>
+              </a:defRPr>
+            </a:lvl6pPr>
+            <a:lvl7pPr marL="2971800" indent="-228600" algn="l" defTabSz="457200" rtl="0" eaLnBrk="1" latinLnBrk="0" hangingPunct="1">
+              <a:spcBef>
+                <a:spcPts val="1000"/>
+              </a:spcBef>
+              <a:spcAft>
+                <a:spcPts val="0"/>
+              </a:spcAft>
+              <a:buClr>
+                <a:schemeClr val="accent1"/>
+              </a:buClr>
+              <a:buSzPct val="80000"/>
+              <a:buFont typeface="Wingdings 3" charset="2"/>
+              <a:buChar char=""/>
+              <a:defRPr sz="1400" b="0" i="0" kern="1200">
+                <a:solidFill>
+                  <a:schemeClr val="tx1"/>
+                </a:solidFill>
+                <a:latin typeface="+mj-lt"/>
+                <a:ea typeface="+mj-ea"/>
+                <a:cs typeface="+mj-cs"/>
+              </a:defRPr>
+            </a:lvl7pPr>
+            <a:lvl8pPr marL="3429000" indent="-228600" algn="l" defTabSz="457200" rtl="0" eaLnBrk="1" latinLnBrk="0" hangingPunct="1">
+              <a:spcBef>
+                <a:spcPts val="1000"/>
+              </a:spcBef>
+              <a:spcAft>
+                <a:spcPts val="0"/>
+              </a:spcAft>
+              <a:buClr>
+                <a:schemeClr val="accent1"/>
+              </a:buClr>
+              <a:buSzPct val="80000"/>
+              <a:buFont typeface="Wingdings 3" charset="2"/>
+              <a:buChar char=""/>
+              <a:defRPr sz="1400" b="0" i="0" kern="1200">
+                <a:solidFill>
+                  <a:schemeClr val="tx1"/>
+                </a:solidFill>
+                <a:latin typeface="+mj-lt"/>
+                <a:ea typeface="+mj-ea"/>
+                <a:cs typeface="+mj-cs"/>
+              </a:defRPr>
+            </a:lvl8pPr>
+            <a:lvl9pPr marL="3886200" indent="-228600" algn="l" defTabSz="457200" rtl="0" eaLnBrk="1" latinLnBrk="0" hangingPunct="1">
+              <a:spcBef>
+                <a:spcPts val="1000"/>
+              </a:spcBef>
+              <a:spcAft>
+                <a:spcPts val="0"/>
+              </a:spcAft>
+              <a:buClr>
+                <a:schemeClr val="accent1"/>
+              </a:buClr>
+              <a:buSzPct val="80000"/>
+              <a:buFont typeface="Wingdings 3" charset="2"/>
+              <a:buChar char=""/>
+              <a:defRPr sz="1400" b="0" i="0" kern="1200">
+                <a:solidFill>
+                  <a:schemeClr val="tx1"/>
+                </a:solidFill>
+                <a:latin typeface="+mj-lt"/>
+                <a:ea typeface="+mj-ea"/>
+                <a:cs typeface="+mj-cs"/>
+              </a:defRPr>
+            </a:lvl9pPr>
+          </a:lstStyle>
+          <a:p>
+            <a:pPr lvl="0"/>
+            <a:r>
+              <a:rPr lang="en-US" dirty="0" err="1"/>
+              <a:t>fact_qos_measurements</a:t>
+            </a:r>
+            <a:r>
+              <a:rPr lang="en-US" dirty="0"/>
+              <a:t> </a:t>
+            </a:r>
+          </a:p>
+          <a:p>
+            <a:pPr lvl="0"/>
+            <a:r>
+              <a:rPr lang="en-US" dirty="0"/>
+              <a:t>sites </a:t>
+            </a:r>
+          </a:p>
+          <a:p>
+            <a:pPr lvl="0"/>
+            <a:r>
+              <a:rPr lang="en-US" dirty="0" err="1"/>
+              <a:t>dim_geo</a:t>
+            </a:r>
+            <a:r>
+              <a:rPr lang="en-US" dirty="0"/>
+              <a:t> </a:t>
+            </a:r>
+          </a:p>
+          <a:p>
+            <a:pPr lvl="0"/>
+            <a:r>
+              <a:rPr lang="en-US" dirty="0" err="1"/>
+              <a:t>dim_operator</a:t>
+            </a:r>
+            <a:r>
+              <a:rPr lang="en-US" dirty="0"/>
+              <a:t> </a:t>
+            </a:r>
+          </a:p>
+          <a:p>
+            <a:pPr lvl="0"/>
+            <a:r>
+              <a:rPr lang="en-US" dirty="0" err="1"/>
+              <a:t>dim_protocol</a:t>
+            </a:r>
+            <a:r>
+              <a:rPr lang="en-US" dirty="0"/>
+              <a:t> </a:t>
+            </a:r>
+          </a:p>
+          <a:p>
+            <a:pPr lvl="0"/>
+            <a:r>
+              <a:rPr lang="en-US" dirty="0" err="1"/>
+              <a:t>sites_by_operator_commune</a:t>
+            </a:r>
+            <a:endParaRPr lang="en-US" dirty="0"/>
+          </a:p>
+          <a:p>
+            <a:endParaRPr lang="en-US" dirty="0"/>
           </a:p>
         </p:txBody>
       </p:sp>
     </p:spTree>
     <p:extLst>
       <p:ext uri="{BB962C8B-B14F-4D97-AF65-F5344CB8AC3E}">
-        <p14:creationId xmlns:p14="http://schemas.microsoft.com/office/powerpoint/2010/main" val="2331972277"/>
+        <p14:creationId xmlns:p14="http://schemas.microsoft.com/office/powerpoint/2010/main" val="3278610153"/>
       </p:ext>
     </p:extLst>
   </p:cSld>
@@ -6323,6 +8359,893 @@
           <p:cNvPr id="2" name="Title 1">
             <a:extLst>
               <a:ext uri="{FF2B5EF4-FFF2-40B4-BE49-F238E27FC236}">
+                <a16:creationId xmlns:a16="http://schemas.microsoft.com/office/drawing/2014/main" id="{A0C5ABC8-2335-3B64-7A14-0284B35729C5}"/>
+              </a:ext>
+            </a:extLst>
+          </p:cNvPr>
+          <p:cNvSpPr>
+            <a:spLocks noGrp="1"/>
+          </p:cNvSpPr>
+          <p:nvPr>
+            <p:ph type="title"/>
+          </p:nvPr>
+        </p:nvSpPr>
+        <p:spPr>
+          <a:xfrm>
+            <a:off x="646111" y="452718"/>
+            <a:ext cx="9404723" cy="866927"/>
+          </a:xfrm>
+        </p:spPr>
+        <p:txBody>
+          <a:bodyPr/>
+          <a:lstStyle/>
+          <a:p>
+            <a:r>
+              <a:rPr lang="en-US" dirty="0"/>
+              <a:t>MySQL relational database</a:t>
+            </a:r>
+          </a:p>
+        </p:txBody>
+      </p:sp>
+      <p:sp>
+        <p:nvSpPr>
+          <p:cNvPr id="3" name="Content Placeholder 2">
+            <a:extLst>
+              <a:ext uri="{FF2B5EF4-FFF2-40B4-BE49-F238E27FC236}">
+                <a16:creationId xmlns:a16="http://schemas.microsoft.com/office/drawing/2014/main" id="{22ACA1CC-90A2-D12D-63F3-6152A1836822}"/>
+              </a:ext>
+            </a:extLst>
+          </p:cNvPr>
+          <p:cNvSpPr>
+            <a:spLocks noGrp="1"/>
+          </p:cNvSpPr>
+          <p:nvPr>
+            <p:ph idx="1"/>
+          </p:nvPr>
+        </p:nvSpPr>
+        <p:spPr>
+          <a:xfrm>
+            <a:off x="1104293" y="4380482"/>
+            <a:ext cx="8946541" cy="2113837"/>
+          </a:xfrm>
+        </p:spPr>
+        <p:txBody>
+          <a:bodyPr/>
+          <a:lstStyle/>
+          <a:p>
+            <a:pPr lvl="0"/>
+            <a:r>
+              <a:rPr lang="en-US" dirty="0"/>
+              <a:t>Denormalized </a:t>
+            </a:r>
+            <a:r>
+              <a:rPr lang="en-US" dirty="0" err="1"/>
+              <a:t>qos_denormalized</a:t>
+            </a:r>
+            <a:r>
+              <a:rPr lang="en-US" dirty="0"/>
+              <a:t> </a:t>
+            </a:r>
+          </a:p>
+          <a:p>
+            <a:pPr lvl="0"/>
+            <a:r>
+              <a:rPr lang="en-US" dirty="0"/>
+              <a:t>317,998 measurements </a:t>
+            </a:r>
+          </a:p>
+          <a:p>
+            <a:pPr lvl="0"/>
+            <a:r>
+              <a:rPr lang="en-US" dirty="0"/>
+              <a:t>partitioned by </a:t>
+            </a:r>
+            <a:r>
+              <a:rPr lang="en-US" dirty="0" err="1"/>
+              <a:t>date_start</a:t>
+            </a:r>
+            <a:r>
+              <a:rPr lang="en-US" dirty="0"/>
+              <a:t> </a:t>
+            </a:r>
+          </a:p>
+          <a:p>
+            <a:pPr lvl="0"/>
+            <a:r>
+              <a:rPr lang="en-US" dirty="0"/>
+              <a:t>clustered by operator/protocol/department/commune</a:t>
+            </a:r>
+          </a:p>
+          <a:p>
+            <a:endParaRPr lang="en-US" dirty="0"/>
+          </a:p>
+        </p:txBody>
+      </p:sp>
+      <p:sp>
+        <p:nvSpPr>
+          <p:cNvPr id="4" name="Content Placeholder 2">
+            <a:extLst>
+              <a:ext uri="{FF2B5EF4-FFF2-40B4-BE49-F238E27FC236}">
+                <a16:creationId xmlns:a16="http://schemas.microsoft.com/office/drawing/2014/main" id="{E3C0066E-E482-FAEE-D85C-458863FB650D}"/>
+              </a:ext>
+            </a:extLst>
+          </p:cNvPr>
+          <p:cNvSpPr txBox="1">
+            <a:spLocks/>
+          </p:cNvSpPr>
+          <p:nvPr/>
+        </p:nvSpPr>
+        <p:spPr>
+          <a:xfrm>
+            <a:off x="1104292" y="1976720"/>
+            <a:ext cx="8946541" cy="1826354"/>
+          </a:xfrm>
+          <a:prstGeom prst="rect">
+            <a:avLst/>
+          </a:prstGeom>
+        </p:spPr>
+        <p:txBody>
+          <a:bodyPr vert="horz" lIns="91440" tIns="45720" rIns="91440" bIns="45720" rtlCol="0">
+            <a:normAutofit/>
+          </a:bodyPr>
+          <a:lstStyle>
+            <a:lvl1pPr marL="342900" indent="-342900" algn="l" defTabSz="457200" rtl="0" eaLnBrk="1" latinLnBrk="0" hangingPunct="1">
+              <a:spcBef>
+                <a:spcPts val="1000"/>
+              </a:spcBef>
+              <a:spcAft>
+                <a:spcPts val="0"/>
+              </a:spcAft>
+              <a:buClr>
+                <a:schemeClr val="accent1"/>
+              </a:buClr>
+              <a:buSzPct val="80000"/>
+              <a:buFont typeface="Wingdings 3" charset="2"/>
+              <a:buChar char=""/>
+              <a:defRPr sz="2000" b="0" i="0" kern="1200">
+                <a:solidFill>
+                  <a:schemeClr val="tx1"/>
+                </a:solidFill>
+                <a:latin typeface="+mj-lt"/>
+                <a:ea typeface="+mj-ea"/>
+                <a:cs typeface="+mj-cs"/>
+              </a:defRPr>
+            </a:lvl1pPr>
+            <a:lvl2pPr marL="742950" indent="-285750" algn="l" defTabSz="457200" rtl="0" eaLnBrk="1" latinLnBrk="0" hangingPunct="1">
+              <a:spcBef>
+                <a:spcPts val="1000"/>
+              </a:spcBef>
+              <a:spcAft>
+                <a:spcPts val="0"/>
+              </a:spcAft>
+              <a:buClr>
+                <a:schemeClr val="accent1"/>
+              </a:buClr>
+              <a:buSzPct val="80000"/>
+              <a:buFont typeface="Wingdings 3" charset="2"/>
+              <a:buChar char=""/>
+              <a:defRPr sz="1800" b="0" i="0" kern="1200">
+                <a:solidFill>
+                  <a:schemeClr val="tx1"/>
+                </a:solidFill>
+                <a:latin typeface="+mj-lt"/>
+                <a:ea typeface="+mj-ea"/>
+                <a:cs typeface="+mj-cs"/>
+              </a:defRPr>
+            </a:lvl2pPr>
+            <a:lvl3pPr marL="1143000" indent="-228600" algn="l" defTabSz="457200" rtl="0" eaLnBrk="1" latinLnBrk="0" hangingPunct="1">
+              <a:spcBef>
+                <a:spcPts val="1000"/>
+              </a:spcBef>
+              <a:spcAft>
+                <a:spcPts val="0"/>
+              </a:spcAft>
+              <a:buClr>
+                <a:schemeClr val="accent1"/>
+              </a:buClr>
+              <a:buSzPct val="80000"/>
+              <a:buFont typeface="Wingdings 3" charset="2"/>
+              <a:buChar char=""/>
+              <a:defRPr sz="1600" b="0" i="0" kern="1200">
+                <a:solidFill>
+                  <a:schemeClr val="tx1"/>
+                </a:solidFill>
+                <a:latin typeface="+mj-lt"/>
+                <a:ea typeface="+mj-ea"/>
+                <a:cs typeface="+mj-cs"/>
+              </a:defRPr>
+            </a:lvl3pPr>
+            <a:lvl4pPr marL="1600200" indent="-228600" algn="l" defTabSz="457200" rtl="0" eaLnBrk="1" latinLnBrk="0" hangingPunct="1">
+              <a:spcBef>
+                <a:spcPts val="1000"/>
+              </a:spcBef>
+              <a:spcAft>
+                <a:spcPts val="0"/>
+              </a:spcAft>
+              <a:buClr>
+                <a:schemeClr val="accent1"/>
+              </a:buClr>
+              <a:buSzPct val="80000"/>
+              <a:buFont typeface="Wingdings 3" charset="2"/>
+              <a:buChar char=""/>
+              <a:defRPr sz="1400" b="0" i="0" kern="1200">
+                <a:solidFill>
+                  <a:schemeClr val="tx1"/>
+                </a:solidFill>
+                <a:latin typeface="+mj-lt"/>
+                <a:ea typeface="+mj-ea"/>
+                <a:cs typeface="+mj-cs"/>
+              </a:defRPr>
+            </a:lvl4pPr>
+            <a:lvl5pPr marL="2057400" indent="-228600" algn="l" defTabSz="457200" rtl="0" eaLnBrk="1" latinLnBrk="0" hangingPunct="1">
+              <a:spcBef>
+                <a:spcPts val="1000"/>
+              </a:spcBef>
+              <a:spcAft>
+                <a:spcPts val="0"/>
+              </a:spcAft>
+              <a:buClr>
+                <a:schemeClr val="accent1"/>
+              </a:buClr>
+              <a:buSzPct val="80000"/>
+              <a:buFont typeface="Wingdings 3" charset="2"/>
+              <a:buChar char=""/>
+              <a:defRPr sz="1400" b="0" i="0" kern="1200">
+                <a:solidFill>
+                  <a:schemeClr val="tx1"/>
+                </a:solidFill>
+                <a:latin typeface="+mj-lt"/>
+                <a:ea typeface="+mj-ea"/>
+                <a:cs typeface="+mj-cs"/>
+              </a:defRPr>
+            </a:lvl5pPr>
+            <a:lvl6pPr marL="2514600" indent="-228600" algn="l" defTabSz="457200" rtl="0" eaLnBrk="1" latinLnBrk="0" hangingPunct="1">
+              <a:spcBef>
+                <a:spcPts val="1000"/>
+              </a:spcBef>
+              <a:spcAft>
+                <a:spcPts val="0"/>
+              </a:spcAft>
+              <a:buClr>
+                <a:schemeClr val="accent1"/>
+              </a:buClr>
+              <a:buSzPct val="80000"/>
+              <a:buFont typeface="Wingdings 3" charset="2"/>
+              <a:buChar char=""/>
+              <a:defRPr sz="1400" b="0" i="0" kern="1200">
+                <a:solidFill>
+                  <a:schemeClr val="tx1"/>
+                </a:solidFill>
+                <a:latin typeface="+mj-lt"/>
+                <a:ea typeface="+mj-ea"/>
+                <a:cs typeface="+mj-cs"/>
+              </a:defRPr>
+            </a:lvl6pPr>
+            <a:lvl7pPr marL="2971800" indent="-228600" algn="l" defTabSz="457200" rtl="0" eaLnBrk="1" latinLnBrk="0" hangingPunct="1">
+              <a:spcBef>
+                <a:spcPts val="1000"/>
+              </a:spcBef>
+              <a:spcAft>
+                <a:spcPts val="0"/>
+              </a:spcAft>
+              <a:buClr>
+                <a:schemeClr val="accent1"/>
+              </a:buClr>
+              <a:buSzPct val="80000"/>
+              <a:buFont typeface="Wingdings 3" charset="2"/>
+              <a:buChar char=""/>
+              <a:defRPr sz="1400" b="0" i="0" kern="1200">
+                <a:solidFill>
+                  <a:schemeClr val="tx1"/>
+                </a:solidFill>
+                <a:latin typeface="+mj-lt"/>
+                <a:ea typeface="+mj-ea"/>
+                <a:cs typeface="+mj-cs"/>
+              </a:defRPr>
+            </a:lvl7pPr>
+            <a:lvl8pPr marL="3429000" indent="-228600" algn="l" defTabSz="457200" rtl="0" eaLnBrk="1" latinLnBrk="0" hangingPunct="1">
+              <a:spcBef>
+                <a:spcPts val="1000"/>
+              </a:spcBef>
+              <a:spcAft>
+                <a:spcPts val="0"/>
+              </a:spcAft>
+              <a:buClr>
+                <a:schemeClr val="accent1"/>
+              </a:buClr>
+              <a:buSzPct val="80000"/>
+              <a:buFont typeface="Wingdings 3" charset="2"/>
+              <a:buChar char=""/>
+              <a:defRPr sz="1400" b="0" i="0" kern="1200">
+                <a:solidFill>
+                  <a:schemeClr val="tx1"/>
+                </a:solidFill>
+                <a:latin typeface="+mj-lt"/>
+                <a:ea typeface="+mj-ea"/>
+                <a:cs typeface="+mj-cs"/>
+              </a:defRPr>
+            </a:lvl8pPr>
+            <a:lvl9pPr marL="3886200" indent="-228600" algn="l" defTabSz="457200" rtl="0" eaLnBrk="1" latinLnBrk="0" hangingPunct="1">
+              <a:spcBef>
+                <a:spcPts val="1000"/>
+              </a:spcBef>
+              <a:spcAft>
+                <a:spcPts val="0"/>
+              </a:spcAft>
+              <a:buClr>
+                <a:schemeClr val="accent1"/>
+              </a:buClr>
+              <a:buSzPct val="80000"/>
+              <a:buFont typeface="Wingdings 3" charset="2"/>
+              <a:buChar char=""/>
+              <a:defRPr sz="1400" b="0" i="0" kern="1200">
+                <a:solidFill>
+                  <a:schemeClr val="tx1"/>
+                </a:solidFill>
+                <a:latin typeface="+mj-lt"/>
+                <a:ea typeface="+mj-ea"/>
+                <a:cs typeface="+mj-cs"/>
+              </a:defRPr>
+            </a:lvl9pPr>
+          </a:lstStyle>
+          <a:p>
+            <a:pPr lvl="0"/>
+            <a:r>
+              <a:rPr lang="en-US" dirty="0"/>
+              <a:t>PK/FK structure </a:t>
+            </a:r>
+          </a:p>
+          <a:p>
+            <a:pPr lvl="0"/>
+            <a:r>
+              <a:rPr lang="en-US" dirty="0"/>
+              <a:t>joins </a:t>
+            </a:r>
+          </a:p>
+          <a:p>
+            <a:pPr lvl="0"/>
+            <a:r>
+              <a:rPr lang="en-US" dirty="0"/>
+              <a:t>site aggregation to avoid measurement duplication </a:t>
+            </a:r>
+          </a:p>
+          <a:p>
+            <a:pPr lvl="0"/>
+            <a:r>
+              <a:rPr lang="en-US" dirty="0"/>
+              <a:t>final relational model</a:t>
+            </a:r>
+          </a:p>
+          <a:p>
+            <a:endParaRPr lang="en-US" dirty="0"/>
+          </a:p>
+        </p:txBody>
+      </p:sp>
+      <p:sp>
+        <p:nvSpPr>
+          <p:cNvPr id="5" name="Title 1">
+            <a:extLst>
+              <a:ext uri="{FF2B5EF4-FFF2-40B4-BE49-F238E27FC236}">
+                <a16:creationId xmlns:a16="http://schemas.microsoft.com/office/drawing/2014/main" id="{627F50F5-391D-8999-BC49-91CF0CA21C8B}"/>
+              </a:ext>
+            </a:extLst>
+          </p:cNvPr>
+          <p:cNvSpPr txBox="1">
+            <a:spLocks/>
+          </p:cNvSpPr>
+          <p:nvPr/>
+        </p:nvSpPr>
+        <p:spPr>
+          <a:xfrm>
+            <a:off x="995938" y="1319645"/>
+            <a:ext cx="5010007" cy="657075"/>
+          </a:xfrm>
+          <a:prstGeom prst="rect">
+            <a:avLst/>
+          </a:prstGeom>
+        </p:spPr>
+        <p:txBody>
+          <a:bodyPr vert="horz" lIns="91440" tIns="45720" rIns="91440" bIns="45720" rtlCol="0" anchor="t">
+            <a:noAutofit/>
+          </a:bodyPr>
+          <a:lstStyle>
+            <a:lvl1pPr algn="l" defTabSz="457200" rtl="0" eaLnBrk="1" latinLnBrk="0" hangingPunct="1">
+              <a:spcBef>
+                <a:spcPct val="0"/>
+              </a:spcBef>
+              <a:buNone/>
+              <a:defRPr sz="4200" b="0" i="0" kern="1200">
+                <a:solidFill>
+                  <a:schemeClr val="tx2"/>
+                </a:solidFill>
+                <a:latin typeface="+mj-lt"/>
+                <a:ea typeface="+mj-ea"/>
+                <a:cs typeface="+mj-cs"/>
+              </a:defRPr>
+            </a:lvl1pPr>
+            <a:lvl2pPr eaLnBrk="1" hangingPunct="1">
+              <a:defRPr>
+                <a:solidFill>
+                  <a:schemeClr val="tx2"/>
+                </a:solidFill>
+              </a:defRPr>
+            </a:lvl2pPr>
+            <a:lvl3pPr eaLnBrk="1" hangingPunct="1">
+              <a:defRPr>
+                <a:solidFill>
+                  <a:schemeClr val="tx2"/>
+                </a:solidFill>
+              </a:defRPr>
+            </a:lvl3pPr>
+            <a:lvl4pPr eaLnBrk="1" hangingPunct="1">
+              <a:defRPr>
+                <a:solidFill>
+                  <a:schemeClr val="tx2"/>
+                </a:solidFill>
+              </a:defRPr>
+            </a:lvl4pPr>
+            <a:lvl5pPr eaLnBrk="1" hangingPunct="1">
+              <a:defRPr>
+                <a:solidFill>
+                  <a:schemeClr val="tx2"/>
+                </a:solidFill>
+              </a:defRPr>
+            </a:lvl5pPr>
+            <a:lvl6pPr eaLnBrk="1" hangingPunct="1">
+              <a:defRPr>
+                <a:solidFill>
+                  <a:schemeClr val="tx2"/>
+                </a:solidFill>
+              </a:defRPr>
+            </a:lvl6pPr>
+            <a:lvl7pPr eaLnBrk="1" hangingPunct="1">
+              <a:defRPr>
+                <a:solidFill>
+                  <a:schemeClr val="tx2"/>
+                </a:solidFill>
+              </a:defRPr>
+            </a:lvl7pPr>
+            <a:lvl8pPr eaLnBrk="1" hangingPunct="1">
+              <a:defRPr>
+                <a:solidFill>
+                  <a:schemeClr val="tx2"/>
+                </a:solidFill>
+              </a:defRPr>
+            </a:lvl8pPr>
+            <a:lvl9pPr eaLnBrk="1" hangingPunct="1">
+              <a:defRPr>
+                <a:solidFill>
+                  <a:schemeClr val="tx2"/>
+                </a:solidFill>
+              </a:defRPr>
+            </a:lvl9pPr>
+          </a:lstStyle>
+          <a:p>
+            <a:r>
+              <a:rPr lang="en-US" sz="2800" b="1" dirty="0"/>
+              <a:t>MySQL relational database</a:t>
+            </a:r>
+          </a:p>
+        </p:txBody>
+      </p:sp>
+      <p:sp>
+        <p:nvSpPr>
+          <p:cNvPr id="7" name="Title 1">
+            <a:extLst>
+              <a:ext uri="{FF2B5EF4-FFF2-40B4-BE49-F238E27FC236}">
+                <a16:creationId xmlns:a16="http://schemas.microsoft.com/office/drawing/2014/main" id="{17E9B05E-D49B-0142-D59E-2762A6C2E606}"/>
+              </a:ext>
+            </a:extLst>
+          </p:cNvPr>
+          <p:cNvSpPr txBox="1">
+            <a:spLocks/>
+          </p:cNvSpPr>
+          <p:nvPr/>
+        </p:nvSpPr>
+        <p:spPr>
+          <a:xfrm>
+            <a:off x="1104292" y="3882736"/>
+            <a:ext cx="5010007" cy="657075"/>
+          </a:xfrm>
+          <a:prstGeom prst="rect">
+            <a:avLst/>
+          </a:prstGeom>
+        </p:spPr>
+        <p:txBody>
+          <a:bodyPr vert="horz" lIns="91440" tIns="45720" rIns="91440" bIns="45720" rtlCol="0" anchor="t">
+            <a:noAutofit/>
+          </a:bodyPr>
+          <a:lstStyle>
+            <a:lvl1pPr algn="l" defTabSz="457200" rtl="0" eaLnBrk="1" latinLnBrk="0" hangingPunct="1">
+              <a:spcBef>
+                <a:spcPct val="0"/>
+              </a:spcBef>
+              <a:buNone/>
+              <a:defRPr sz="4200" b="0" i="0" kern="1200">
+                <a:solidFill>
+                  <a:schemeClr val="tx2"/>
+                </a:solidFill>
+                <a:latin typeface="+mj-lt"/>
+                <a:ea typeface="+mj-ea"/>
+                <a:cs typeface="+mj-cs"/>
+              </a:defRPr>
+            </a:lvl1pPr>
+            <a:lvl2pPr eaLnBrk="1" hangingPunct="1">
+              <a:defRPr>
+                <a:solidFill>
+                  <a:schemeClr val="tx2"/>
+                </a:solidFill>
+              </a:defRPr>
+            </a:lvl2pPr>
+            <a:lvl3pPr eaLnBrk="1" hangingPunct="1">
+              <a:defRPr>
+                <a:solidFill>
+                  <a:schemeClr val="tx2"/>
+                </a:solidFill>
+              </a:defRPr>
+            </a:lvl3pPr>
+            <a:lvl4pPr eaLnBrk="1" hangingPunct="1">
+              <a:defRPr>
+                <a:solidFill>
+                  <a:schemeClr val="tx2"/>
+                </a:solidFill>
+              </a:defRPr>
+            </a:lvl4pPr>
+            <a:lvl5pPr eaLnBrk="1" hangingPunct="1">
+              <a:defRPr>
+                <a:solidFill>
+                  <a:schemeClr val="tx2"/>
+                </a:solidFill>
+              </a:defRPr>
+            </a:lvl5pPr>
+            <a:lvl6pPr eaLnBrk="1" hangingPunct="1">
+              <a:defRPr>
+                <a:solidFill>
+                  <a:schemeClr val="tx2"/>
+                </a:solidFill>
+              </a:defRPr>
+            </a:lvl6pPr>
+            <a:lvl7pPr eaLnBrk="1" hangingPunct="1">
+              <a:defRPr>
+                <a:solidFill>
+                  <a:schemeClr val="tx2"/>
+                </a:solidFill>
+              </a:defRPr>
+            </a:lvl7pPr>
+            <a:lvl8pPr eaLnBrk="1" hangingPunct="1">
+              <a:defRPr>
+                <a:solidFill>
+                  <a:schemeClr val="tx2"/>
+                </a:solidFill>
+              </a:defRPr>
+            </a:lvl8pPr>
+            <a:lvl9pPr eaLnBrk="1" hangingPunct="1">
+              <a:defRPr>
+                <a:solidFill>
+                  <a:schemeClr val="tx2"/>
+                </a:solidFill>
+              </a:defRPr>
+            </a:lvl9pPr>
+          </a:lstStyle>
+          <a:p>
+            <a:r>
+              <a:rPr lang="en-US" sz="2800" b="1" dirty="0" err="1"/>
+              <a:t>BigQuery</a:t>
+            </a:r>
+            <a:endParaRPr lang="en-US" sz="2800" b="1" dirty="0"/>
+          </a:p>
+        </p:txBody>
+      </p:sp>
+    </p:spTree>
+    <p:extLst>
+      <p:ext uri="{BB962C8B-B14F-4D97-AF65-F5344CB8AC3E}">
+        <p14:creationId xmlns:p14="http://schemas.microsoft.com/office/powerpoint/2010/main" val="3123621724"/>
+      </p:ext>
+    </p:extLst>
+  </p:cSld>
+  <p:clrMapOvr>
+    <a:masterClrMapping/>
+  </p:clrMapOvr>
+</p:sld>
+</file>
+
+<file path=ppt/slides/slide4.xml><?xml version="1.0" encoding="utf-8"?>
+<p:sld xmlns:a="http://schemas.openxmlformats.org/drawingml/2006/main" xmlns:r="http://schemas.openxmlformats.org/officeDocument/2006/relationships" xmlns:p="http://schemas.openxmlformats.org/presentationml/2006/main">
+  <p:cSld>
+    <p:spTree>
+      <p:nvGrpSpPr>
+        <p:cNvPr id="1" name=""/>
+        <p:cNvGrpSpPr/>
+        <p:nvPr/>
+      </p:nvGrpSpPr>
+      <p:grpSpPr>
+        <a:xfrm>
+          <a:off x="0" y="0"/>
+          <a:ext cx="0" cy="0"/>
+          <a:chOff x="0" y="0"/>
+          <a:chExt cx="0" cy="0"/>
+        </a:xfrm>
+      </p:grpSpPr>
+      <p:sp>
+        <p:nvSpPr>
+          <p:cNvPr id="2" name="Title 1">
+            <a:extLst>
+              <a:ext uri="{FF2B5EF4-FFF2-40B4-BE49-F238E27FC236}">
+                <a16:creationId xmlns:a16="http://schemas.microsoft.com/office/drawing/2014/main" id="{BB5B018D-710E-0EF3-AA19-31E6A1073E20}"/>
+              </a:ext>
+            </a:extLst>
+          </p:cNvPr>
+          <p:cNvSpPr>
+            <a:spLocks noGrp="1"/>
+          </p:cNvSpPr>
+          <p:nvPr>
+            <p:ph type="title"/>
+          </p:nvPr>
+        </p:nvSpPr>
+        <p:spPr/>
+        <p:txBody>
+          <a:bodyPr/>
+          <a:lstStyle/>
+          <a:p>
+            <a:r>
+              <a:rPr lang="en-US" dirty="0"/>
+              <a:t>EDA / Analytics</a:t>
+            </a:r>
+          </a:p>
+        </p:txBody>
+      </p:sp>
+      <p:sp>
+        <p:nvSpPr>
+          <p:cNvPr id="3" name="Content Placeholder 2">
+            <a:extLst>
+              <a:ext uri="{FF2B5EF4-FFF2-40B4-BE49-F238E27FC236}">
+                <a16:creationId xmlns:a16="http://schemas.microsoft.com/office/drawing/2014/main" id="{CB7BE66B-8FD3-3B9D-556F-EF475C22E273}"/>
+              </a:ext>
+            </a:extLst>
+          </p:cNvPr>
+          <p:cNvSpPr>
+            <a:spLocks noGrp="1"/>
+          </p:cNvSpPr>
+          <p:nvPr>
+            <p:ph idx="1"/>
+          </p:nvPr>
+        </p:nvSpPr>
+        <p:spPr/>
+        <p:txBody>
+          <a:bodyPr/>
+          <a:lstStyle/>
+          <a:p>
+            <a:r>
+              <a:rPr lang="en-US" dirty="0"/>
+              <a:t>Dataset overview:</a:t>
+            </a:r>
+          </a:p>
+          <a:p>
+            <a:endParaRPr lang="en-US" dirty="0"/>
+          </a:p>
+          <a:p>
+            <a:endParaRPr lang="en-US" dirty="0"/>
+          </a:p>
+          <a:p>
+            <a:r>
+              <a:rPr lang="en-US" dirty="0"/>
+              <a:t>Measurement distribution:</a:t>
+            </a:r>
+          </a:p>
+          <a:p>
+            <a:endParaRPr lang="en-US" dirty="0"/>
+          </a:p>
+          <a:p>
+            <a:endParaRPr lang="en-US" dirty="0"/>
+          </a:p>
+          <a:p>
+            <a:r>
+              <a:rPr lang="en-US" dirty="0"/>
+              <a:t>Radio conditions — operator/environment</a:t>
+            </a:r>
+          </a:p>
+          <a:p>
+            <a:endParaRPr lang="en-US" dirty="0"/>
+          </a:p>
+          <a:p>
+            <a:endParaRPr lang="en-US" dirty="0"/>
+          </a:p>
+          <a:p>
+            <a:endParaRPr lang="en-US" dirty="0"/>
+          </a:p>
+        </p:txBody>
+      </p:sp>
+    </p:spTree>
+    <p:extLst>
+      <p:ext uri="{BB962C8B-B14F-4D97-AF65-F5344CB8AC3E}">
+        <p14:creationId xmlns:p14="http://schemas.microsoft.com/office/powerpoint/2010/main" val="1038995095"/>
+      </p:ext>
+    </p:extLst>
+  </p:cSld>
+  <p:clrMapOvr>
+    <a:masterClrMapping/>
+  </p:clrMapOvr>
+</p:sld>
+</file>
+
+<file path=ppt/slides/slide5.xml><?xml version="1.0" encoding="utf-8"?>
+<p:sld xmlns:a="http://schemas.openxmlformats.org/drawingml/2006/main" xmlns:r="http://schemas.openxmlformats.org/officeDocument/2006/relationships" xmlns:p="http://schemas.openxmlformats.org/presentationml/2006/main">
+  <p:cSld>
+    <p:spTree>
+      <p:nvGrpSpPr>
+        <p:cNvPr id="1" name=""/>
+        <p:cNvGrpSpPr/>
+        <p:nvPr/>
+      </p:nvGrpSpPr>
+      <p:grpSpPr>
+        <a:xfrm>
+          <a:off x="0" y="0"/>
+          <a:ext cx="0" cy="0"/>
+          <a:chOff x="0" y="0"/>
+          <a:chExt cx="0" cy="0"/>
+        </a:xfrm>
+      </p:grpSpPr>
+      <p:sp>
+        <p:nvSpPr>
+          <p:cNvPr id="2" name="Title 1">
+            <a:extLst>
+              <a:ext uri="{FF2B5EF4-FFF2-40B4-BE49-F238E27FC236}">
+                <a16:creationId xmlns:a16="http://schemas.microsoft.com/office/drawing/2014/main" id="{09897808-0148-A72C-9BE3-74E4E592A827}"/>
+              </a:ext>
+            </a:extLst>
+          </p:cNvPr>
+          <p:cNvSpPr>
+            <a:spLocks noGrp="1"/>
+          </p:cNvSpPr>
+          <p:nvPr>
+            <p:ph type="title"/>
+          </p:nvPr>
+        </p:nvSpPr>
+        <p:spPr/>
+        <p:txBody>
+          <a:bodyPr/>
+          <a:lstStyle/>
+          <a:p>
+            <a:r>
+              <a:rPr lang="fr-FR" dirty="0"/>
+              <a:t>Radio conditions</a:t>
+            </a:r>
+            <a:endParaRPr lang="en-US" dirty="0"/>
+          </a:p>
+        </p:txBody>
+      </p:sp>
+      <p:pic>
+        <p:nvPicPr>
+          <p:cNvPr id="7" name="Content Placeholder 6">
+            <a:extLst>
+              <a:ext uri="{FF2B5EF4-FFF2-40B4-BE49-F238E27FC236}">
+                <a16:creationId xmlns:a16="http://schemas.microsoft.com/office/drawing/2014/main" id="{463227D7-241F-1476-612F-179456F0DBF6}"/>
+              </a:ext>
+            </a:extLst>
+          </p:cNvPr>
+          <p:cNvPicPr>
+            <a:picLocks noGrp="1" noChangeAspect="1"/>
+          </p:cNvPicPr>
+          <p:nvPr>
+            <p:ph idx="1"/>
+          </p:nvPr>
+        </p:nvPicPr>
+        <p:blipFill>
+          <a:blip r:embed="rId2"/>
+          <a:stretch>
+            <a:fillRect/>
+          </a:stretch>
+        </p:blipFill>
+        <p:spPr>
+          <a:xfrm>
+            <a:off x="646111" y="2091559"/>
+            <a:ext cx="3919397" cy="3388893"/>
+          </a:xfrm>
+          <a:prstGeom prst="rect">
+            <a:avLst/>
+          </a:prstGeom>
+        </p:spPr>
+      </p:pic>
+      <p:pic>
+        <p:nvPicPr>
+          <p:cNvPr id="9" name="Picture 8">
+            <a:extLst>
+              <a:ext uri="{FF2B5EF4-FFF2-40B4-BE49-F238E27FC236}">
+                <a16:creationId xmlns:a16="http://schemas.microsoft.com/office/drawing/2014/main" id="{9FCA8801-8E79-78B8-6E91-9A8C7E8B1083}"/>
+              </a:ext>
+            </a:extLst>
+          </p:cNvPr>
+          <p:cNvPicPr>
+            <a:picLocks noChangeAspect="1"/>
+          </p:cNvPicPr>
+          <p:nvPr/>
+        </p:nvPicPr>
+        <p:blipFill>
+          <a:blip r:embed="rId3"/>
+          <a:stretch>
+            <a:fillRect/>
+          </a:stretch>
+        </p:blipFill>
+        <p:spPr>
+          <a:xfrm>
+            <a:off x="4971393" y="2119854"/>
+            <a:ext cx="4174998" cy="3346312"/>
+          </a:xfrm>
+          <a:prstGeom prst="rect">
+            <a:avLst/>
+          </a:prstGeom>
+        </p:spPr>
+      </p:pic>
+      <p:sp>
+        <p:nvSpPr>
+          <p:cNvPr id="10" name="TextBox 9">
+            <a:extLst>
+              <a:ext uri="{FF2B5EF4-FFF2-40B4-BE49-F238E27FC236}">
+                <a16:creationId xmlns:a16="http://schemas.microsoft.com/office/drawing/2014/main" id="{1C9009A3-A992-8272-8340-DBAB73D7036C}"/>
+              </a:ext>
+            </a:extLst>
+          </p:cNvPr>
+          <p:cNvSpPr txBox="1"/>
+          <p:nvPr/>
+        </p:nvSpPr>
+        <p:spPr>
+          <a:xfrm>
+            <a:off x="1072055" y="5752433"/>
+            <a:ext cx="8366235" cy="923330"/>
+          </a:xfrm>
+          <a:prstGeom prst="rect">
+            <a:avLst/>
+          </a:prstGeom>
+          <a:noFill/>
+        </p:spPr>
+        <p:txBody>
+          <a:bodyPr wrap="square" rtlCol="0">
+            <a:spAutoFit/>
+          </a:bodyPr>
+          <a:lstStyle/>
+          <a:p>
+            <a:r>
+              <a:rPr lang="en-US" dirty="0"/>
+              <a:t>Orange and SFR show stronger signal levels, while Orange also provides the best radio quality (RSRQ). Free Mobile records the weakest RSRP across all environments.</a:t>
+            </a:r>
+          </a:p>
+        </p:txBody>
+      </p:sp>
+    </p:spTree>
+    <p:extLst>
+      <p:ext uri="{BB962C8B-B14F-4D97-AF65-F5344CB8AC3E}">
+        <p14:creationId xmlns:p14="http://schemas.microsoft.com/office/powerpoint/2010/main" val="2331972277"/>
+      </p:ext>
+    </p:extLst>
+  </p:cSld>
+  <p:clrMapOvr>
+    <a:masterClrMapping/>
+  </p:clrMapOvr>
+</p:sld>
+</file>
+
+<file path=ppt/slides/slide6.xml><?xml version="1.0" encoding="utf-8"?>
+<p:sld xmlns:a="http://schemas.openxmlformats.org/drawingml/2006/main" xmlns:r="http://schemas.openxmlformats.org/officeDocument/2006/relationships" xmlns:p="http://schemas.openxmlformats.org/presentationml/2006/main">
+  <p:cSld>
+    <p:spTree>
+      <p:nvGrpSpPr>
+        <p:cNvPr id="1" name=""/>
+        <p:cNvGrpSpPr/>
+        <p:nvPr/>
+      </p:nvGrpSpPr>
+      <p:grpSpPr>
+        <a:xfrm>
+          <a:off x="0" y="0"/>
+          <a:ext cx="0" cy="0"/>
+          <a:chOff x="0" y="0"/>
+          <a:chExt cx="0" cy="0"/>
+        </a:xfrm>
+      </p:grpSpPr>
+      <p:sp>
+        <p:nvSpPr>
+          <p:cNvPr id="2" name="Title 1">
+            <a:extLst>
+              <a:ext uri="{FF2B5EF4-FFF2-40B4-BE49-F238E27FC236}">
                 <a16:creationId xmlns:a16="http://schemas.microsoft.com/office/drawing/2014/main" id="{198A073D-DA10-1EF1-EDEC-253F1E9D0E75}"/>
               </a:ext>
             </a:extLst>
@@ -6339,7 +9262,10 @@
           <a:bodyPr/>
           <a:lstStyle/>
           <a:p>
-            <a:endParaRPr lang="en-US"/>
+            <a:r>
+              <a:rPr lang="en-US" dirty="0"/>
+              <a:t>territorial inequalities Analytics</a:t>
+            </a:r>
           </a:p>
         </p:txBody>
       </p:sp>
@@ -6364,7 +9290,37 @@
           <a:bodyPr/>
           <a:lstStyle/>
           <a:p>
-            <a:endParaRPr lang="en-US"/>
+            <a:r>
+              <a:rPr lang="en-US" dirty="0"/>
+              <a:t>Region × Operator → RSRP / RSRQ</a:t>
+            </a:r>
+          </a:p>
+          <a:p>
+            <a:endParaRPr lang="en-US" dirty="0"/>
+          </a:p>
+          <a:p>
+            <a:r>
+              <a:rPr lang="en-US" dirty="0"/>
+              <a:t>Region → service performance</a:t>
+            </a:r>
+          </a:p>
+          <a:p>
+            <a:endParaRPr lang="en-US" dirty="0"/>
+          </a:p>
+          <a:p>
+            <a:r>
+              <a:rPr lang="en-US" dirty="0"/>
+              <a:t>Region → infrastructure</a:t>
+            </a:r>
+          </a:p>
+          <a:p>
+            <a:endParaRPr lang="en-US" dirty="0"/>
+          </a:p>
+          <a:p>
+            <a:r>
+              <a:rPr lang="en-US" dirty="0"/>
+              <a:t>Infrastructure ↔ radio/performance</a:t>
+            </a:r>
           </a:p>
         </p:txBody>
       </p:sp>
@@ -6372,6 +9328,683 @@
     <p:extLst>
       <p:ext uri="{BB962C8B-B14F-4D97-AF65-F5344CB8AC3E}">
         <p14:creationId xmlns:p14="http://schemas.microsoft.com/office/powerpoint/2010/main" val="4189441495"/>
+      </p:ext>
+    </p:extLst>
+  </p:cSld>
+  <p:clrMapOvr>
+    <a:masterClrMapping/>
+  </p:clrMapOvr>
+</p:sld>
+</file>
+
+<file path=ppt/slides/slide7.xml><?xml version="1.0" encoding="utf-8"?>
+<p:sld xmlns:a="http://schemas.openxmlformats.org/drawingml/2006/main" xmlns:r="http://schemas.openxmlformats.org/officeDocument/2006/relationships" xmlns:p="http://schemas.openxmlformats.org/presentationml/2006/main">
+  <p:cSld>
+    <p:spTree>
+      <p:nvGrpSpPr>
+        <p:cNvPr id="1" name=""/>
+        <p:cNvGrpSpPr/>
+        <p:nvPr/>
+      </p:nvGrpSpPr>
+      <p:grpSpPr>
+        <a:xfrm>
+          <a:off x="0" y="0"/>
+          <a:ext cx="0" cy="0"/>
+          <a:chOff x="0" y="0"/>
+          <a:chExt cx="0" cy="0"/>
+        </a:xfrm>
+      </p:grpSpPr>
+      <p:sp>
+        <p:nvSpPr>
+          <p:cNvPr id="2" name="Title 1">
+            <a:extLst>
+              <a:ext uri="{FF2B5EF4-FFF2-40B4-BE49-F238E27FC236}">
+                <a16:creationId xmlns:a16="http://schemas.microsoft.com/office/drawing/2014/main" id="{A57295A0-9504-F229-B6AB-FDE37E1A06A8}"/>
+              </a:ext>
+            </a:extLst>
+          </p:cNvPr>
+          <p:cNvSpPr>
+            <a:spLocks noGrp="1"/>
+          </p:cNvSpPr>
+          <p:nvPr>
+            <p:ph type="title"/>
+          </p:nvPr>
+        </p:nvSpPr>
+        <p:spPr/>
+        <p:txBody>
+          <a:bodyPr/>
+          <a:lstStyle/>
+          <a:p>
+            <a:r>
+              <a:rPr lang="en-US" dirty="0"/>
+              <a:t>Territorial radio conditions:</a:t>
+            </a:r>
+            <a:br>
+              <a:rPr lang="en-US" dirty="0"/>
+            </a:br>
+            <a:r>
+              <a:rPr lang="en-US" sz="2800" dirty="0"/>
+              <a:t> Region × Operator → RSRP / RSRQ</a:t>
+            </a:r>
+            <a:br>
+              <a:rPr lang="en-US" dirty="0"/>
+            </a:br>
+            <a:br>
+              <a:rPr lang="en-US" dirty="0"/>
+            </a:br>
+            <a:endParaRPr lang="en-US" dirty="0"/>
+          </a:p>
+        </p:txBody>
+      </p:sp>
+      <p:pic>
+        <p:nvPicPr>
+          <p:cNvPr id="7" name="Content Placeholder 6">
+            <a:extLst>
+              <a:ext uri="{FF2B5EF4-FFF2-40B4-BE49-F238E27FC236}">
+                <a16:creationId xmlns:a16="http://schemas.microsoft.com/office/drawing/2014/main" id="{71600BCD-DB07-6D9D-AAC4-2F13F518F397}"/>
+              </a:ext>
+            </a:extLst>
+          </p:cNvPr>
+          <p:cNvPicPr>
+            <a:picLocks noGrp="1" noChangeAspect="1"/>
+          </p:cNvPicPr>
+          <p:nvPr>
+            <p:ph idx="1"/>
+          </p:nvPr>
+        </p:nvPicPr>
+        <p:blipFill>
+          <a:blip r:embed="rId2"/>
+          <a:stretch>
+            <a:fillRect/>
+          </a:stretch>
+        </p:blipFill>
+        <p:spPr>
+          <a:xfrm>
+            <a:off x="6174214" y="3341389"/>
+            <a:ext cx="5559268" cy="2976282"/>
+          </a:xfrm>
+          <a:prstGeom prst="rect">
+            <a:avLst/>
+          </a:prstGeom>
+          <a:ln w="38100" cap="sq">
+            <a:solidFill>
+              <a:schemeClr val="bg2">
+                <a:lumMod val="60000"/>
+                <a:lumOff val="40000"/>
+              </a:schemeClr>
+            </a:solidFill>
+            <a:prstDash val="solid"/>
+            <a:miter lim="800000"/>
+          </a:ln>
+          <a:effectLst>
+            <a:outerShdw blurRad="50800" dist="38100" dir="2700000" algn="tl" rotWithShape="0">
+              <a:srgbClr val="000000">
+                <a:alpha val="43000"/>
+              </a:srgbClr>
+            </a:outerShdw>
+          </a:effectLst>
+        </p:spPr>
+      </p:pic>
+      <p:pic>
+        <p:nvPicPr>
+          <p:cNvPr id="9" name="Picture 8">
+            <a:extLst>
+              <a:ext uri="{FF2B5EF4-FFF2-40B4-BE49-F238E27FC236}">
+                <a16:creationId xmlns:a16="http://schemas.microsoft.com/office/drawing/2014/main" id="{E7E9C7BC-8132-7A5C-CE20-F24CE30DA32D}"/>
+              </a:ext>
+            </a:extLst>
+          </p:cNvPr>
+          <p:cNvPicPr>
+            <a:picLocks noChangeAspect="1"/>
+          </p:cNvPicPr>
+          <p:nvPr/>
+        </p:nvPicPr>
+        <p:blipFill>
+          <a:blip r:embed="rId3"/>
+          <a:stretch>
+            <a:fillRect/>
+          </a:stretch>
+        </p:blipFill>
+        <p:spPr>
+          <a:xfrm>
+            <a:off x="496301" y="3341388"/>
+            <a:ext cx="5559268" cy="3003283"/>
+          </a:xfrm>
+          <a:prstGeom prst="rect">
+            <a:avLst/>
+          </a:prstGeom>
+          <a:ln w="38100" cap="sq">
+            <a:solidFill>
+              <a:schemeClr val="bg2">
+                <a:lumMod val="60000"/>
+                <a:lumOff val="40000"/>
+              </a:schemeClr>
+            </a:solidFill>
+            <a:prstDash val="solid"/>
+            <a:miter lim="800000"/>
+          </a:ln>
+          <a:effectLst>
+            <a:outerShdw blurRad="50800" dist="38100" dir="2700000" algn="tl" rotWithShape="0">
+              <a:srgbClr val="000000">
+                <a:alpha val="43000"/>
+              </a:srgbClr>
+            </a:outerShdw>
+          </a:effectLst>
+        </p:spPr>
+      </p:pic>
+      <p:sp>
+        <p:nvSpPr>
+          <p:cNvPr id="10" name="TextBox 9">
+            <a:extLst>
+              <a:ext uri="{FF2B5EF4-FFF2-40B4-BE49-F238E27FC236}">
+                <a16:creationId xmlns:a16="http://schemas.microsoft.com/office/drawing/2014/main" id="{35F6159D-A103-5C84-7632-C6A6E8608760}"/>
+              </a:ext>
+            </a:extLst>
+          </p:cNvPr>
+          <p:cNvSpPr txBox="1"/>
+          <p:nvPr/>
+        </p:nvSpPr>
+        <p:spPr>
+          <a:xfrm>
+            <a:off x="496301" y="1735279"/>
+            <a:ext cx="11237181" cy="1200329"/>
+          </a:xfrm>
+          <a:prstGeom prst="rect">
+            <a:avLst/>
+          </a:prstGeom>
+          <a:noFill/>
+        </p:spPr>
+        <p:txBody>
+          <a:bodyPr wrap="square" rtlCol="0">
+            <a:spAutoFit/>
+          </a:bodyPr>
+          <a:lstStyle/>
+          <a:p>
+            <a:r>
+              <a:rPr lang="en-US" dirty="0"/>
+              <a:t>Territorial inequalities are observed for both signal strength (RSRP) and signal quality (RSRQ), but they do not affect operators in the same way. Bouygues Telecom shows the largest regional variation in RSRP, while SFR shows the largest variation in RSRQ. This indicates that territorial disparities depend on the radio performance dimension considered.</a:t>
+            </a:r>
+          </a:p>
+        </p:txBody>
+      </p:sp>
+    </p:spTree>
+    <p:extLst>
+      <p:ext uri="{BB962C8B-B14F-4D97-AF65-F5344CB8AC3E}">
+        <p14:creationId xmlns:p14="http://schemas.microsoft.com/office/powerpoint/2010/main" val="1465722108"/>
+      </p:ext>
+    </p:extLst>
+  </p:cSld>
+  <p:clrMapOvr>
+    <a:masterClrMapping/>
+  </p:clrMapOvr>
+</p:sld>
+</file>
+
+<file path=ppt/slides/slide8.xml><?xml version="1.0" encoding="utf-8"?>
+<p:sld xmlns:a="http://schemas.openxmlformats.org/drawingml/2006/main" xmlns:r="http://schemas.openxmlformats.org/officeDocument/2006/relationships" xmlns:p="http://schemas.openxmlformats.org/presentationml/2006/main">
+  <p:cSld>
+    <p:spTree>
+      <p:nvGrpSpPr>
+        <p:cNvPr id="1" name=""/>
+        <p:cNvGrpSpPr/>
+        <p:nvPr/>
+      </p:nvGrpSpPr>
+      <p:grpSpPr>
+        <a:xfrm>
+          <a:off x="0" y="0"/>
+          <a:ext cx="0" cy="0"/>
+          <a:chOff x="0" y="0"/>
+          <a:chExt cx="0" cy="0"/>
+        </a:xfrm>
+      </p:grpSpPr>
+      <p:sp>
+        <p:nvSpPr>
+          <p:cNvPr id="2" name="Title 1">
+            <a:extLst>
+              <a:ext uri="{FF2B5EF4-FFF2-40B4-BE49-F238E27FC236}">
+                <a16:creationId xmlns:a16="http://schemas.microsoft.com/office/drawing/2014/main" id="{42F6523C-4CB5-0AAD-C49E-F4811AAFFC2F}"/>
+              </a:ext>
+            </a:extLst>
+          </p:cNvPr>
+          <p:cNvSpPr>
+            <a:spLocks noGrp="1"/>
+          </p:cNvSpPr>
+          <p:nvPr>
+            <p:ph type="title"/>
+          </p:nvPr>
+        </p:nvSpPr>
+        <p:spPr/>
+        <p:txBody>
+          <a:bodyPr/>
+          <a:lstStyle/>
+          <a:p>
+            <a:r>
+              <a:rPr lang="en-US" dirty="0"/>
+              <a:t>Region → service performance</a:t>
+            </a:r>
+            <a:br>
+              <a:rPr lang="en-US" dirty="0"/>
+            </a:br>
+            <a:endParaRPr lang="en-US" dirty="0"/>
+          </a:p>
+        </p:txBody>
+      </p:sp>
+      <p:sp>
+        <p:nvSpPr>
+          <p:cNvPr id="3" name="Content Placeholder 2">
+            <a:extLst>
+              <a:ext uri="{FF2B5EF4-FFF2-40B4-BE49-F238E27FC236}">
+                <a16:creationId xmlns:a16="http://schemas.microsoft.com/office/drawing/2014/main" id="{165E9A46-AD78-CF29-D397-CF90BC060897}"/>
+              </a:ext>
+            </a:extLst>
+          </p:cNvPr>
+          <p:cNvSpPr>
+            <a:spLocks noGrp="1"/>
+          </p:cNvSpPr>
+          <p:nvPr>
+            <p:ph idx="1"/>
+          </p:nvPr>
+        </p:nvSpPr>
+        <p:spPr/>
+        <p:txBody>
+          <a:bodyPr/>
+          <a:lstStyle/>
+          <a:p>
+            <a:r>
+              <a:rPr lang="fr-FR" dirty="0"/>
+              <a:t>Paste </a:t>
+            </a:r>
+            <a:r>
+              <a:rPr lang="fr-FR" dirty="0" err="1"/>
+              <a:t>region</a:t>
+            </a:r>
+            <a:r>
+              <a:rPr lang="fr-FR" dirty="0"/>
+              <a:t>/</a:t>
+            </a:r>
+            <a:r>
+              <a:rPr lang="fr-FR" dirty="0" err="1"/>
+              <a:t>operators</a:t>
+            </a:r>
+            <a:r>
+              <a:rPr lang="fr-FR" dirty="0"/>
+              <a:t> </a:t>
+            </a:r>
+            <a:r>
+              <a:rPr lang="fr-FR" dirty="0" err="1"/>
+              <a:t>disparities</a:t>
+            </a:r>
+            <a:r>
+              <a:rPr lang="fr-FR" dirty="0"/>
+              <a:t> of WEB+DOWNLOAD+UPLOAD+STREAM</a:t>
+            </a:r>
+            <a:endParaRPr lang="en-US" dirty="0"/>
+          </a:p>
+        </p:txBody>
+      </p:sp>
+    </p:spTree>
+    <p:extLst>
+      <p:ext uri="{BB962C8B-B14F-4D97-AF65-F5344CB8AC3E}">
+        <p14:creationId xmlns:p14="http://schemas.microsoft.com/office/powerpoint/2010/main" val="346414049"/>
+      </p:ext>
+    </p:extLst>
+  </p:cSld>
+  <p:clrMapOvr>
+    <a:masterClrMapping/>
+  </p:clrMapOvr>
+</p:sld>
+</file>
+
+<file path=ppt/slides/slide9.xml><?xml version="1.0" encoding="utf-8"?>
+<p:sld xmlns:a="http://schemas.openxmlformats.org/drawingml/2006/main" xmlns:r="http://schemas.openxmlformats.org/officeDocument/2006/relationships" xmlns:p="http://schemas.openxmlformats.org/presentationml/2006/main">
+  <p:cSld>
+    <p:spTree>
+      <p:nvGrpSpPr>
+        <p:cNvPr id="1" name=""/>
+        <p:cNvGrpSpPr/>
+        <p:nvPr/>
+      </p:nvGrpSpPr>
+      <p:grpSpPr>
+        <a:xfrm>
+          <a:off x="0" y="0"/>
+          <a:ext cx="0" cy="0"/>
+          <a:chOff x="0" y="0"/>
+          <a:chExt cx="0" cy="0"/>
+        </a:xfrm>
+      </p:grpSpPr>
+      <p:sp>
+        <p:nvSpPr>
+          <p:cNvPr id="2" name="Title 1">
+            <a:extLst>
+              <a:ext uri="{FF2B5EF4-FFF2-40B4-BE49-F238E27FC236}">
+                <a16:creationId xmlns:a16="http://schemas.microsoft.com/office/drawing/2014/main" id="{9297C18A-3512-9941-A695-6B0B0C6BA7AF}"/>
+              </a:ext>
+            </a:extLst>
+          </p:cNvPr>
+          <p:cNvSpPr>
+            <a:spLocks noGrp="1"/>
+          </p:cNvSpPr>
+          <p:nvPr>
+            <p:ph type="title"/>
+          </p:nvPr>
+        </p:nvSpPr>
+        <p:spPr>
+          <a:xfrm>
+            <a:off x="646111" y="452718"/>
+            <a:ext cx="9404723" cy="763018"/>
+          </a:xfrm>
+        </p:spPr>
+        <p:txBody>
+          <a:bodyPr/>
+          <a:lstStyle/>
+          <a:p>
+            <a:r>
+              <a:rPr lang="fr-FR" dirty="0" err="1"/>
+              <a:t>What</a:t>
+            </a:r>
+            <a:r>
+              <a:rPr lang="fr-FR" dirty="0"/>
+              <a:t> can </a:t>
+            </a:r>
+            <a:r>
+              <a:rPr lang="fr-FR" dirty="0" err="1"/>
+              <a:t>explain</a:t>
+            </a:r>
+            <a:r>
+              <a:rPr lang="fr-FR" dirty="0"/>
+              <a:t> </a:t>
+            </a:r>
+            <a:r>
+              <a:rPr lang="fr-FR" dirty="0" err="1"/>
+              <a:t>these</a:t>
+            </a:r>
+            <a:r>
+              <a:rPr lang="fr-FR" dirty="0"/>
+              <a:t> </a:t>
+            </a:r>
+            <a:r>
+              <a:rPr lang="fr-FR" dirty="0" err="1"/>
+              <a:t>diparities</a:t>
+            </a:r>
+            <a:r>
+              <a:rPr lang="fr-FR" dirty="0"/>
+              <a:t>?</a:t>
+            </a:r>
+            <a:endParaRPr lang="en-US" dirty="0"/>
+          </a:p>
+        </p:txBody>
+      </p:sp>
+      <p:sp>
+        <p:nvSpPr>
+          <p:cNvPr id="3" name="Content Placeholder 2">
+            <a:extLst>
+              <a:ext uri="{FF2B5EF4-FFF2-40B4-BE49-F238E27FC236}">
+                <a16:creationId xmlns:a16="http://schemas.microsoft.com/office/drawing/2014/main" id="{B518290B-8792-B79F-D5D2-2B28CD4F7B80}"/>
+              </a:ext>
+            </a:extLst>
+          </p:cNvPr>
+          <p:cNvSpPr>
+            <a:spLocks noGrp="1"/>
+          </p:cNvSpPr>
+          <p:nvPr>
+            <p:ph idx="1"/>
+          </p:nvPr>
+        </p:nvSpPr>
+        <p:spPr>
+          <a:xfrm>
+            <a:off x="646111" y="1887296"/>
+            <a:ext cx="5266315" cy="3522517"/>
+          </a:xfrm>
+        </p:spPr>
+        <p:txBody>
+          <a:bodyPr>
+            <a:normAutofit fontScale="92500" lnSpcReduction="10000"/>
+          </a:bodyPr>
+          <a:lstStyle/>
+          <a:p>
+            <a:pPr lvl="0"/>
+            <a:r>
+              <a:rPr lang="en-US" b="1" dirty="0"/>
+              <a:t>All operators together:</a:t>
+            </a:r>
+            <a:r>
+              <a:rPr lang="en-US" dirty="0"/>
+              <a:t> negative trend. </a:t>
+            </a:r>
+          </a:p>
+          <a:p>
+            <a:pPr lvl="0"/>
+            <a:r>
+              <a:rPr lang="en-US" b="1" dirty="0"/>
+              <a:t>Within each operator:</a:t>
+            </a:r>
+            <a:r>
+              <a:rPr lang="en-US" dirty="0"/>
+              <a:t> mostly positive trend.</a:t>
+            </a:r>
+          </a:p>
+          <a:p>
+            <a:pPr lvl="0"/>
+            <a:r>
+              <a:rPr lang="en-US" dirty="0"/>
+              <a:t>Operators have different performance levels and different deployment strategies.</a:t>
+            </a:r>
+          </a:p>
+          <a:p>
+            <a:pPr lvl="1">
+              <a:buFont typeface="Wingdings" panose="05000000000000000000" pitchFamily="2" charset="2"/>
+              <a:buChar char="§"/>
+            </a:pPr>
+            <a:r>
+              <a:rPr lang="en-US" dirty="0"/>
+              <a:t>Orange tends to have </a:t>
+            </a:r>
+            <a:r>
+              <a:rPr lang="en-US" b="1" dirty="0"/>
+              <a:t>higher download speeds</a:t>
+            </a:r>
+            <a:r>
+              <a:rPr lang="en-US" dirty="0"/>
+              <a:t> but lower 5G deployment rates. </a:t>
+            </a:r>
+          </a:p>
+          <a:p>
+            <a:pPr lvl="1">
+              <a:buFont typeface="Wingdings" panose="05000000000000000000" pitchFamily="2" charset="2"/>
+              <a:buChar char="§"/>
+            </a:pPr>
+            <a:r>
+              <a:rPr lang="en-US" dirty="0"/>
+              <a:t>Free tends to have </a:t>
+            </a:r>
+            <a:r>
+              <a:rPr lang="en-US" b="1" dirty="0"/>
+              <a:t>higher 5G deployment rates</a:t>
+            </a:r>
+            <a:r>
+              <a:rPr lang="en-US" dirty="0"/>
+              <a:t> but lower download speeds.</a:t>
+            </a:r>
+          </a:p>
+          <a:p>
+            <a:pPr lvl="0"/>
+            <a:endParaRPr lang="en-US" dirty="0"/>
+          </a:p>
+        </p:txBody>
+      </p:sp>
+      <p:sp>
+        <p:nvSpPr>
+          <p:cNvPr id="5" name="TextBox 4">
+            <a:extLst>
+              <a:ext uri="{FF2B5EF4-FFF2-40B4-BE49-F238E27FC236}">
+                <a16:creationId xmlns:a16="http://schemas.microsoft.com/office/drawing/2014/main" id="{A2CABBC9-180B-A74D-F353-179B907B520E}"/>
+              </a:ext>
+            </a:extLst>
+          </p:cNvPr>
+          <p:cNvSpPr txBox="1"/>
+          <p:nvPr/>
+        </p:nvSpPr>
+        <p:spPr>
+          <a:xfrm>
+            <a:off x="260976" y="1129486"/>
+            <a:ext cx="6094268" cy="646331"/>
+          </a:xfrm>
+          <a:prstGeom prst="rect">
+            <a:avLst/>
+          </a:prstGeom>
+          <a:noFill/>
+        </p:spPr>
+        <p:txBody>
+          <a:bodyPr wrap="square">
+            <a:spAutoFit/>
+          </a:bodyPr>
+          <a:lstStyle/>
+          <a:p>
+            <a:r>
+              <a:rPr lang="en-US" dirty="0"/>
+              <a:t>Does having more 5G infrastructure correspond to better measured service performance?</a:t>
+            </a:r>
+            <a:endParaRPr lang="en-US" b="1" dirty="0"/>
+          </a:p>
+        </p:txBody>
+      </p:sp>
+      <p:pic>
+        <p:nvPicPr>
+          <p:cNvPr id="13" name="Picture 12">
+            <a:extLst>
+              <a:ext uri="{FF2B5EF4-FFF2-40B4-BE49-F238E27FC236}">
+                <a16:creationId xmlns:a16="http://schemas.microsoft.com/office/drawing/2014/main" id="{35DD5FC5-D56D-B80E-8976-B6506926B57A}"/>
+              </a:ext>
+            </a:extLst>
+          </p:cNvPr>
+          <p:cNvPicPr>
+            <a:picLocks noChangeAspect="1"/>
+          </p:cNvPicPr>
+          <p:nvPr/>
+        </p:nvPicPr>
+        <p:blipFill>
+          <a:blip r:embed="rId2"/>
+          <a:stretch>
+            <a:fillRect/>
+          </a:stretch>
+        </p:blipFill>
+        <p:spPr>
+          <a:xfrm>
+            <a:off x="6912360" y="3751763"/>
+            <a:ext cx="4633529" cy="2969859"/>
+          </a:xfrm>
+          <a:prstGeom prst="rect">
+            <a:avLst/>
+          </a:prstGeom>
+          <a:ln w="38100" cap="sq">
+            <a:solidFill>
+              <a:schemeClr val="bg2">
+                <a:lumMod val="60000"/>
+                <a:lumOff val="40000"/>
+              </a:schemeClr>
+            </a:solidFill>
+            <a:prstDash val="solid"/>
+            <a:miter lim="800000"/>
+          </a:ln>
+          <a:effectLst>
+            <a:outerShdw blurRad="50800" dist="38100" dir="2700000" algn="tl" rotWithShape="0">
+              <a:srgbClr val="000000">
+                <a:alpha val="43000"/>
+              </a:srgbClr>
+            </a:outerShdw>
+          </a:effectLst>
+        </p:spPr>
+      </p:pic>
+      <p:pic>
+        <p:nvPicPr>
+          <p:cNvPr id="15" name="Picture 14">
+            <a:extLst>
+              <a:ext uri="{FF2B5EF4-FFF2-40B4-BE49-F238E27FC236}">
+                <a16:creationId xmlns:a16="http://schemas.microsoft.com/office/drawing/2014/main" id="{B86E2EB3-9429-A2E1-58F9-8705C3C7528E}"/>
+              </a:ext>
+            </a:extLst>
+          </p:cNvPr>
+          <p:cNvPicPr>
+            <a:picLocks noChangeAspect="1"/>
+          </p:cNvPicPr>
+          <p:nvPr/>
+        </p:nvPicPr>
+        <p:blipFill>
+          <a:blip r:embed="rId3"/>
+          <a:stretch>
+            <a:fillRect/>
+          </a:stretch>
+        </p:blipFill>
+        <p:spPr>
+          <a:xfrm>
+            <a:off x="6912360" y="452718"/>
+            <a:ext cx="4633529" cy="3053917"/>
+          </a:xfrm>
+          <a:prstGeom prst="rect">
+            <a:avLst/>
+          </a:prstGeom>
+          <a:ln w="38100" cap="sq">
+            <a:solidFill>
+              <a:schemeClr val="bg2">
+                <a:lumMod val="60000"/>
+                <a:lumOff val="40000"/>
+              </a:schemeClr>
+            </a:solidFill>
+            <a:prstDash val="solid"/>
+            <a:miter lim="800000"/>
+          </a:ln>
+          <a:effectLst>
+            <a:outerShdw blurRad="50800" dist="38100" dir="2700000" algn="tl" rotWithShape="0">
+              <a:srgbClr val="000000">
+                <a:alpha val="43000"/>
+              </a:srgbClr>
+            </a:outerShdw>
+          </a:effectLst>
+        </p:spPr>
+      </p:pic>
+      <p:sp>
+        <p:nvSpPr>
+          <p:cNvPr id="17" name="TextBox 16">
+            <a:extLst>
+              <a:ext uri="{FF2B5EF4-FFF2-40B4-BE49-F238E27FC236}">
+                <a16:creationId xmlns:a16="http://schemas.microsoft.com/office/drawing/2014/main" id="{FB0FF23D-596E-465E-4D7A-3AA85C508C9F}"/>
+              </a:ext>
+            </a:extLst>
+          </p:cNvPr>
+          <p:cNvSpPr txBox="1"/>
+          <p:nvPr/>
+        </p:nvSpPr>
+        <p:spPr>
+          <a:xfrm>
+            <a:off x="646111" y="5521293"/>
+            <a:ext cx="6094268" cy="1200329"/>
+          </a:xfrm>
+          <a:prstGeom prst="rect">
+            <a:avLst/>
+          </a:prstGeom>
+          <a:noFill/>
+        </p:spPr>
+        <p:txBody>
+          <a:bodyPr wrap="square">
+            <a:spAutoFit/>
+          </a:bodyPr>
+          <a:lstStyle/>
+          <a:p>
+            <a:r>
+              <a:rPr lang="en-US" dirty="0">
+                <a:solidFill>
+                  <a:srgbClr val="FFFF00"/>
+                </a:solidFill>
+              </a:rPr>
+              <a:t>5G infrastructure does appear to contribute to performance, but infrastructure alone does not explain the observed disparities. Operator-specific differences remain important</a:t>
+            </a:r>
+          </a:p>
+        </p:txBody>
+      </p:sp>
+    </p:spTree>
+    <p:extLst>
+      <p:ext uri="{BB962C8B-B14F-4D97-AF65-F5344CB8AC3E}">
+        <p14:creationId xmlns:p14="http://schemas.microsoft.com/office/powerpoint/2010/main" val="517794962"/>
       </p:ext>
     </p:extLst>
   </p:cSld>

</xml_diff>

<commit_message>
Added machine_learning_ipy file and updated README.md file
</commit_message>
<xml_diff>
--- a/RNCP_presentation_sept26.pptx
+++ b/RNCP_presentation_sept26.pptx
@@ -5,7 +5,7 @@
     <p:sldMasterId id="2147483648" r:id="rId1"/>
   </p:sldMasterIdLst>
   <p:notesMasterIdLst>
-    <p:notesMasterId r:id="rId19"/>
+    <p:notesMasterId r:id="rId20"/>
   </p:notesMasterIdLst>
   <p:sldIdLst>
     <p:sldId id="256" r:id="rId2"/>
@@ -19,12 +19,13 @@
     <p:sldId id="283" r:id="rId10"/>
     <p:sldId id="284" r:id="rId11"/>
     <p:sldId id="285" r:id="rId12"/>
-    <p:sldId id="291" r:id="rId13"/>
-    <p:sldId id="288" r:id="rId14"/>
-    <p:sldId id="289" r:id="rId15"/>
-    <p:sldId id="290" r:id="rId16"/>
-    <p:sldId id="293" r:id="rId17"/>
-    <p:sldId id="292" r:id="rId18"/>
+    <p:sldId id="295" r:id="rId13"/>
+    <p:sldId id="291" r:id="rId14"/>
+    <p:sldId id="288" r:id="rId15"/>
+    <p:sldId id="289" r:id="rId16"/>
+    <p:sldId id="290" r:id="rId17"/>
+    <p:sldId id="293" r:id="rId18"/>
+    <p:sldId id="292" r:id="rId19"/>
   </p:sldIdLst>
   <p:sldSz cx="12192000" cy="6858000"/>
   <p:notesSz cx="7104063" cy="10234613"/>
@@ -546,7 +547,7 @@
           <a:p>
             <a:fld id="{24BD1F29-6D9C-4F9A-84F0-0549FD512D9F}" type="slidenum">
               <a:rPr lang="en-US" smtClean="0"/>
-              <a:t>12</a:t>
+              <a:t>13</a:t>
             </a:fld>
             <a:endParaRPr lang="en-US"/>
           </a:p>
@@ -8056,6 +8057,1006 @@
       </p:grpSpPr>
       <p:sp>
         <p:nvSpPr>
+          <p:cNvPr id="24" name="Rectangle 23">
+            <a:extLst>
+              <a:ext uri="{FF2B5EF4-FFF2-40B4-BE49-F238E27FC236}">
+                <a16:creationId xmlns:a16="http://schemas.microsoft.com/office/drawing/2014/main" id="{E3A446B6-2204-48B8-A7C5-606E45BCA1EE}"/>
+              </a:ext>
+              <a:ext uri="{C183D7F6-B498-43B3-948B-1728B52AA6E4}">
+                <adec:decorative xmlns:adec="http://schemas.microsoft.com/office/drawing/2017/decorative" val="1"/>
+              </a:ext>
+            </a:extLst>
+          </p:cNvPr>
+          <p:cNvSpPr>
+            <a:spLocks noGrp="1" noRot="1" noChangeAspect="1" noMove="1" noResize="1" noEditPoints="1" noAdjustHandles="1" noChangeArrowheads="1" noChangeShapeType="1" noTextEdit="1"/>
+          </p:cNvSpPr>
+          <p:nvPr>
+            <p:extLst>
+              <p:ext uri="{386F3935-93C4-4BCD-93E2-E3B085C9AB24}">
+                <p16:designElem xmlns:p16="http://schemas.microsoft.com/office/powerpoint/2015/main" val="1"/>
+              </p:ext>
+            </p:extLst>
+          </p:nvPr>
+        </p:nvSpPr>
+        <p:spPr>
+          <a:xfrm>
+            <a:off x="0" y="0"/>
+            <a:ext cx="12191999" cy="6858000"/>
+          </a:xfrm>
+          <a:prstGeom prst="rect">
+            <a:avLst/>
+          </a:prstGeom>
+          <a:ln>
+            <a:noFill/>
+          </a:ln>
+        </p:spPr>
+        <p:style>
+          <a:lnRef idx="2">
+            <a:schemeClr val="accent1">
+              <a:shade val="50000"/>
+            </a:schemeClr>
+          </a:lnRef>
+          <a:fillRef idx="1003">
+            <a:schemeClr val="dk2"/>
+          </a:fillRef>
+          <a:effectRef idx="0">
+            <a:schemeClr val="accent1"/>
+          </a:effectRef>
+          <a:fontRef idx="minor">
+            <a:schemeClr val="lt1"/>
+          </a:fontRef>
+        </p:style>
+        <p:txBody>
+          <a:bodyPr rtlCol="0" anchor="ctr"/>
+          <a:lstStyle/>
+          <a:p>
+            <a:pPr algn="ctr"/>
+            <a:endParaRPr lang="en-US"/>
+          </a:p>
+        </p:txBody>
+      </p:sp>
+      <p:sp>
+        <p:nvSpPr>
+          <p:cNvPr id="2" name="Title 1">
+            <a:extLst>
+              <a:ext uri="{FF2B5EF4-FFF2-40B4-BE49-F238E27FC236}">
+                <a16:creationId xmlns:a16="http://schemas.microsoft.com/office/drawing/2014/main" id="{96866990-844B-2A3C-274A-3C973D1D9D47}"/>
+              </a:ext>
+            </a:extLst>
+          </p:cNvPr>
+          <p:cNvSpPr>
+            <a:spLocks noGrp="1"/>
+          </p:cNvSpPr>
+          <p:nvPr>
+            <p:ph type="title"/>
+          </p:nvPr>
+        </p:nvSpPr>
+        <p:spPr>
+          <a:xfrm>
+            <a:off x="648929" y="965201"/>
+            <a:ext cx="3903412" cy="4773612"/>
+          </a:xfrm>
+        </p:spPr>
+        <p:txBody>
+          <a:bodyPr anchor="ctr">
+            <a:normAutofit/>
+          </a:bodyPr>
+          <a:lstStyle/>
+          <a:p>
+            <a:r>
+              <a:rPr lang="fr-FR" b="1" dirty="0">
+                <a:solidFill>
+                  <a:srgbClr val="EBEBEB"/>
+                </a:solidFill>
+              </a:rPr>
+              <a:t>9. ML Process </a:t>
+            </a:r>
+            <a:endParaRPr lang="en-US" b="1" dirty="0">
+              <a:solidFill>
+                <a:srgbClr val="EBEBEB"/>
+              </a:solidFill>
+            </a:endParaRPr>
+          </a:p>
+        </p:txBody>
+      </p:sp>
+      <p:sp>
+        <p:nvSpPr>
+          <p:cNvPr id="25" name="Rectangle 24">
+            <a:extLst>
+              <a:ext uri="{FF2B5EF4-FFF2-40B4-BE49-F238E27FC236}">
+                <a16:creationId xmlns:a16="http://schemas.microsoft.com/office/drawing/2014/main" id="{FBF70932-2C39-4BA6-AA08-EF3AD899CBD1}"/>
+              </a:ext>
+              <a:ext uri="{C183D7F6-B498-43B3-948B-1728B52AA6E4}">
+                <adec:decorative xmlns:adec="http://schemas.microsoft.com/office/drawing/2017/decorative" val="1"/>
+              </a:ext>
+            </a:extLst>
+          </p:cNvPr>
+          <p:cNvSpPr>
+            <a:spLocks noGrp="1" noRot="1" noChangeAspect="1" noMove="1" noResize="1" noEditPoints="1" noAdjustHandles="1" noChangeArrowheads="1" noChangeShapeType="1" noTextEdit="1"/>
+          </p:cNvSpPr>
+          <p:nvPr>
+            <p:extLst>
+              <p:ext uri="{386F3935-93C4-4BCD-93E2-E3B085C9AB24}">
+                <p16:designElem xmlns:p16="http://schemas.microsoft.com/office/powerpoint/2015/main" val="1"/>
+              </p:ext>
+            </p:extLst>
+          </p:nvPr>
+        </p:nvSpPr>
+        <p:spPr>
+          <a:xfrm>
+            <a:off x="4639056" y="0"/>
+            <a:ext cx="7552944" cy="6858000"/>
+          </a:xfrm>
+          <a:prstGeom prst="rect">
+            <a:avLst/>
+          </a:prstGeom>
+          <a:solidFill>
+            <a:srgbClr val="FFFFFF"/>
+          </a:solidFill>
+          <a:ln>
+            <a:noFill/>
+          </a:ln>
+        </p:spPr>
+        <p:style>
+          <a:lnRef idx="2">
+            <a:schemeClr val="accent1">
+              <a:shade val="50000"/>
+            </a:schemeClr>
+          </a:lnRef>
+          <a:fillRef idx="1">
+            <a:schemeClr val="accent1"/>
+          </a:fillRef>
+          <a:effectRef idx="0">
+            <a:schemeClr val="accent1"/>
+          </a:effectRef>
+          <a:fontRef idx="minor">
+            <a:schemeClr val="lt1"/>
+          </a:fontRef>
+        </p:style>
+        <p:txBody>
+          <a:bodyPr rtlCol="0" anchor="ctr"/>
+          <a:lstStyle/>
+          <a:p>
+            <a:pPr algn="ctr"/>
+            <a:endParaRPr lang="en-US"/>
+          </a:p>
+        </p:txBody>
+      </p:sp>
+      <p:sp useBgFill="1">
+        <p:nvSpPr>
+          <p:cNvPr id="26" name="Rounded Rectangle 9">
+            <a:extLst>
+              <a:ext uri="{FF2B5EF4-FFF2-40B4-BE49-F238E27FC236}">
+                <a16:creationId xmlns:a16="http://schemas.microsoft.com/office/drawing/2014/main" id="{0FD39269-4644-4CAE-8A56-899A62A9C756}"/>
+              </a:ext>
+              <a:ext uri="{C183D7F6-B498-43B3-948B-1728B52AA6E4}">
+                <adec:decorative xmlns:adec="http://schemas.microsoft.com/office/drawing/2017/decorative" val="1"/>
+              </a:ext>
+            </a:extLst>
+          </p:cNvPr>
+          <p:cNvSpPr>
+            <a:spLocks noGrp="1" noRot="1" noChangeAspect="1" noMove="1" noResize="1" noEditPoints="1" noAdjustHandles="1" noChangeArrowheads="1" noChangeShapeType="1" noTextEdit="1"/>
+          </p:cNvSpPr>
+          <p:nvPr>
+            <p:extLst>
+              <p:ext uri="{386F3935-93C4-4BCD-93E2-E3B085C9AB24}">
+                <p16:designElem xmlns:p16="http://schemas.microsoft.com/office/powerpoint/2015/main" val="1"/>
+              </p:ext>
+            </p:extLst>
+          </p:nvPr>
+        </p:nvSpPr>
+        <p:spPr>
+          <a:xfrm>
+            <a:off x="5123688" y="484632"/>
+            <a:ext cx="6584098" cy="5739187"/>
+          </a:xfrm>
+          <a:prstGeom prst="roundRect">
+            <a:avLst>
+              <a:gd name="adj" fmla="val 0"/>
+            </a:avLst>
+          </a:prstGeom>
+          <a:ln w="12700" cap="sq">
+            <a:solidFill>
+              <a:schemeClr val="bg1">
+                <a:lumMod val="75000"/>
+              </a:schemeClr>
+            </a:solidFill>
+            <a:miter lim="800000"/>
+          </a:ln>
+          <a:effectLst>
+            <a:outerShdw blurRad="63500" dist="25400" dir="5400000" algn="tl" rotWithShape="0">
+              <a:srgbClr val="000000">
+                <a:alpha val="39000"/>
+              </a:srgbClr>
+            </a:outerShdw>
+          </a:effectLst>
+        </p:spPr>
+        <p:style>
+          <a:lnRef idx="2">
+            <a:schemeClr val="accent1">
+              <a:shade val="50000"/>
+            </a:schemeClr>
+          </a:lnRef>
+          <a:fillRef idx="1">
+            <a:schemeClr val="accent1"/>
+          </a:fillRef>
+          <a:effectRef idx="0">
+            <a:schemeClr val="accent1"/>
+          </a:effectRef>
+          <a:fontRef idx="minor">
+            <a:schemeClr val="lt1"/>
+          </a:fontRef>
+        </p:style>
+        <p:txBody>
+          <a:bodyPr rtlCol="0" anchor="ctr"/>
+          <a:lstStyle/>
+          <a:p>
+            <a:pPr algn="ctr"/>
+            <a:endParaRPr lang="en-US"/>
+          </a:p>
+        </p:txBody>
+      </p:sp>
+      <p:sp>
+        <p:nvSpPr>
+          <p:cNvPr id="27" name="Rectangle 26">
+            <a:extLst>
+              <a:ext uri="{FF2B5EF4-FFF2-40B4-BE49-F238E27FC236}">
+                <a16:creationId xmlns:a16="http://schemas.microsoft.com/office/drawing/2014/main" id="{302302A5-B07A-48BB-9A56-89192DCCAB1E}"/>
+              </a:ext>
+              <a:ext uri="{C183D7F6-B498-43B3-948B-1728B52AA6E4}">
+                <adec:decorative xmlns:adec="http://schemas.microsoft.com/office/drawing/2017/decorative" val="1"/>
+              </a:ext>
+            </a:extLst>
+          </p:cNvPr>
+          <p:cNvSpPr>
+            <a:spLocks noGrp="1" noRot="1" noChangeAspect="1" noMove="1" noResize="1" noEditPoints="1" noAdjustHandles="1" noChangeArrowheads="1" noChangeShapeType="1" noTextEdit="1"/>
+          </p:cNvSpPr>
+          <p:nvPr>
+            <p:extLst>
+              <p:ext uri="{386F3935-93C4-4BCD-93E2-E3B085C9AB24}">
+                <p16:designElem xmlns:p16="http://schemas.microsoft.com/office/powerpoint/2015/main" val="1"/>
+              </p:ext>
+            </p:extLst>
+          </p:nvPr>
+        </p:nvSpPr>
+        <p:spPr>
+          <a:xfrm>
+            <a:off x="10442448" y="0"/>
+            <a:ext cx="685800" cy="1143000"/>
+          </a:xfrm>
+          <a:prstGeom prst="rect">
+            <a:avLst/>
+          </a:prstGeom>
+          <a:solidFill>
+            <a:schemeClr val="accent1"/>
+          </a:solidFill>
+          <a:ln>
+            <a:noFill/>
+          </a:ln>
+        </p:spPr>
+        <p:style>
+          <a:lnRef idx="1">
+            <a:schemeClr val="accent1"/>
+          </a:lnRef>
+          <a:fillRef idx="3">
+            <a:schemeClr val="accent1"/>
+          </a:fillRef>
+          <a:effectRef idx="2">
+            <a:schemeClr val="accent1"/>
+          </a:effectRef>
+          <a:fontRef idx="minor">
+            <a:schemeClr val="lt1"/>
+          </a:fontRef>
+        </p:style>
+        <p:txBody>
+          <a:bodyPr/>
+          <a:lstStyle/>
+          <a:p>
+            <a:endParaRPr lang="en-US"/>
+          </a:p>
+        </p:txBody>
+      </p:sp>
+      <p:graphicFrame>
+        <p:nvGraphicFramePr>
+          <p:cNvPr id="11" name="Content Placeholder 10">
+            <a:extLst>
+              <a:ext uri="{FF2B5EF4-FFF2-40B4-BE49-F238E27FC236}">
+                <a16:creationId xmlns:a16="http://schemas.microsoft.com/office/drawing/2014/main" id="{A77D9E10-D02D-1D8C-3A04-333BCB807F9C}"/>
+              </a:ext>
+            </a:extLst>
+          </p:cNvPr>
+          <p:cNvGraphicFramePr>
+            <a:graphicFrameLocks noGrp="1"/>
+          </p:cNvGraphicFramePr>
+          <p:nvPr>
+            <p:ph idx="1"/>
+            <p:extLst>
+              <p:ext uri="{D42A27DB-BD31-4B8C-83A1-F6EECF244321}">
+                <p14:modId xmlns:p14="http://schemas.microsoft.com/office/powerpoint/2010/main" val="4140388767"/>
+              </p:ext>
+            </p:extLst>
+          </p:nvPr>
+        </p:nvGraphicFramePr>
+        <p:xfrm>
+          <a:off x="5525717" y="1943100"/>
+          <a:ext cx="5779622" cy="2622117"/>
+        </p:xfrm>
+        <a:graphic>
+          <a:graphicData uri="http://schemas.openxmlformats.org/drawingml/2006/table">
+            <a:tbl>
+              <a:tblPr firstRow="1" bandRow="1">
+                <a:tableStyleId>{00A15C55-8517-42AA-B614-E9B94910E393}</a:tableStyleId>
+              </a:tblPr>
+              <a:tblGrid>
+                <a:gridCol w="1477922">
+                  <a:extLst>
+                    <a:ext uri="{9D8B030D-6E8A-4147-A177-3AD203B41FA5}">
+                      <a16:colId xmlns:a16="http://schemas.microsoft.com/office/drawing/2014/main" val="2156652215"/>
+                    </a:ext>
+                  </a:extLst>
+                </a:gridCol>
+                <a:gridCol w="970369">
+                  <a:extLst>
+                    <a:ext uri="{9D8B030D-6E8A-4147-A177-3AD203B41FA5}">
+                      <a16:colId xmlns:a16="http://schemas.microsoft.com/office/drawing/2014/main" val="926857948"/>
+                    </a:ext>
+                  </a:extLst>
+                </a:gridCol>
+                <a:gridCol w="1493800">
+                  <a:extLst>
+                    <a:ext uri="{9D8B030D-6E8A-4147-A177-3AD203B41FA5}">
+                      <a16:colId xmlns:a16="http://schemas.microsoft.com/office/drawing/2014/main" val="3318665075"/>
+                    </a:ext>
+                  </a:extLst>
+                </a:gridCol>
+                <a:gridCol w="1837531">
+                  <a:extLst>
+                    <a:ext uri="{9D8B030D-6E8A-4147-A177-3AD203B41FA5}">
+                      <a16:colId xmlns:a16="http://schemas.microsoft.com/office/drawing/2014/main" val="445565844"/>
+                    </a:ext>
+                  </a:extLst>
+                </a:gridCol>
+              </a:tblGrid>
+              <a:tr h="644563">
+                <a:tc>
+                  <a:txBody>
+                    <a:bodyPr/>
+                    <a:lstStyle/>
+                    <a:p>
+                      <a:pPr algn="ctr" fontAlgn="ctr">
+                        <a:buNone/>
+                      </a:pPr>
+                      <a:r>
+                        <a:rPr lang="en-US" sz="1800" b="1" u="none" strike="noStrike" cap="none" spc="0">
+                          <a:solidFill>
+                            <a:schemeClr val="tx1"/>
+                          </a:solidFill>
+                          <a:effectLst/>
+                        </a:rPr>
+                        <a:t>Model</a:t>
+                      </a:r>
+                      <a:endParaRPr lang="en-US" sz="1800" b="1" i="0" u="none" strike="noStrike" cap="none" spc="0">
+                        <a:solidFill>
+                          <a:schemeClr val="tx1"/>
+                        </a:solidFill>
+                        <a:effectLst/>
+                        <a:latin typeface="Aptos Narrow" panose="020B0004020202020204" pitchFamily="34" charset="0"/>
+                      </a:endParaRPr>
+                    </a:p>
+                  </a:txBody>
+                  <a:tcPr marL="113466" marR="12097" marT="32419" marB="243142" anchor="b"/>
+                </a:tc>
+                <a:tc>
+                  <a:txBody>
+                    <a:bodyPr/>
+                    <a:lstStyle/>
+                    <a:p>
+                      <a:pPr algn="ctr" fontAlgn="ctr">
+                        <a:buNone/>
+                      </a:pPr>
+                      <a:r>
+                        <a:rPr lang="en-US" sz="1800" b="1" u="none" strike="noStrike" cap="none" spc="0">
+                          <a:solidFill>
+                            <a:schemeClr val="tx1"/>
+                          </a:solidFill>
+                          <a:effectLst/>
+                        </a:rPr>
+                        <a:t>R²</a:t>
+                      </a:r>
+                      <a:endParaRPr lang="en-US" sz="1800" b="1" i="0" u="none" strike="noStrike" cap="none" spc="0">
+                        <a:solidFill>
+                          <a:schemeClr val="tx1"/>
+                        </a:solidFill>
+                        <a:effectLst/>
+                        <a:latin typeface="Aptos Narrow" panose="020B0004020202020204" pitchFamily="34" charset="0"/>
+                      </a:endParaRPr>
+                    </a:p>
+                  </a:txBody>
+                  <a:tcPr marL="113466" marR="12097" marT="32419" marB="243142" anchor="b"/>
+                </a:tc>
+                <a:tc>
+                  <a:txBody>
+                    <a:bodyPr/>
+                    <a:lstStyle/>
+                    <a:p>
+                      <a:pPr algn="ctr" fontAlgn="ctr">
+                        <a:buNone/>
+                      </a:pPr>
+                      <a:r>
+                        <a:rPr lang="en-US" sz="1800" b="1" u="none" strike="noStrike" cap="none" spc="0">
+                          <a:solidFill>
+                            <a:schemeClr val="tx1"/>
+                          </a:solidFill>
+                          <a:effectLst/>
+                        </a:rPr>
+                        <a:t>MAE (Mbps)</a:t>
+                      </a:r>
+                      <a:endParaRPr lang="en-US" sz="1800" b="1" i="0" u="none" strike="noStrike" cap="none" spc="0">
+                        <a:solidFill>
+                          <a:schemeClr val="tx1"/>
+                        </a:solidFill>
+                        <a:effectLst/>
+                        <a:latin typeface="Aptos Narrow" panose="020B0004020202020204" pitchFamily="34" charset="0"/>
+                      </a:endParaRPr>
+                    </a:p>
+                  </a:txBody>
+                  <a:tcPr marL="113466" marR="12097" marT="32419" marB="243142" anchor="b"/>
+                </a:tc>
+                <a:tc>
+                  <a:txBody>
+                    <a:bodyPr/>
+                    <a:lstStyle/>
+                    <a:p>
+                      <a:pPr algn="ctr" fontAlgn="ctr">
+                        <a:buNone/>
+                      </a:pPr>
+                      <a:r>
+                        <a:rPr lang="en-US" sz="1800" b="1" u="none" strike="noStrike" cap="none" spc="0">
+                          <a:solidFill>
+                            <a:schemeClr val="tx1"/>
+                          </a:solidFill>
+                          <a:effectLst/>
+                        </a:rPr>
+                        <a:t>RMSE (Mbps)</a:t>
+                      </a:r>
+                      <a:endParaRPr lang="en-US" sz="1800" b="1" i="0" u="none" strike="noStrike" cap="none" spc="0">
+                        <a:solidFill>
+                          <a:schemeClr val="tx1"/>
+                        </a:solidFill>
+                        <a:effectLst/>
+                        <a:latin typeface="Aptos Narrow" panose="020B0004020202020204" pitchFamily="34" charset="0"/>
+                      </a:endParaRPr>
+                    </a:p>
+                  </a:txBody>
+                  <a:tcPr marL="113466" marR="12097" marT="32419" marB="243142" anchor="b"/>
+                </a:tc>
+                <a:extLst>
+                  <a:ext uri="{0D108BD9-81ED-4DB2-BD59-A6C34878D82A}">
+                    <a16:rowId xmlns:a16="http://schemas.microsoft.com/office/drawing/2014/main" val="2972688445"/>
+                  </a:ext>
+                </a:extLst>
+              </a:tr>
+              <a:tr h="988777">
+                <a:tc>
+                  <a:txBody>
+                    <a:bodyPr/>
+                    <a:lstStyle/>
+                    <a:p>
+                      <a:pPr algn="l" fontAlgn="ctr">
+                        <a:buNone/>
+                      </a:pPr>
+                      <a:r>
+                        <a:rPr lang="en-US" sz="1600" b="1" u="none" strike="noStrike" cap="none" spc="0">
+                          <a:solidFill>
+                            <a:schemeClr val="tx1"/>
+                          </a:solidFill>
+                          <a:effectLst/>
+                        </a:rPr>
+                        <a:t>Decision Tree</a:t>
+                      </a:r>
+                      <a:endParaRPr lang="en-US" sz="1600" b="1" i="0" u="none" strike="noStrike" cap="none" spc="0">
+                        <a:solidFill>
+                          <a:schemeClr val="tx1"/>
+                        </a:solidFill>
+                        <a:effectLst/>
+                        <a:latin typeface="Aptos Narrow" panose="020B0004020202020204" pitchFamily="34" charset="0"/>
+                      </a:endParaRPr>
+                    </a:p>
+                  </a:txBody>
+                  <a:tcPr marL="113466" marR="12097" marT="32419" marB="243142" anchor="ctr"/>
+                </a:tc>
+                <a:tc>
+                  <a:txBody>
+                    <a:bodyPr/>
+                    <a:lstStyle/>
+                    <a:p>
+                      <a:pPr algn="ctr" fontAlgn="ctr">
+                        <a:buNone/>
+                      </a:pPr>
+                      <a:r>
+                        <a:rPr lang="en-US" sz="1600" u="none" strike="noStrike" cap="none" spc="0" dirty="0">
+                          <a:solidFill>
+                            <a:schemeClr val="tx1"/>
+                          </a:solidFill>
+                          <a:effectLst/>
+                        </a:rPr>
+                        <a:t>0.478</a:t>
+                      </a:r>
+                      <a:endParaRPr lang="en-US" sz="1600" b="0" i="0" u="none" strike="noStrike" cap="none" spc="0" dirty="0">
+                        <a:solidFill>
+                          <a:schemeClr val="tx1"/>
+                        </a:solidFill>
+                        <a:effectLst/>
+                        <a:latin typeface="Aptos Narrow" panose="020B0004020202020204" pitchFamily="34" charset="0"/>
+                      </a:endParaRPr>
+                    </a:p>
+                  </a:txBody>
+                  <a:tcPr marL="113466" marR="12097" marT="32419" marB="243142" anchor="ctr"/>
+                </a:tc>
+                <a:tc>
+                  <a:txBody>
+                    <a:bodyPr/>
+                    <a:lstStyle/>
+                    <a:p>
+                      <a:pPr algn="ctr" fontAlgn="ctr">
+                        <a:buNone/>
+                      </a:pPr>
+                      <a:r>
+                        <a:rPr lang="en-US" sz="1600" u="none" strike="noStrike" cap="none" spc="0" dirty="0">
+                          <a:solidFill>
+                            <a:schemeClr val="tx1"/>
+                          </a:solidFill>
+                          <a:effectLst/>
+                        </a:rPr>
+                        <a:t>81</a:t>
+                      </a:r>
+                      <a:endParaRPr lang="en-US" sz="1600" b="0" i="0" u="none" strike="noStrike" cap="none" spc="0" dirty="0">
+                        <a:solidFill>
+                          <a:schemeClr val="tx1"/>
+                        </a:solidFill>
+                        <a:effectLst/>
+                        <a:latin typeface="Aptos Narrow" panose="020B0004020202020204" pitchFamily="34" charset="0"/>
+                      </a:endParaRPr>
+                    </a:p>
+                  </a:txBody>
+                  <a:tcPr marL="113466" marR="12097" marT="32419" marB="243142" anchor="ctr"/>
+                </a:tc>
+                <a:tc>
+                  <a:txBody>
+                    <a:bodyPr/>
+                    <a:lstStyle/>
+                    <a:p>
+                      <a:pPr algn="ctr" fontAlgn="ctr">
+                        <a:buNone/>
+                      </a:pPr>
+                      <a:r>
+                        <a:rPr lang="en-US" sz="1600" u="none" strike="noStrike" cap="none" spc="0" dirty="0">
+                          <a:solidFill>
+                            <a:schemeClr val="tx1"/>
+                          </a:solidFill>
+                          <a:effectLst/>
+                        </a:rPr>
+                        <a:t>113</a:t>
+                      </a:r>
+                      <a:endParaRPr lang="en-US" sz="1600" b="0" i="0" u="none" strike="noStrike" cap="none" spc="0" dirty="0">
+                        <a:solidFill>
+                          <a:schemeClr val="tx1"/>
+                        </a:solidFill>
+                        <a:effectLst/>
+                        <a:latin typeface="Aptos Narrow" panose="020B0004020202020204" pitchFamily="34" charset="0"/>
+                      </a:endParaRPr>
+                    </a:p>
+                  </a:txBody>
+                  <a:tcPr marL="113466" marR="12097" marT="32419" marB="243142" anchor="ctr"/>
+                </a:tc>
+                <a:extLst>
+                  <a:ext uri="{0D108BD9-81ED-4DB2-BD59-A6C34878D82A}">
+                    <a16:rowId xmlns:a16="http://schemas.microsoft.com/office/drawing/2014/main" val="3817651728"/>
+                  </a:ext>
+                </a:extLst>
+              </a:tr>
+              <a:tr h="988777">
+                <a:tc>
+                  <a:txBody>
+                    <a:bodyPr/>
+                    <a:lstStyle/>
+                    <a:p>
+                      <a:pPr algn="l" fontAlgn="ctr">
+                        <a:buNone/>
+                      </a:pPr>
+                      <a:r>
+                        <a:rPr lang="en-US" sz="1600" b="1" u="none" strike="noStrike" cap="none" spc="0" dirty="0">
+                          <a:solidFill>
+                            <a:schemeClr val="tx1"/>
+                          </a:solidFill>
+                          <a:effectLst/>
+                        </a:rPr>
+                        <a:t>Linear Regression</a:t>
+                      </a:r>
+                      <a:endParaRPr lang="en-US" sz="1600" b="1" i="0" u="none" strike="noStrike" cap="none" spc="0" dirty="0">
+                        <a:solidFill>
+                          <a:schemeClr val="tx1"/>
+                        </a:solidFill>
+                        <a:effectLst/>
+                        <a:latin typeface="Aptos Narrow" panose="020B0004020202020204" pitchFamily="34" charset="0"/>
+                      </a:endParaRPr>
+                    </a:p>
+                  </a:txBody>
+                  <a:tcPr marL="113466" marR="12097" marT="32419" marB="243142" anchor="ctr"/>
+                </a:tc>
+                <a:tc>
+                  <a:txBody>
+                    <a:bodyPr/>
+                    <a:lstStyle/>
+                    <a:p>
+                      <a:pPr algn="ctr" fontAlgn="ctr">
+                        <a:buNone/>
+                      </a:pPr>
+                      <a:r>
+                        <a:rPr lang="en-US" sz="1600" u="none" strike="noStrike" cap="none" spc="0" dirty="0">
+                          <a:solidFill>
+                            <a:schemeClr val="tx1"/>
+                          </a:solidFill>
+                          <a:effectLst/>
+                        </a:rPr>
+                        <a:t>0.385</a:t>
+                      </a:r>
+                      <a:endParaRPr lang="en-US" sz="1600" b="0" i="0" u="none" strike="noStrike" cap="none" spc="0" dirty="0">
+                        <a:solidFill>
+                          <a:schemeClr val="tx1"/>
+                        </a:solidFill>
+                        <a:effectLst/>
+                        <a:latin typeface="Aptos Narrow" panose="020B0004020202020204" pitchFamily="34" charset="0"/>
+                      </a:endParaRPr>
+                    </a:p>
+                  </a:txBody>
+                  <a:tcPr marL="113466" marR="12097" marT="32419" marB="243142" anchor="ctr"/>
+                </a:tc>
+                <a:tc>
+                  <a:txBody>
+                    <a:bodyPr/>
+                    <a:lstStyle/>
+                    <a:p>
+                      <a:pPr algn="ctr" fontAlgn="ctr">
+                        <a:buNone/>
+                      </a:pPr>
+                      <a:r>
+                        <a:rPr lang="en-US" sz="1600" u="none" strike="noStrike" cap="none" spc="0" dirty="0">
+                          <a:solidFill>
+                            <a:schemeClr val="tx1"/>
+                          </a:solidFill>
+                          <a:effectLst/>
+                        </a:rPr>
+                        <a:t>99</a:t>
+                      </a:r>
+                      <a:endParaRPr lang="en-US" sz="1600" b="0" i="0" u="none" strike="noStrike" cap="none" spc="0" dirty="0">
+                        <a:solidFill>
+                          <a:schemeClr val="tx1"/>
+                        </a:solidFill>
+                        <a:effectLst/>
+                        <a:latin typeface="Aptos Narrow" panose="020B0004020202020204" pitchFamily="34" charset="0"/>
+                      </a:endParaRPr>
+                    </a:p>
+                  </a:txBody>
+                  <a:tcPr marL="113466" marR="12097" marT="32419" marB="243142" anchor="ctr"/>
+                </a:tc>
+                <a:tc>
+                  <a:txBody>
+                    <a:bodyPr/>
+                    <a:lstStyle/>
+                    <a:p>
+                      <a:pPr algn="ctr" fontAlgn="ctr">
+                        <a:buNone/>
+                      </a:pPr>
+                      <a:r>
+                        <a:rPr lang="en-US" sz="1600" u="none" strike="noStrike" cap="none" spc="0" dirty="0">
+                          <a:solidFill>
+                            <a:schemeClr val="tx1"/>
+                          </a:solidFill>
+                          <a:effectLst/>
+                        </a:rPr>
+                        <a:t>123</a:t>
+                      </a:r>
+                      <a:endParaRPr lang="en-US" sz="1600" b="0" i="0" u="none" strike="noStrike" cap="none" spc="0" dirty="0">
+                        <a:solidFill>
+                          <a:schemeClr val="tx1"/>
+                        </a:solidFill>
+                        <a:effectLst/>
+                        <a:latin typeface="Aptos Narrow" panose="020B0004020202020204" pitchFamily="34" charset="0"/>
+                      </a:endParaRPr>
+                    </a:p>
+                  </a:txBody>
+                  <a:tcPr marL="113466" marR="12097" marT="32419" marB="243142" anchor="ctr"/>
+                </a:tc>
+                <a:extLst>
+                  <a:ext uri="{0D108BD9-81ED-4DB2-BD59-A6C34878D82A}">
+                    <a16:rowId xmlns:a16="http://schemas.microsoft.com/office/drawing/2014/main" val="3101008567"/>
+                  </a:ext>
+                </a:extLst>
+              </a:tr>
+            </a:tbl>
+          </a:graphicData>
+        </a:graphic>
+      </p:graphicFrame>
+      <p:sp>
+        <p:nvSpPr>
+          <p:cNvPr id="14" name="Content Placeholder 2">
+            <a:extLst>
+              <a:ext uri="{FF2B5EF4-FFF2-40B4-BE49-F238E27FC236}">
+                <a16:creationId xmlns:a16="http://schemas.microsoft.com/office/drawing/2014/main" id="{E6BB7A09-3B40-B677-2CC9-904ED1166620}"/>
+              </a:ext>
+            </a:extLst>
+          </p:cNvPr>
+          <p:cNvSpPr txBox="1">
+            <a:spLocks/>
+          </p:cNvSpPr>
+          <p:nvPr/>
+        </p:nvSpPr>
+        <p:spPr>
+          <a:xfrm>
+            <a:off x="5131879" y="4834839"/>
+            <a:ext cx="6411192" cy="1188846"/>
+          </a:xfrm>
+          <a:prstGeom prst="rect">
+            <a:avLst/>
+          </a:prstGeom>
+        </p:spPr>
+        <p:txBody>
+          <a:bodyPr vert="horz" lIns="91440" tIns="45720" rIns="91440" bIns="45720" rtlCol="0">
+            <a:noAutofit/>
+          </a:bodyPr>
+          <a:lstStyle>
+            <a:lvl1pPr marL="342900" indent="-342900" algn="l" defTabSz="457200" rtl="0" eaLnBrk="1" latinLnBrk="0" hangingPunct="1">
+              <a:spcBef>
+                <a:spcPts val="1000"/>
+              </a:spcBef>
+              <a:spcAft>
+                <a:spcPts val="0"/>
+              </a:spcAft>
+              <a:buClr>
+                <a:schemeClr val="accent1"/>
+              </a:buClr>
+              <a:buSzPct val="80000"/>
+              <a:buFont typeface="Wingdings 3" charset="2"/>
+              <a:buChar char=""/>
+              <a:defRPr sz="2000" b="0" i="0" kern="1200">
+                <a:solidFill>
+                  <a:schemeClr val="tx1"/>
+                </a:solidFill>
+                <a:latin typeface="+mj-lt"/>
+                <a:ea typeface="+mj-ea"/>
+                <a:cs typeface="+mj-cs"/>
+              </a:defRPr>
+            </a:lvl1pPr>
+            <a:lvl2pPr marL="742950" indent="-285750" algn="l" defTabSz="457200" rtl="0" eaLnBrk="1" latinLnBrk="0" hangingPunct="1">
+              <a:spcBef>
+                <a:spcPts val="1000"/>
+              </a:spcBef>
+              <a:spcAft>
+                <a:spcPts val="0"/>
+              </a:spcAft>
+              <a:buClr>
+                <a:schemeClr val="accent1"/>
+              </a:buClr>
+              <a:buSzPct val="80000"/>
+              <a:buFont typeface="Wingdings 3" charset="2"/>
+              <a:buChar char=""/>
+              <a:defRPr sz="1800" b="0" i="0" kern="1200">
+                <a:solidFill>
+                  <a:schemeClr val="tx1"/>
+                </a:solidFill>
+                <a:latin typeface="+mj-lt"/>
+                <a:ea typeface="+mj-ea"/>
+                <a:cs typeface="+mj-cs"/>
+              </a:defRPr>
+            </a:lvl2pPr>
+            <a:lvl3pPr marL="1143000" indent="-228600" algn="l" defTabSz="457200" rtl="0" eaLnBrk="1" latinLnBrk="0" hangingPunct="1">
+              <a:spcBef>
+                <a:spcPts val="1000"/>
+              </a:spcBef>
+              <a:spcAft>
+                <a:spcPts val="0"/>
+              </a:spcAft>
+              <a:buClr>
+                <a:schemeClr val="accent1"/>
+              </a:buClr>
+              <a:buSzPct val="80000"/>
+              <a:buFont typeface="Wingdings 3" charset="2"/>
+              <a:buChar char=""/>
+              <a:defRPr sz="1600" b="0" i="0" kern="1200">
+                <a:solidFill>
+                  <a:schemeClr val="tx1"/>
+                </a:solidFill>
+                <a:latin typeface="+mj-lt"/>
+                <a:ea typeface="+mj-ea"/>
+                <a:cs typeface="+mj-cs"/>
+              </a:defRPr>
+            </a:lvl3pPr>
+            <a:lvl4pPr marL="1600200" indent="-228600" algn="l" defTabSz="457200" rtl="0" eaLnBrk="1" latinLnBrk="0" hangingPunct="1">
+              <a:spcBef>
+                <a:spcPts val="1000"/>
+              </a:spcBef>
+              <a:spcAft>
+                <a:spcPts val="0"/>
+              </a:spcAft>
+              <a:buClr>
+                <a:schemeClr val="accent1"/>
+              </a:buClr>
+              <a:buSzPct val="80000"/>
+              <a:buFont typeface="Wingdings 3" charset="2"/>
+              <a:buChar char=""/>
+              <a:defRPr sz="1400" b="0" i="0" kern="1200">
+                <a:solidFill>
+                  <a:schemeClr val="tx1"/>
+                </a:solidFill>
+                <a:latin typeface="+mj-lt"/>
+                <a:ea typeface="+mj-ea"/>
+                <a:cs typeface="+mj-cs"/>
+              </a:defRPr>
+            </a:lvl4pPr>
+            <a:lvl5pPr marL="2057400" indent="-228600" algn="l" defTabSz="457200" rtl="0" eaLnBrk="1" latinLnBrk="0" hangingPunct="1">
+              <a:spcBef>
+                <a:spcPts val="1000"/>
+              </a:spcBef>
+              <a:spcAft>
+                <a:spcPts val="0"/>
+              </a:spcAft>
+              <a:buClr>
+                <a:schemeClr val="accent1"/>
+              </a:buClr>
+              <a:buSzPct val="80000"/>
+              <a:buFont typeface="Wingdings 3" charset="2"/>
+              <a:buChar char=""/>
+              <a:defRPr sz="1400" b="0" i="0" kern="1200">
+                <a:solidFill>
+                  <a:schemeClr val="tx1"/>
+                </a:solidFill>
+                <a:latin typeface="+mj-lt"/>
+                <a:ea typeface="+mj-ea"/>
+                <a:cs typeface="+mj-cs"/>
+              </a:defRPr>
+            </a:lvl5pPr>
+            <a:lvl6pPr marL="2514600" indent="-228600" algn="l" defTabSz="457200" rtl="0" eaLnBrk="1" latinLnBrk="0" hangingPunct="1">
+              <a:spcBef>
+                <a:spcPts val="1000"/>
+              </a:spcBef>
+              <a:spcAft>
+                <a:spcPts val="0"/>
+              </a:spcAft>
+              <a:buClr>
+                <a:schemeClr val="accent1"/>
+              </a:buClr>
+              <a:buSzPct val="80000"/>
+              <a:buFont typeface="Wingdings 3" charset="2"/>
+              <a:buChar char=""/>
+              <a:defRPr sz="1400" b="0" i="0" kern="1200">
+                <a:solidFill>
+                  <a:schemeClr val="tx1"/>
+                </a:solidFill>
+                <a:latin typeface="+mj-lt"/>
+                <a:ea typeface="+mj-ea"/>
+                <a:cs typeface="+mj-cs"/>
+              </a:defRPr>
+            </a:lvl6pPr>
+            <a:lvl7pPr marL="2971800" indent="-228600" algn="l" defTabSz="457200" rtl="0" eaLnBrk="1" latinLnBrk="0" hangingPunct="1">
+              <a:spcBef>
+                <a:spcPts val="1000"/>
+              </a:spcBef>
+              <a:spcAft>
+                <a:spcPts val="0"/>
+              </a:spcAft>
+              <a:buClr>
+                <a:schemeClr val="accent1"/>
+              </a:buClr>
+              <a:buSzPct val="80000"/>
+              <a:buFont typeface="Wingdings 3" charset="2"/>
+              <a:buChar char=""/>
+              <a:defRPr sz="1400" b="0" i="0" kern="1200">
+                <a:solidFill>
+                  <a:schemeClr val="tx1"/>
+                </a:solidFill>
+                <a:latin typeface="+mj-lt"/>
+                <a:ea typeface="+mj-ea"/>
+                <a:cs typeface="+mj-cs"/>
+              </a:defRPr>
+            </a:lvl7pPr>
+            <a:lvl8pPr marL="3429000" indent="-228600" algn="l" defTabSz="457200" rtl="0" eaLnBrk="1" latinLnBrk="0" hangingPunct="1">
+              <a:spcBef>
+                <a:spcPts val="1000"/>
+              </a:spcBef>
+              <a:spcAft>
+                <a:spcPts val="0"/>
+              </a:spcAft>
+              <a:buClr>
+                <a:schemeClr val="accent1"/>
+              </a:buClr>
+              <a:buSzPct val="80000"/>
+              <a:buFont typeface="Wingdings 3" charset="2"/>
+              <a:buChar char=""/>
+              <a:defRPr sz="1400" b="0" i="0" kern="1200">
+                <a:solidFill>
+                  <a:schemeClr val="tx1"/>
+                </a:solidFill>
+                <a:latin typeface="+mj-lt"/>
+                <a:ea typeface="+mj-ea"/>
+                <a:cs typeface="+mj-cs"/>
+              </a:defRPr>
+            </a:lvl8pPr>
+            <a:lvl9pPr marL="3886200" indent="-228600" algn="l" defTabSz="457200" rtl="0" eaLnBrk="1" latinLnBrk="0" hangingPunct="1">
+              <a:spcBef>
+                <a:spcPts val="1000"/>
+              </a:spcBef>
+              <a:spcAft>
+                <a:spcPts val="0"/>
+              </a:spcAft>
+              <a:buClr>
+                <a:schemeClr val="accent1"/>
+              </a:buClr>
+              <a:buSzPct val="80000"/>
+              <a:buFont typeface="Wingdings 3" charset="2"/>
+              <a:buChar char=""/>
+              <a:defRPr sz="1400" b="0" i="0" kern="1200">
+                <a:solidFill>
+                  <a:schemeClr val="tx1"/>
+                </a:solidFill>
+                <a:latin typeface="+mj-lt"/>
+                <a:ea typeface="+mj-ea"/>
+                <a:cs typeface="+mj-cs"/>
+              </a:defRPr>
+            </a:lvl9pPr>
+          </a:lstStyle>
+          <a:p>
+            <a:r>
+              <a:rPr lang="en-US" sz="1600" b="1" dirty="0"/>
+              <a:t>KEY OBSERVATION: </a:t>
+            </a:r>
+            <a:r>
+              <a:rPr lang="en-US" sz="1600" dirty="0"/>
+              <a:t>5G performance differs both between operators and  across territories.  Download speed is used as the main KPI for the next steps (explanatory analysis.)</a:t>
+            </a:r>
+          </a:p>
+        </p:txBody>
+      </p:sp>
+    </p:spTree>
+    <p:extLst>
+      <p:ext uri="{BB962C8B-B14F-4D97-AF65-F5344CB8AC3E}">
+        <p14:creationId xmlns:p14="http://schemas.microsoft.com/office/powerpoint/2010/main" val="4264155239"/>
+      </p:ext>
+    </p:extLst>
+  </p:cSld>
+  <p:clrMapOvr>
+    <a:overrideClrMapping bg1="lt1" tx1="dk1" bg2="lt2" tx2="dk2" accent1="accent1" accent2="accent2" accent3="accent3" accent4="accent4" accent5="accent5" accent6="accent6" hlink="hlink" folHlink="folHlink"/>
+  </p:clrMapOvr>
+</p:sld>
+</file>
+
+<file path=ppt/slides/slide13.xml><?xml version="1.0" encoding="utf-8"?>
+<p:sld xmlns:a="http://schemas.openxmlformats.org/drawingml/2006/main" xmlns:r="http://schemas.openxmlformats.org/officeDocument/2006/relationships" xmlns:p="http://schemas.openxmlformats.org/presentationml/2006/main">
+  <p:cSld>
+    <p:bg>
+      <p:bgPr>
+        <a:solidFill>
+          <a:schemeClr val="bg1"/>
+        </a:solidFill>
+        <a:effectLst/>
+      </p:bgPr>
+    </p:bg>
+    <p:spTree>
+      <p:nvGrpSpPr>
+        <p:cNvPr id="1" name=""/>
+        <p:cNvGrpSpPr/>
+        <p:nvPr/>
+      </p:nvGrpSpPr>
+      <p:grpSpPr>
+        <a:xfrm>
+          <a:off x="0" y="0"/>
+          <a:ext cx="0" cy="0"/>
+          <a:chOff x="0" y="0"/>
+          <a:chExt cx="0" cy="0"/>
+        </a:xfrm>
+      </p:grpSpPr>
+      <p:sp>
+        <p:nvSpPr>
           <p:cNvPr id="8" name="Rectangle 7">
             <a:extLst>
               <a:ext uri="{FF2B5EF4-FFF2-40B4-BE49-F238E27FC236}">
@@ -9235,7 +10236,7 @@
                   <a:schemeClr val="bg1"/>
                 </a:solidFill>
               </a:rPr>
-              <a:t>9. What Could Explain the Differences?</a:t>
+              <a:t>10. What Could Explain the Differences?</a:t>
             </a:r>
           </a:p>
         </p:txBody>
@@ -9292,7 +10293,7 @@
 </p:sld>
 </file>
 
-<file path=ppt/slides/slide13.xml><?xml version="1.0" encoding="utf-8"?>
+<file path=ppt/slides/slide14.xml><?xml version="1.0" encoding="utf-8"?>
 <p:sld xmlns:a="http://schemas.openxmlformats.org/drawingml/2006/main" xmlns:r="http://schemas.openxmlformats.org/officeDocument/2006/relationships" xmlns:p="http://schemas.openxmlformats.org/presentationml/2006/main">
   <p:cSld>
     <p:spTree>
@@ -9341,7 +10342,7 @@
                   <a:schemeClr val="tx1"/>
                 </a:solidFill>
               </a:rPr>
-              <a:t>9.1. </a:t>
+              <a:t>10.1. </a:t>
             </a:r>
             <a:r>
               <a:rPr lang="fr-FR" sz="4400" b="1" dirty="0" err="1">
@@ -9732,206 +10733,6 @@
 </p:sld>
 </file>
 
-<file path=ppt/slides/slide14.xml><?xml version="1.0" encoding="utf-8"?>
-<p:sld xmlns:a="http://schemas.openxmlformats.org/drawingml/2006/main" xmlns:r="http://schemas.openxmlformats.org/officeDocument/2006/relationships" xmlns:p="http://schemas.openxmlformats.org/presentationml/2006/main">
-  <p:cSld>
-    <p:spTree>
-      <p:nvGrpSpPr>
-        <p:cNvPr id="1" name=""/>
-        <p:cNvGrpSpPr/>
-        <p:nvPr/>
-      </p:nvGrpSpPr>
-      <p:grpSpPr>
-        <a:xfrm>
-          <a:off x="0" y="0"/>
-          <a:ext cx="0" cy="0"/>
-          <a:chOff x="0" y="0"/>
-          <a:chExt cx="0" cy="0"/>
-        </a:xfrm>
-      </p:grpSpPr>
-      <p:sp>
-        <p:nvSpPr>
-          <p:cNvPr id="2" name="Title 1">
-            <a:extLst>
-              <a:ext uri="{FF2B5EF4-FFF2-40B4-BE49-F238E27FC236}">
-                <a16:creationId xmlns:a16="http://schemas.microsoft.com/office/drawing/2014/main" id="{CE85BF32-8755-BFC4-3ADA-8D23EA47A303}"/>
-              </a:ext>
-            </a:extLst>
-          </p:cNvPr>
-          <p:cNvSpPr>
-            <a:spLocks noGrp="1"/>
-          </p:cNvSpPr>
-          <p:nvPr>
-            <p:ph type="title"/>
-          </p:nvPr>
-        </p:nvSpPr>
-        <p:spPr/>
-        <p:txBody>
-          <a:bodyPr/>
-          <a:lstStyle/>
-          <a:p>
-            <a:r>
-              <a:rPr lang="en-US" b="1" dirty="0"/>
-              <a:t>10. Final Conclusion</a:t>
-            </a:r>
-          </a:p>
-        </p:txBody>
-      </p:sp>
-      <p:sp>
-        <p:nvSpPr>
-          <p:cNvPr id="3" name="Content Placeholder 2">
-            <a:extLst>
-              <a:ext uri="{FF2B5EF4-FFF2-40B4-BE49-F238E27FC236}">
-                <a16:creationId xmlns:a16="http://schemas.microsoft.com/office/drawing/2014/main" id="{404096C3-D57F-086A-01E3-2C33A474837E}"/>
-              </a:ext>
-            </a:extLst>
-          </p:cNvPr>
-          <p:cNvSpPr>
-            <a:spLocks noGrp="1"/>
-          </p:cNvSpPr>
-          <p:nvPr>
-            <p:ph idx="1"/>
-          </p:nvPr>
-        </p:nvSpPr>
-        <p:spPr>
-          <a:xfrm>
-            <a:off x="1104293" y="1772364"/>
-            <a:ext cx="8946541" cy="4195481"/>
-          </a:xfrm>
-        </p:spPr>
-        <p:txBody>
-          <a:bodyPr>
-            <a:normAutofit fontScale="92500" lnSpcReduction="10000"/>
-          </a:bodyPr>
-          <a:lstStyle/>
-          <a:p>
-            <a:pPr marL="0" indent="0">
-              <a:buNone/>
-            </a:pPr>
-            <a:r>
-              <a:rPr lang="en-US" b="1" dirty="0"/>
-              <a:t>What did we learn?</a:t>
-            </a:r>
-          </a:p>
-          <a:p>
-            <a:r>
-              <a:rPr lang="en-US" b="1" dirty="0"/>
-              <a:t>1. Performance disparities exist: </a:t>
-            </a:r>
-            <a:endParaRPr lang="en-US" dirty="0"/>
-          </a:p>
-          <a:p>
-            <a:pPr lvl="1">
-              <a:buFont typeface="Wingdings" panose="05000000000000000000" pitchFamily="2" charset="2"/>
-              <a:buChar char="v"/>
-            </a:pPr>
-            <a:r>
-              <a:rPr lang="en-US" dirty="0"/>
-              <a:t>5G download performance differs significantly across operators and territories.</a:t>
-            </a:r>
-          </a:p>
-          <a:p>
-            <a:r>
-              <a:rPr lang="en-US" b="1" dirty="0"/>
-              <a:t>2. Several factors are associated with performance</a:t>
-            </a:r>
-            <a:endParaRPr lang="en-US" dirty="0"/>
-          </a:p>
-          <a:p>
-            <a:pPr lvl="1">
-              <a:buFont typeface="Wingdings" panose="05000000000000000000" pitchFamily="2" charset="2"/>
-              <a:buChar char="v"/>
-            </a:pPr>
-            <a:r>
-              <a:rPr lang="en-US" b="1" dirty="0"/>
-              <a:t>Territorial context:</a:t>
-            </a:r>
-            <a:r>
-              <a:rPr lang="en-US" dirty="0"/>
-              <a:t> population</a:t>
-            </a:r>
-          </a:p>
-          <a:p>
-            <a:pPr lvl="1">
-              <a:buFont typeface="Wingdings" panose="05000000000000000000" pitchFamily="2" charset="2"/>
-              <a:buChar char="v"/>
-            </a:pPr>
-            <a:r>
-              <a:rPr lang="en-US" b="1" dirty="0"/>
-              <a:t>Network infrastructure:</a:t>
-            </a:r>
-            <a:r>
-              <a:rPr lang="en-US" dirty="0"/>
-              <a:t> pure 5G deployment</a:t>
-            </a:r>
-          </a:p>
-          <a:p>
-            <a:pPr lvl="1">
-              <a:buFont typeface="Wingdings" panose="05000000000000000000" pitchFamily="2" charset="2"/>
-              <a:buChar char="v"/>
-            </a:pPr>
-            <a:r>
-              <a:rPr lang="en-US" b="1" dirty="0"/>
-              <a:t>Radio environment:</a:t>
-            </a:r>
-            <a:r>
-              <a:rPr lang="en-US" dirty="0"/>
-              <a:t> RSRP</a:t>
-            </a:r>
-          </a:p>
-          <a:p>
-            <a:r>
-              <a:rPr lang="en-US" b="1" dirty="0"/>
-              <a:t>3. These factors do not tell the whole story</a:t>
-            </a:r>
-            <a:endParaRPr lang="en-US" dirty="0"/>
-          </a:p>
-          <a:p>
-            <a:pPr lvl="1">
-              <a:buFont typeface="Wingdings" panose="05000000000000000000" pitchFamily="2" charset="2"/>
-              <a:buChar char="v"/>
-            </a:pPr>
-            <a:r>
-              <a:rPr lang="en-US" dirty="0"/>
-              <a:t>Significant differences remain between operators under similar territorial or infrastructure conditions.</a:t>
-            </a:r>
-          </a:p>
-          <a:p>
-            <a:pPr lvl="1">
-              <a:buFont typeface="Wingdings" panose="05000000000000000000" pitchFamily="2" charset="2"/>
-              <a:buChar char="v"/>
-            </a:pPr>
-            <a:r>
-              <a:rPr lang="en-US" dirty="0"/>
-              <a:t>This points to an important </a:t>
-            </a:r>
-            <a:r>
-              <a:rPr lang="en-US" b="1" dirty="0"/>
-              <a:t>operator-specific component</a:t>
-            </a:r>
-            <a:r>
-              <a:rPr lang="en-US" dirty="0"/>
-              <a:t>.</a:t>
-            </a:r>
-          </a:p>
-          <a:p>
-            <a:endParaRPr lang="en-US" dirty="0"/>
-          </a:p>
-        </p:txBody>
-      </p:sp>
-    </p:spTree>
-    <p:extLst>
-      <p:ext uri="{BB962C8B-B14F-4D97-AF65-F5344CB8AC3E}">
-        <p14:creationId xmlns:p14="http://schemas.microsoft.com/office/powerpoint/2010/main" val="1438097033"/>
-      </p:ext>
-    </p:extLst>
-  </p:cSld>
-  <p:clrMapOvr>
-    <a:masterClrMapping/>
-  </p:clrMapOvr>
-</p:sld>
-</file>
-
 <file path=ppt/slides/slide15.xml><?xml version="1.0" encoding="utf-8"?>
 <p:sld xmlns:a="http://schemas.openxmlformats.org/drawingml/2006/main" xmlns:r="http://schemas.openxmlformats.org/officeDocument/2006/relationships" xmlns:p="http://schemas.openxmlformats.org/presentationml/2006/main">
   <p:cSld>
@@ -9954,6 +10755,206 @@
           <p:cNvPr id="2" name="Title 1">
             <a:extLst>
               <a:ext uri="{FF2B5EF4-FFF2-40B4-BE49-F238E27FC236}">
+                <a16:creationId xmlns:a16="http://schemas.microsoft.com/office/drawing/2014/main" id="{CE85BF32-8755-BFC4-3ADA-8D23EA47A303}"/>
+              </a:ext>
+            </a:extLst>
+          </p:cNvPr>
+          <p:cNvSpPr>
+            <a:spLocks noGrp="1"/>
+          </p:cNvSpPr>
+          <p:nvPr>
+            <p:ph type="title"/>
+          </p:nvPr>
+        </p:nvSpPr>
+        <p:spPr/>
+        <p:txBody>
+          <a:bodyPr/>
+          <a:lstStyle/>
+          <a:p>
+            <a:r>
+              <a:rPr lang="en-US" b="1" dirty="0"/>
+              <a:t>11. Final Conclusion</a:t>
+            </a:r>
+          </a:p>
+        </p:txBody>
+      </p:sp>
+      <p:sp>
+        <p:nvSpPr>
+          <p:cNvPr id="3" name="Content Placeholder 2">
+            <a:extLst>
+              <a:ext uri="{FF2B5EF4-FFF2-40B4-BE49-F238E27FC236}">
+                <a16:creationId xmlns:a16="http://schemas.microsoft.com/office/drawing/2014/main" id="{404096C3-D57F-086A-01E3-2C33A474837E}"/>
+              </a:ext>
+            </a:extLst>
+          </p:cNvPr>
+          <p:cNvSpPr>
+            <a:spLocks noGrp="1"/>
+          </p:cNvSpPr>
+          <p:nvPr>
+            <p:ph idx="1"/>
+          </p:nvPr>
+        </p:nvSpPr>
+        <p:spPr>
+          <a:xfrm>
+            <a:off x="1104293" y="1772364"/>
+            <a:ext cx="8946541" cy="4195481"/>
+          </a:xfrm>
+        </p:spPr>
+        <p:txBody>
+          <a:bodyPr>
+            <a:normAutofit fontScale="92500" lnSpcReduction="10000"/>
+          </a:bodyPr>
+          <a:lstStyle/>
+          <a:p>
+            <a:pPr marL="0" indent="0">
+              <a:buNone/>
+            </a:pPr>
+            <a:r>
+              <a:rPr lang="en-US" b="1" dirty="0"/>
+              <a:t>What did we learn?</a:t>
+            </a:r>
+          </a:p>
+          <a:p>
+            <a:r>
+              <a:rPr lang="en-US" b="1" dirty="0"/>
+              <a:t>1. Performance disparities exist: </a:t>
+            </a:r>
+            <a:endParaRPr lang="en-US" dirty="0"/>
+          </a:p>
+          <a:p>
+            <a:pPr lvl="1">
+              <a:buFont typeface="Wingdings" panose="05000000000000000000" pitchFamily="2" charset="2"/>
+              <a:buChar char="v"/>
+            </a:pPr>
+            <a:r>
+              <a:rPr lang="en-US" dirty="0"/>
+              <a:t>5G download performance differs significantly across operators and territories.</a:t>
+            </a:r>
+          </a:p>
+          <a:p>
+            <a:r>
+              <a:rPr lang="en-US" b="1" dirty="0"/>
+              <a:t>2. Several factors are associated with performance</a:t>
+            </a:r>
+            <a:endParaRPr lang="en-US" dirty="0"/>
+          </a:p>
+          <a:p>
+            <a:pPr lvl="1">
+              <a:buFont typeface="Wingdings" panose="05000000000000000000" pitchFamily="2" charset="2"/>
+              <a:buChar char="v"/>
+            </a:pPr>
+            <a:r>
+              <a:rPr lang="en-US" b="1" dirty="0"/>
+              <a:t>Territorial context:</a:t>
+            </a:r>
+            <a:r>
+              <a:rPr lang="en-US" dirty="0"/>
+              <a:t> population</a:t>
+            </a:r>
+          </a:p>
+          <a:p>
+            <a:pPr lvl="1">
+              <a:buFont typeface="Wingdings" panose="05000000000000000000" pitchFamily="2" charset="2"/>
+              <a:buChar char="v"/>
+            </a:pPr>
+            <a:r>
+              <a:rPr lang="en-US" b="1" dirty="0"/>
+              <a:t>Network infrastructure:</a:t>
+            </a:r>
+            <a:r>
+              <a:rPr lang="en-US" dirty="0"/>
+              <a:t> pure 5G deployment</a:t>
+            </a:r>
+          </a:p>
+          <a:p>
+            <a:pPr lvl="1">
+              <a:buFont typeface="Wingdings" panose="05000000000000000000" pitchFamily="2" charset="2"/>
+              <a:buChar char="v"/>
+            </a:pPr>
+            <a:r>
+              <a:rPr lang="en-US" b="1" dirty="0"/>
+              <a:t>Radio environment:</a:t>
+            </a:r>
+            <a:r>
+              <a:rPr lang="en-US" dirty="0"/>
+              <a:t> RSRP</a:t>
+            </a:r>
+          </a:p>
+          <a:p>
+            <a:r>
+              <a:rPr lang="en-US" b="1" dirty="0"/>
+              <a:t>3. These factors do not tell the whole story</a:t>
+            </a:r>
+            <a:endParaRPr lang="en-US" dirty="0"/>
+          </a:p>
+          <a:p>
+            <a:pPr lvl="1">
+              <a:buFont typeface="Wingdings" panose="05000000000000000000" pitchFamily="2" charset="2"/>
+              <a:buChar char="v"/>
+            </a:pPr>
+            <a:r>
+              <a:rPr lang="en-US" dirty="0"/>
+              <a:t>Significant differences remain between operators under similar territorial or infrastructure conditions.</a:t>
+            </a:r>
+          </a:p>
+          <a:p>
+            <a:pPr lvl="1">
+              <a:buFont typeface="Wingdings" panose="05000000000000000000" pitchFamily="2" charset="2"/>
+              <a:buChar char="v"/>
+            </a:pPr>
+            <a:r>
+              <a:rPr lang="en-US" dirty="0"/>
+              <a:t>This points to an important </a:t>
+            </a:r>
+            <a:r>
+              <a:rPr lang="en-US" b="1" dirty="0"/>
+              <a:t>operator-specific component</a:t>
+            </a:r>
+            <a:r>
+              <a:rPr lang="en-US" dirty="0"/>
+              <a:t>.</a:t>
+            </a:r>
+          </a:p>
+          <a:p>
+            <a:endParaRPr lang="en-US" dirty="0"/>
+          </a:p>
+        </p:txBody>
+      </p:sp>
+    </p:spTree>
+    <p:extLst>
+      <p:ext uri="{BB962C8B-B14F-4D97-AF65-F5344CB8AC3E}">
+        <p14:creationId xmlns:p14="http://schemas.microsoft.com/office/powerpoint/2010/main" val="1438097033"/>
+      </p:ext>
+    </p:extLst>
+  </p:cSld>
+  <p:clrMapOvr>
+    <a:masterClrMapping/>
+  </p:clrMapOvr>
+</p:sld>
+</file>
+
+<file path=ppt/slides/slide16.xml><?xml version="1.0" encoding="utf-8"?>
+<p:sld xmlns:a="http://schemas.openxmlformats.org/drawingml/2006/main" xmlns:r="http://schemas.openxmlformats.org/officeDocument/2006/relationships" xmlns:p="http://schemas.openxmlformats.org/presentationml/2006/main">
+  <p:cSld>
+    <p:spTree>
+      <p:nvGrpSpPr>
+        <p:cNvPr id="1" name=""/>
+        <p:cNvGrpSpPr/>
+        <p:nvPr/>
+      </p:nvGrpSpPr>
+      <p:grpSpPr>
+        <a:xfrm>
+          <a:off x="0" y="0"/>
+          <a:ext cx="0" cy="0"/>
+          <a:chOff x="0" y="0"/>
+          <a:chExt cx="0" cy="0"/>
+        </a:xfrm>
+      </p:grpSpPr>
+      <p:sp>
+        <p:nvSpPr>
+          <p:cNvPr id="2" name="Title 1">
+            <a:extLst>
+              <a:ext uri="{FF2B5EF4-FFF2-40B4-BE49-F238E27FC236}">
                 <a16:creationId xmlns:a16="http://schemas.microsoft.com/office/drawing/2014/main" id="{07EAF479-7C39-5A7C-39C2-5C495725A959}"/>
               </a:ext>
             </a:extLst>
@@ -10091,7 +11092,7 @@
 </p:sld>
 </file>
 
-<file path=ppt/slides/slide16.xml><?xml version="1.0" encoding="utf-8"?>
+<file path=ppt/slides/slide17.xml><?xml version="1.0" encoding="utf-8"?>
 <p:sld xmlns:a="http://schemas.openxmlformats.org/drawingml/2006/main" xmlns:r="http://schemas.openxmlformats.org/officeDocument/2006/relationships" xmlns:p="http://schemas.openxmlformats.org/presentationml/2006/main">
   <p:cSld>
     <p:bg>
@@ -11173,7 +12174,7 @@
 </p:sld>
 </file>
 
-<file path=ppt/slides/slide17.xml><?xml version="1.0" encoding="utf-8"?>
+<file path=ppt/slides/slide18.xml><?xml version="1.0" encoding="utf-8"?>
 <p:sld xmlns:a="http://schemas.openxmlformats.org/drawingml/2006/main" xmlns:r="http://schemas.openxmlformats.org/officeDocument/2006/relationships" xmlns:p="http://schemas.openxmlformats.org/presentationml/2006/main">
   <p:cSld>
     <p:bg>

</xml_diff>